<commit_message>
Add English demo narration and update author identity
</commit_message>
<xml_diff>
--- a/submission/AlphaVault-Presentation.pptx
+++ b/submission/AlphaVault-Presentation.pptx
@@ -2,22 +2,22 @@
 <file path=ppt/presentation.xml><?xml version="1.0" encoding="utf-8"?>
 <p:presentation xmlns:p="http://schemas.openxmlformats.org/presentationml/2006/main">
   <p:sldMasterIdLst>
-    <p:sldMasterId xmlns:r="http://schemas.openxmlformats.org/officeDocument/2006/relationships" id="2147483648" r:id="R8eb5638866e24786"/>
+    <p:sldMasterId xmlns:r="http://schemas.openxmlformats.org/officeDocument/2006/relationships" id="2147483648" r:id="R44bc541ab706427c"/>
   </p:sldMasterIdLst>
   <p:notesMasterIdLst>
-    <p:notesMasterId xmlns:r="http://schemas.openxmlformats.org/officeDocument/2006/relationships" r:id="R56f5f33280a34888"/>
+    <p:notesMasterId xmlns:r="http://schemas.openxmlformats.org/officeDocument/2006/relationships" r:id="Ra16646cc356d4b5a"/>
   </p:notesMasterIdLst>
   <p:sldIdLst>
-    <p:sldId xmlns:r="http://schemas.openxmlformats.org/officeDocument/2006/relationships" id="256" r:id="Red0f8b035d024776"/>
-    <p:sldId xmlns:r="http://schemas.openxmlformats.org/officeDocument/2006/relationships" id="257" r:id="Ra66f2590a4344789"/>
-    <p:sldId xmlns:r="http://schemas.openxmlformats.org/officeDocument/2006/relationships" id="258" r:id="Rcb5ecc6a3b4e49ac"/>
-    <p:sldId xmlns:r="http://schemas.openxmlformats.org/officeDocument/2006/relationships" id="259" r:id="R582967f64ad44652"/>
-    <p:sldId xmlns:r="http://schemas.openxmlformats.org/officeDocument/2006/relationships" id="260" r:id="R50355b4d119d4468"/>
-    <p:sldId xmlns:r="http://schemas.openxmlformats.org/officeDocument/2006/relationships" id="261" r:id="Rad3ef3f3c20144c7"/>
-    <p:sldId xmlns:r="http://schemas.openxmlformats.org/officeDocument/2006/relationships" id="262" r:id="R4cb63c38f75e4201"/>
-    <p:sldId xmlns:r="http://schemas.openxmlformats.org/officeDocument/2006/relationships" id="263" r:id="R6e243aba10b546d9"/>
-    <p:sldId xmlns:r="http://schemas.openxmlformats.org/officeDocument/2006/relationships" id="264" r:id="R26d782b84aa14154"/>
-    <p:sldId xmlns:r="http://schemas.openxmlformats.org/officeDocument/2006/relationships" id="265" r:id="R27f0299a562b4444"/>
+    <p:sldId xmlns:r="http://schemas.openxmlformats.org/officeDocument/2006/relationships" id="256" r:id="R4be15f1744694366"/>
+    <p:sldId xmlns:r="http://schemas.openxmlformats.org/officeDocument/2006/relationships" id="257" r:id="Rc40f81d3bb654201"/>
+    <p:sldId xmlns:r="http://schemas.openxmlformats.org/officeDocument/2006/relationships" id="258" r:id="Rbdfa5ff04bfc48f4"/>
+    <p:sldId xmlns:r="http://schemas.openxmlformats.org/officeDocument/2006/relationships" id="259" r:id="R583697f2ecde4347"/>
+    <p:sldId xmlns:r="http://schemas.openxmlformats.org/officeDocument/2006/relationships" id="260" r:id="R74aa7a3eaa084bf0"/>
+    <p:sldId xmlns:r="http://schemas.openxmlformats.org/officeDocument/2006/relationships" id="261" r:id="R3b4cb079103d4f5f"/>
+    <p:sldId xmlns:r="http://schemas.openxmlformats.org/officeDocument/2006/relationships" id="262" r:id="Rc3db6be84fd14189"/>
+    <p:sldId xmlns:r="http://schemas.openxmlformats.org/officeDocument/2006/relationships" id="263" r:id="R57c7f4ab30ff4677"/>
+    <p:sldId xmlns:r="http://schemas.openxmlformats.org/officeDocument/2006/relationships" id="264" r:id="Re206162601fd4d28"/>
+    <p:sldId xmlns:r="http://schemas.openxmlformats.org/officeDocument/2006/relationships" id="265" r:id="R8cec3040682547dc"/>
   </p:sldIdLst>
   <p:sldSz cx="12192000" cy="6858000"/>
   <p:notesSz cx="6858000" cy="9144000"/>
@@ -521,7 +521,7 @@
           <a:lstStyle xmlns:a="http://schemas.openxmlformats.org/drawingml/2006/main"/>
           <a:p xmlns:a="http://schemas.openxmlformats.org/drawingml/2006/main">
             <a:r>
-              <a:t>20 seconds. Explain the next engineering steps without claiming they already exist. Replace trusted mock reports and exchange with suitable production integrations, test actual market data and net trading, then strengthen governance and audit. Before course submission fill identity, align rubric, check repo access and verify source if required. Sources: report sections on limitations and docs/REQUIREMENTS.md.</a:t>
+              <a:t>20 seconds. Explain the next engineering steps without claiming they already exist. Replace trusted mock reports and exchange with suitable production integrations, test actual market data and net trading, then strengthen governance and audit. Before course submission align rubric, check repo access and verify source if required. Sources: report sections on limitations and docs/REQUIREMENTS.md.</a:t>
             </a:r>
           </a:p>
         </p:txBody>
@@ -1128,7 +1128,7 @@
           <p:cNvPr id="3" name="Title">
             <a:extLst xmlns:a="http://schemas.openxmlformats.org/drawingml/2006/main">
               <a:ext uri="{FF2B5EF4-FFF2-40B4-BE49-F238E27FC236}">
-                <a16:creationId xmlns:a16="http://schemas.microsoft.com/office/drawing/2014/main" id="{B804704F-E7BC-402A-A8E0-84464B7135B1}"/>
+                <a16:creationId xmlns:a16="http://schemas.microsoft.com/office/drawing/2014/main" id="{48477FF1-05AA-45C7-A991-BD8EA206B196}"/>
               </a:ext>
             </a:extLst>
           </p:cNvPr>
@@ -1285,7 +1285,7 @@
           <p:cNvPr id="2" name="Subtitle">
             <a:extLst xmlns:a="http://schemas.openxmlformats.org/drawingml/2006/main">
               <a:ext uri="{FF2B5EF4-FFF2-40B4-BE49-F238E27FC236}">
-                <a16:creationId xmlns:a16="http://schemas.microsoft.com/office/drawing/2014/main" id="{B958EDE5-E90F-4B35-A872-B0DFC4DAB00A}"/>
+                <a16:creationId xmlns:a16="http://schemas.microsoft.com/office/drawing/2014/main" id="{954A50AE-7FAD-479C-8B1B-0249D4A1F7A3}"/>
               </a:ext>
             </a:extLst>
           </p:cNvPr>
@@ -1459,7 +1459,7 @@
           <p:cNvPr id="2" name="Section title">
             <a:extLst xmlns:a="http://schemas.openxmlformats.org/drawingml/2006/main">
               <a:ext uri="{FF2B5EF4-FFF2-40B4-BE49-F238E27FC236}">
-                <a16:creationId xmlns:a16="http://schemas.microsoft.com/office/drawing/2014/main" id="{ACFADCE0-8FEE-4D68-915D-DBEAB9D1E35C}"/>
+                <a16:creationId xmlns:a16="http://schemas.microsoft.com/office/drawing/2014/main" id="{CAE2664A-B8C2-4190-A773-E916B1250301}"/>
               </a:ext>
             </a:extLst>
           </p:cNvPr>
@@ -1633,7 +1633,7 @@
           <p:cNvPr id="3" name="Title">
             <a:extLst xmlns:a="http://schemas.openxmlformats.org/drawingml/2006/main">
               <a:ext uri="{FF2B5EF4-FFF2-40B4-BE49-F238E27FC236}">
-                <a16:creationId xmlns:a16="http://schemas.microsoft.com/office/drawing/2014/main" id="{B026ED8B-2B59-4E05-BEC1-80751E1B2E59}"/>
+                <a16:creationId xmlns:a16="http://schemas.microsoft.com/office/drawing/2014/main" id="{C58D7F92-AFB0-4727-A815-950AA6C2D810}"/>
               </a:ext>
             </a:extLst>
           </p:cNvPr>
@@ -1790,7 +1790,7 @@
           <p:cNvPr id="2" name="Body">
             <a:extLst xmlns:a="http://schemas.openxmlformats.org/drawingml/2006/main">
               <a:ext uri="{FF2B5EF4-FFF2-40B4-BE49-F238E27FC236}">
-                <a16:creationId xmlns:a16="http://schemas.microsoft.com/office/drawing/2014/main" id="{31B38317-BE7B-4A03-8602-87AF6F231F6A}"/>
+                <a16:creationId xmlns:a16="http://schemas.microsoft.com/office/drawing/2014/main" id="{4E795905-07FA-4177-9173-07E97326E7E2}"/>
               </a:ext>
             </a:extLst>
           </p:cNvPr>
@@ -1964,7 +1964,7 @@
           <p:cNvPr id="4" name="Title">
             <a:extLst xmlns:a="http://schemas.openxmlformats.org/drawingml/2006/main">
               <a:ext uri="{FF2B5EF4-FFF2-40B4-BE49-F238E27FC236}">
-                <a16:creationId xmlns:a16="http://schemas.microsoft.com/office/drawing/2014/main" id="{917541F9-3696-4F84-A135-6FE4A7AB1337}"/>
+                <a16:creationId xmlns:a16="http://schemas.microsoft.com/office/drawing/2014/main" id="{BB1286D1-5E1F-46A6-A2EE-6BB34DBD0B07}"/>
               </a:ext>
             </a:extLst>
           </p:cNvPr>
@@ -2121,7 +2121,7 @@
           <p:cNvPr id="2" name="Left column">
             <a:extLst xmlns:a="http://schemas.openxmlformats.org/drawingml/2006/main">
               <a:ext uri="{FF2B5EF4-FFF2-40B4-BE49-F238E27FC236}">
-                <a16:creationId xmlns:a16="http://schemas.microsoft.com/office/drawing/2014/main" id="{3E63A75A-3B85-4FE3-A3CB-3E4FDA84FD10}"/>
+                <a16:creationId xmlns:a16="http://schemas.microsoft.com/office/drawing/2014/main" id="{30B44328-EF64-4538-9AD9-743C0F70E61A}"/>
               </a:ext>
             </a:extLst>
           </p:cNvPr>
@@ -2278,7 +2278,7 @@
           <p:cNvPr id="3" name="Right column">
             <a:extLst xmlns:a="http://schemas.openxmlformats.org/drawingml/2006/main">
               <a:ext uri="{FF2B5EF4-FFF2-40B4-BE49-F238E27FC236}">
-                <a16:creationId xmlns:a16="http://schemas.microsoft.com/office/drawing/2014/main" id="{6B1B7646-CFCE-4AC3-90B8-48CFE682A13A}"/>
+                <a16:creationId xmlns:a16="http://schemas.microsoft.com/office/drawing/2014/main" id="{4BC9F280-4574-43D8-8211-E748C5858E04}"/>
               </a:ext>
             </a:extLst>
           </p:cNvPr>
@@ -2452,7 +2452,7 @@
           <p:cNvPr id="3" name="Title">
             <a:extLst xmlns:a="http://schemas.openxmlformats.org/drawingml/2006/main">
               <a:ext uri="{FF2B5EF4-FFF2-40B4-BE49-F238E27FC236}">
-                <a16:creationId xmlns:a16="http://schemas.microsoft.com/office/drawing/2014/main" id="{10EFCD41-057D-46F2-B6D1-156EC9C3593C}"/>
+                <a16:creationId xmlns:a16="http://schemas.microsoft.com/office/drawing/2014/main" id="{4A5BDBAB-E4CC-4EE2-AC6D-33B2E2ECC8C8}"/>
               </a:ext>
             </a:extLst>
           </p:cNvPr>
@@ -2609,7 +2609,7 @@
           <p:cNvPr id="2" name="Left column">
             <a:extLst xmlns:a="http://schemas.openxmlformats.org/drawingml/2006/main">
               <a:ext uri="{FF2B5EF4-FFF2-40B4-BE49-F238E27FC236}">
-                <a16:creationId xmlns:a16="http://schemas.microsoft.com/office/drawing/2014/main" id="{0316189B-35A2-4E15-87D6-4F7210319F3B}"/>
+                <a16:creationId xmlns:a16="http://schemas.microsoft.com/office/drawing/2014/main" id="{A6F1EF0F-A4DF-469F-9583-D75C89C026D0}"/>
               </a:ext>
             </a:extLst>
           </p:cNvPr>
@@ -2804,12 +2804,12 @@
   </p:cSld>
   <p:clrMap bg1="lt1" tx1="dk1" bg2="lt2" tx2="dk2" accent1="accent1" accent2="accent2" accent3="accent3" accent4="accent4" accent5="accent5" accent6="accent6" hlink="hlink" folHlink="folHlink"/>
   <p:sldLayoutIdLst>
-    <p:sldLayoutId xmlns:r="http://schemas.openxmlformats.org/officeDocument/2006/relationships" id="2147483649" r:id="Rf8fac33c0b9f4be4"/>
-    <p:sldLayoutId xmlns:r="http://schemas.openxmlformats.org/officeDocument/2006/relationships" id="2147483650" r:id="Re386bbc85a924689"/>
-    <p:sldLayoutId xmlns:r="http://schemas.openxmlformats.org/officeDocument/2006/relationships" id="2147483651" r:id="Rd93d4881e0e44728"/>
-    <p:sldLayoutId xmlns:r="http://schemas.openxmlformats.org/officeDocument/2006/relationships" id="2147483652" r:id="Rf1a25639a5524a06"/>
-    <p:sldLayoutId xmlns:r="http://schemas.openxmlformats.org/officeDocument/2006/relationships" id="2147483653" r:id="R260bf855c81e4ef1"/>
-    <p:sldLayoutId xmlns:r="http://schemas.openxmlformats.org/officeDocument/2006/relationships" id="2147483654" r:id="Rf3d585f723a24281"/>
+    <p:sldLayoutId xmlns:r="http://schemas.openxmlformats.org/officeDocument/2006/relationships" id="2147483649" r:id="R2e67f5c80a524b0e"/>
+    <p:sldLayoutId xmlns:r="http://schemas.openxmlformats.org/officeDocument/2006/relationships" id="2147483650" r:id="R6d8b84ed907c440d"/>
+    <p:sldLayoutId xmlns:r="http://schemas.openxmlformats.org/officeDocument/2006/relationships" id="2147483651" r:id="R8d6d0e43a5cc4ed4"/>
+    <p:sldLayoutId xmlns:r="http://schemas.openxmlformats.org/officeDocument/2006/relationships" id="2147483652" r:id="R4bb68f3197994181"/>
+    <p:sldLayoutId xmlns:r="http://schemas.openxmlformats.org/officeDocument/2006/relationships" id="2147483653" r:id="R557d1233b1ba4d86"/>
+    <p:sldLayoutId xmlns:r="http://schemas.openxmlformats.org/officeDocument/2006/relationships" id="2147483654" r:id="R5ec288db0c8b487c"/>
   </p:sldLayoutIdLst>
   <p:txStyles>
     <p:titleStyle>
@@ -6570,7 +6570,7 @@
           <p:cNvPr id="5" name="">
             <a:extLst xmlns:a="http://schemas.openxmlformats.org/drawingml/2006/main">
               <a:ext uri="{FF2B5EF4-FFF2-40B4-BE49-F238E27FC236}">
-                <a16:creationId xmlns:a16="http://schemas.microsoft.com/office/drawing/2014/main" id="{F3639FFC-CB6B-4473-A54C-BC39E65828D3}"/>
+                <a16:creationId xmlns:a16="http://schemas.microsoft.com/office/drawing/2014/main" id="{48E330AF-BEE5-43A0-A4A8-162E73A9DF3A}"/>
               </a:ext>
             </a:extLst>
           </p:cNvPr>
@@ -6636,7 +6636,7 @@
           <p:cNvPr id="2" name="">
             <a:extLst xmlns:a="http://schemas.openxmlformats.org/drawingml/2006/main">
               <a:ext uri="{FF2B5EF4-FFF2-40B4-BE49-F238E27FC236}">
-                <a16:creationId xmlns:a16="http://schemas.microsoft.com/office/drawing/2014/main" id="{F80462B5-8E0A-49BD-BCF1-07E5A8CF6CA3}"/>
+                <a16:creationId xmlns:a16="http://schemas.microsoft.com/office/drawing/2014/main" id="{6EE2B03A-976C-43F7-B403-F36690A6C63B}"/>
               </a:ext>
             </a:extLst>
           </p:cNvPr>
@@ -6725,7 +6725,7 @@
           <p:cNvPr id="3" name="">
             <a:extLst xmlns:a="http://schemas.openxmlformats.org/drawingml/2006/main">
               <a:ext uri="{FF2B5EF4-FFF2-40B4-BE49-F238E27FC236}">
-                <a16:creationId xmlns:a16="http://schemas.microsoft.com/office/drawing/2014/main" id="{B0DF2F29-4B41-48C9-B4F3-8632D10DF0CB}"/>
+                <a16:creationId xmlns:a16="http://schemas.microsoft.com/office/drawing/2014/main" id="{7CEC4142-11DC-4B02-9EE3-9367F5C98E20}"/>
               </a:ext>
             </a:extLst>
           </p:cNvPr>
@@ -6791,7 +6791,7 @@
           <p:cNvPr id="4" name="">
             <a:extLst xmlns:a="http://schemas.openxmlformats.org/drawingml/2006/main">
               <a:ext uri="{FF2B5EF4-FFF2-40B4-BE49-F238E27FC236}">
-                <a16:creationId xmlns:a16="http://schemas.microsoft.com/office/drawing/2014/main" id="{2BB895AC-A27D-45FF-AA08-A9311F83E678}"/>
+                <a16:creationId xmlns:a16="http://schemas.microsoft.com/office/drawing/2014/main" id="{B9C75D9A-FBB7-46B1-91A9-845FD5F3AD70}"/>
               </a:ext>
             </a:extLst>
           </p:cNvPr>
@@ -6847,7 +6847,7 @@
                 <a:ea typeface="Arial"/>
                 <a:cs typeface="Arial"/>
               </a:rPr>
-              <a:t>SC6113 project demonstration</a:t>
+              <a:t>Du zhuotong  |  SC6113 project demonstration</a:t>
             </a:r>
           </a:p>
           <a:p xmlns:a="http://schemas.openxmlformats.org/drawingml/2006/main">
@@ -6878,7 +6878,7 @@
     </p:spTree>
     <p:extLst>
       <p:ext uri="{BB962C8B-B14F-4D97-AF65-F5344CB8AC3E}">
-        <p14:creationId xmlns:p14="http://schemas.microsoft.com/office/powerpoint/2010/main" val="944998850"/>
+        <p14:creationId xmlns:p14="http://schemas.microsoft.com/office/powerpoint/2010/main" val="1348722437"/>
       </p:ext>
     </p:extLst>
   </p:cSld>
@@ -6909,7 +6909,7 @@
           <p:cNvPr id="6" name="">
             <a:extLst xmlns:a="http://schemas.openxmlformats.org/drawingml/2006/main">
               <a:ext uri="{FF2B5EF4-FFF2-40B4-BE49-F238E27FC236}">
-                <a16:creationId xmlns:a16="http://schemas.microsoft.com/office/drawing/2014/main" id="{29865196-CDD8-4E2E-9B30-B4CF8AD38A79}"/>
+                <a16:creationId xmlns:a16="http://schemas.microsoft.com/office/drawing/2014/main" id="{6B18E0FE-11A9-4F45-B33A-1C8B992827D7}"/>
               </a:ext>
             </a:extLst>
           </p:cNvPr>
@@ -6975,7 +6975,7 @@
           <p:cNvPr id="2" name="">
             <a:extLst xmlns:a="http://schemas.openxmlformats.org/drawingml/2006/main">
               <a:ext uri="{FF2B5EF4-FFF2-40B4-BE49-F238E27FC236}">
-                <a16:creationId xmlns:a16="http://schemas.microsoft.com/office/drawing/2014/main" id="{B7A6060E-21B4-44B2-8395-1F8AD8C5983E}"/>
+                <a16:creationId xmlns:a16="http://schemas.microsoft.com/office/drawing/2014/main" id="{95659D87-7D44-48AA-9814-AFB40CC85770}"/>
               </a:ext>
             </a:extLst>
           </p:cNvPr>
@@ -7041,7 +7041,7 @@
           <p:cNvPr id="3" name="">
             <a:extLst xmlns:a="http://schemas.openxmlformats.org/drawingml/2006/main">
               <a:ext uri="{FF2B5EF4-FFF2-40B4-BE49-F238E27FC236}">
-                <a16:creationId xmlns:a16="http://schemas.microsoft.com/office/drawing/2014/main" id="{54A288F4-3127-4BF2-9259-5C3AC0FF4DF5}"/>
+                <a16:creationId xmlns:a16="http://schemas.microsoft.com/office/drawing/2014/main" id="{2E6C0CBD-D1B7-4104-901C-932E94525634}"/>
               </a:ext>
             </a:extLst>
           </p:cNvPr>
@@ -7153,7 +7153,7 @@
           <p:cNvPr id="4" name="">
             <a:extLst xmlns:a="http://schemas.openxmlformats.org/drawingml/2006/main">
               <a:ext uri="{FF2B5EF4-FFF2-40B4-BE49-F238E27FC236}">
-                <a16:creationId xmlns:a16="http://schemas.microsoft.com/office/drawing/2014/main" id="{FEFA5774-FEFD-4A25-92CA-0922CED24A13}"/>
+                <a16:creationId xmlns:a16="http://schemas.microsoft.com/office/drawing/2014/main" id="{F9B5659B-E37D-4529-B6F4-ABAECCD418E4}"/>
               </a:ext>
             </a:extLst>
           </p:cNvPr>
@@ -7219,7 +7219,7 @@
           <p:cNvPr id="5" name="">
             <a:extLst xmlns:a="http://schemas.openxmlformats.org/drawingml/2006/main">
               <a:ext uri="{FF2B5EF4-FFF2-40B4-BE49-F238E27FC236}">
-                <a16:creationId xmlns:a16="http://schemas.microsoft.com/office/drawing/2014/main" id="{D5EF9893-F9E0-48E6-A38D-80627A45A43B}"/>
+                <a16:creationId xmlns:a16="http://schemas.microsoft.com/office/drawing/2014/main" id="{401A5CBA-38C6-4126-92EF-DBB9F4C7E945}"/>
               </a:ext>
             </a:extLst>
           </p:cNvPr>
@@ -7283,7 +7283,7 @@
     </p:spTree>
     <p:extLst>
       <p:ext uri="{BB962C8B-B14F-4D97-AF65-F5344CB8AC3E}">
-        <p14:creationId xmlns:p14="http://schemas.microsoft.com/office/powerpoint/2010/main" val="404643679"/>
+        <p14:creationId xmlns:p14="http://schemas.microsoft.com/office/powerpoint/2010/main" val="2060134819"/>
       </p:ext>
     </p:extLst>
   </p:cSld>
@@ -7314,7 +7314,7 @@
           <p:cNvPr id="4" name="">
             <a:extLst xmlns:a="http://schemas.openxmlformats.org/drawingml/2006/main">
               <a:ext uri="{FF2B5EF4-FFF2-40B4-BE49-F238E27FC236}">
-                <a16:creationId xmlns:a16="http://schemas.microsoft.com/office/drawing/2014/main" id="{D30A0999-BE39-43FC-A9B1-9488FE5C3940}"/>
+                <a16:creationId xmlns:a16="http://schemas.microsoft.com/office/drawing/2014/main" id="{86EE79A8-9541-4A6F-A1A7-B3376763E394}"/>
               </a:ext>
             </a:extLst>
           </p:cNvPr>
@@ -7380,7 +7380,7 @@
           <p:cNvPr id="2" name="">
             <a:extLst xmlns:a="http://schemas.openxmlformats.org/drawingml/2006/main">
               <a:ext uri="{FF2B5EF4-FFF2-40B4-BE49-F238E27FC236}">
-                <a16:creationId xmlns:a16="http://schemas.microsoft.com/office/drawing/2014/main" id="{5AF381E6-AC5E-43ED-8CBA-C7095A9CA6C1}"/>
+                <a16:creationId xmlns:a16="http://schemas.microsoft.com/office/drawing/2014/main" id="{9C0BDD56-B7C4-4E13-B821-1A3F1CED32F5}"/>
               </a:ext>
             </a:extLst>
           </p:cNvPr>
@@ -7658,7 +7658,7 @@
           <p:cNvPr id="3" name="">
             <a:extLst xmlns:a="http://schemas.openxmlformats.org/drawingml/2006/main">
               <a:ext uri="{FF2B5EF4-FFF2-40B4-BE49-F238E27FC236}">
-                <a16:creationId xmlns:a16="http://schemas.microsoft.com/office/drawing/2014/main" id="{5B56221E-540A-42EB-B623-0AC29A12D60D}"/>
+                <a16:creationId xmlns:a16="http://schemas.microsoft.com/office/drawing/2014/main" id="{57535E0A-9B66-4D18-B93D-5E75B6F70665}"/>
               </a:ext>
             </a:extLst>
           </p:cNvPr>
@@ -7722,7 +7722,7 @@
     </p:spTree>
     <p:extLst>
       <p:ext uri="{BB962C8B-B14F-4D97-AF65-F5344CB8AC3E}">
-        <p14:creationId xmlns:p14="http://schemas.microsoft.com/office/powerpoint/2010/main" val="1968300675"/>
+        <p14:creationId xmlns:p14="http://schemas.microsoft.com/office/powerpoint/2010/main" val="319411937"/>
       </p:ext>
     </p:extLst>
   </p:cSld>
@@ -7753,7 +7753,7 @@
           <p:cNvPr id="4" name="">
             <a:extLst xmlns:a="http://schemas.openxmlformats.org/drawingml/2006/main">
               <a:ext uri="{FF2B5EF4-FFF2-40B4-BE49-F238E27FC236}">
-                <a16:creationId xmlns:a16="http://schemas.microsoft.com/office/drawing/2014/main" id="{43497390-84F8-4FC1-B9FB-53B70860EF5C}"/>
+                <a16:creationId xmlns:a16="http://schemas.microsoft.com/office/drawing/2014/main" id="{B9306FC9-F44D-4636-95AC-03479F4FEA51}"/>
               </a:ext>
             </a:extLst>
           </p:cNvPr>
@@ -7819,7 +7819,7 @@
           <p:cNvPr id="2" name="">
             <a:extLst xmlns:a="http://schemas.openxmlformats.org/drawingml/2006/main">
               <a:ext uri="{FF2B5EF4-FFF2-40B4-BE49-F238E27FC236}">
-                <a16:creationId xmlns:a16="http://schemas.microsoft.com/office/drawing/2014/main" id="{1DCEF373-AA98-463B-891A-4B97B65F4678}"/>
+                <a16:creationId xmlns:a16="http://schemas.microsoft.com/office/drawing/2014/main" id="{98945E39-FAEE-481C-AF21-88B19A0AE9F7}"/>
               </a:ext>
             </a:extLst>
           </p:cNvPr>
@@ -8157,7 +8157,7 @@
           <p:cNvPr id="3" name="">
             <a:extLst xmlns:a="http://schemas.openxmlformats.org/drawingml/2006/main">
               <a:ext uri="{FF2B5EF4-FFF2-40B4-BE49-F238E27FC236}">
-                <a16:creationId xmlns:a16="http://schemas.microsoft.com/office/drawing/2014/main" id="{762A71C0-32E1-4626-A775-26D6DD792769}"/>
+                <a16:creationId xmlns:a16="http://schemas.microsoft.com/office/drawing/2014/main" id="{E18943B0-117D-433A-ACC0-BE0B1F38D915}"/>
               </a:ext>
             </a:extLst>
           </p:cNvPr>
@@ -8221,7 +8221,7 @@
     </p:spTree>
     <p:extLst>
       <p:ext uri="{BB962C8B-B14F-4D97-AF65-F5344CB8AC3E}">
-        <p14:creationId xmlns:p14="http://schemas.microsoft.com/office/powerpoint/2010/main" val="1468288052"/>
+        <p14:creationId xmlns:p14="http://schemas.microsoft.com/office/powerpoint/2010/main" val="440581810"/>
       </p:ext>
     </p:extLst>
   </p:cSld>
@@ -8252,7 +8252,7 @@
           <p:cNvPr id="4" name="">
             <a:extLst xmlns:a="http://schemas.openxmlformats.org/drawingml/2006/main">
               <a:ext uri="{FF2B5EF4-FFF2-40B4-BE49-F238E27FC236}">
-                <a16:creationId xmlns:a16="http://schemas.microsoft.com/office/drawing/2014/main" id="{B553D65F-6165-43B0-A755-A1B0A2D2D192}"/>
+                <a16:creationId xmlns:a16="http://schemas.microsoft.com/office/drawing/2014/main" id="{F084107F-D092-4A15-A403-BE3127D55ADA}"/>
               </a:ext>
             </a:extLst>
           </p:cNvPr>
@@ -8318,7 +8318,7 @@
           <p:cNvPr id="2" name="">
             <a:extLst xmlns:a="http://schemas.openxmlformats.org/drawingml/2006/main">
               <a:ext uri="{FF2B5EF4-FFF2-40B4-BE49-F238E27FC236}">
-                <a16:creationId xmlns:a16="http://schemas.microsoft.com/office/drawing/2014/main" id="{645AF872-0188-4343-B0BD-A072E8BAF4E8}"/>
+                <a16:creationId xmlns:a16="http://schemas.microsoft.com/office/drawing/2014/main" id="{BBA3FF65-1F04-4F5C-B765-EE9762ACACAE}"/>
               </a:ext>
             </a:extLst>
           </p:cNvPr>
@@ -8546,7 +8546,7 @@
           <p:cNvPr id="3" name="">
             <a:extLst xmlns:a="http://schemas.openxmlformats.org/drawingml/2006/main">
               <a:ext uri="{FF2B5EF4-FFF2-40B4-BE49-F238E27FC236}">
-                <a16:creationId xmlns:a16="http://schemas.microsoft.com/office/drawing/2014/main" id="{AD646BC8-133C-4A9A-9DBF-7AFC10BAE67D}"/>
+                <a16:creationId xmlns:a16="http://schemas.microsoft.com/office/drawing/2014/main" id="{16DF749F-96DF-43D4-9968-692A4199F2C5}"/>
               </a:ext>
             </a:extLst>
           </p:cNvPr>
@@ -8610,7 +8610,7 @@
     </p:spTree>
     <p:extLst>
       <p:ext uri="{BB962C8B-B14F-4D97-AF65-F5344CB8AC3E}">
-        <p14:creationId xmlns:p14="http://schemas.microsoft.com/office/powerpoint/2010/main" val="256521819"/>
+        <p14:creationId xmlns:p14="http://schemas.microsoft.com/office/powerpoint/2010/main" val="1953545721"/>
       </p:ext>
     </p:extLst>
   </p:cSld>
@@ -8641,7 +8641,7 @@
           <p:cNvPr id="7" name="">
             <a:extLst xmlns:a="http://schemas.openxmlformats.org/drawingml/2006/main">
               <a:ext uri="{FF2B5EF4-FFF2-40B4-BE49-F238E27FC236}">
-                <a16:creationId xmlns:a16="http://schemas.microsoft.com/office/drawing/2014/main" id="{1A75A2C8-C705-43B7-A548-65FEAF2EE059}"/>
+                <a16:creationId xmlns:a16="http://schemas.microsoft.com/office/drawing/2014/main" id="{2292F441-C022-4359-AF41-4772C790050B}"/>
               </a:ext>
             </a:extLst>
           </p:cNvPr>
@@ -8707,7 +8707,7 @@
           <p:cNvPr id="2" name="">
             <a:extLst xmlns:a="http://schemas.openxmlformats.org/drawingml/2006/main">
               <a:ext uri="{FF2B5EF4-FFF2-40B4-BE49-F238E27FC236}">
-                <a16:creationId xmlns:a16="http://schemas.microsoft.com/office/drawing/2014/main" id="{6EFA0A4B-D6E9-4E38-81FD-9E2FDA6123C1}"/>
+                <a16:creationId xmlns:a16="http://schemas.microsoft.com/office/drawing/2014/main" id="{2EA1C4F6-07CD-41EE-9F28-877B07EA41AD}"/>
               </a:ext>
             </a:extLst>
           </p:cNvPr>
@@ -8773,7 +8773,7 @@
           <p:cNvPr id="3" name="">
             <a:extLst xmlns:a="http://schemas.openxmlformats.org/drawingml/2006/main">
               <a:ext uri="{FF2B5EF4-FFF2-40B4-BE49-F238E27FC236}">
-                <a16:creationId xmlns:a16="http://schemas.microsoft.com/office/drawing/2014/main" id="{103C70ED-8EF0-4FF7-B377-D9EA42EE7DAC}"/>
+                <a16:creationId xmlns:a16="http://schemas.microsoft.com/office/drawing/2014/main" id="{B1A87FE8-1982-46E9-9CEF-86B4D78F4E71}"/>
               </a:ext>
             </a:extLst>
           </p:cNvPr>
@@ -8908,7 +8908,7 @@
           <p:cNvPr id="4" name="">
             <a:extLst xmlns:a="http://schemas.openxmlformats.org/drawingml/2006/main">
               <a:ext uri="{FF2B5EF4-FFF2-40B4-BE49-F238E27FC236}">
-                <a16:creationId xmlns:a16="http://schemas.microsoft.com/office/drawing/2014/main" id="{6638057C-22FA-4612-9A52-E7FE7A5FBD11}"/>
+                <a16:creationId xmlns:a16="http://schemas.microsoft.com/office/drawing/2014/main" id="{000CAD36-2313-474A-B62E-DE5F0E729D3D}"/>
               </a:ext>
             </a:extLst>
           </p:cNvPr>
@@ -8974,7 +8974,7 @@
           <p:cNvPr id="5" name="">
             <a:extLst xmlns:a="http://schemas.openxmlformats.org/drawingml/2006/main">
               <a:ext uri="{FF2B5EF4-FFF2-40B4-BE49-F238E27FC236}">
-                <a16:creationId xmlns:a16="http://schemas.microsoft.com/office/drawing/2014/main" id="{D3C9D08B-BDB4-4802-B626-3255B4DDDEB8}"/>
+                <a16:creationId xmlns:a16="http://schemas.microsoft.com/office/drawing/2014/main" id="{172DD296-3453-4445-9A7B-CB9E5D75FE35}"/>
               </a:ext>
             </a:extLst>
           </p:cNvPr>
@@ -9086,7 +9086,7 @@
           <p:cNvPr id="6" name="">
             <a:extLst xmlns:a="http://schemas.openxmlformats.org/drawingml/2006/main">
               <a:ext uri="{FF2B5EF4-FFF2-40B4-BE49-F238E27FC236}">
-                <a16:creationId xmlns:a16="http://schemas.microsoft.com/office/drawing/2014/main" id="{1D378DFD-F4DE-4576-B550-3BA3D3BAB73C}"/>
+                <a16:creationId xmlns:a16="http://schemas.microsoft.com/office/drawing/2014/main" id="{E7E8A183-F368-4A31-9191-6CF2FDE3884B}"/>
               </a:ext>
             </a:extLst>
           </p:cNvPr>
@@ -9150,7 +9150,7 @@
     </p:spTree>
     <p:extLst>
       <p:ext uri="{BB962C8B-B14F-4D97-AF65-F5344CB8AC3E}">
-        <p14:creationId xmlns:p14="http://schemas.microsoft.com/office/powerpoint/2010/main" val="1559525895"/>
+        <p14:creationId xmlns:p14="http://schemas.microsoft.com/office/powerpoint/2010/main" val="1692014357"/>
       </p:ext>
     </p:extLst>
   </p:cSld>
@@ -9181,7 +9181,7 @@
           <p:cNvPr id="6" name="">
             <a:extLst xmlns:a="http://schemas.openxmlformats.org/drawingml/2006/main">
               <a:ext uri="{FF2B5EF4-FFF2-40B4-BE49-F238E27FC236}">
-                <a16:creationId xmlns:a16="http://schemas.microsoft.com/office/drawing/2014/main" id="{684C8691-6DB4-4A7D-BE35-A38A9AF1B9A5}"/>
+                <a16:creationId xmlns:a16="http://schemas.microsoft.com/office/drawing/2014/main" id="{EC7AC48A-D342-45D5-A28C-8161FA260D5B}"/>
               </a:ext>
             </a:extLst>
           </p:cNvPr>
@@ -9247,7 +9247,7 @@
           <p:cNvPr id="2" name="Chart">
             <a:extLst xmlns:a="http://schemas.openxmlformats.org/drawingml/2006/main">
               <a:ext uri="{FF2B5EF4-FFF2-40B4-BE49-F238E27FC236}">
-                <a16:creationId xmlns:a16="http://schemas.microsoft.com/office/drawing/2014/main" id="{601F931C-4652-4FA6-9A6D-2E3CD5E72231}"/>
+                <a16:creationId xmlns:a16="http://schemas.microsoft.com/office/drawing/2014/main" id="{17C05F86-F79E-49C0-809E-D5D861A265CB}"/>
               </a:ext>
             </a:extLst>
           </p:cNvPr>
@@ -9260,7 +9260,7 @@
         </p:xfrm>
         <a:graphic xmlns:a="http://schemas.openxmlformats.org/drawingml/2006/main">
           <a:graphicData uri="http://schemas.openxmlformats.org/drawingml/2006/chart">
-            <c:chart xmlns:r="http://schemas.openxmlformats.org/officeDocument/2006/relationships" xmlns:c="http://schemas.openxmlformats.org/drawingml/2006/chart" r:id="R656d5e1339a14b81"/>
+            <c:chart xmlns:r="http://schemas.openxmlformats.org/officeDocument/2006/relationships" xmlns:c="http://schemas.openxmlformats.org/drawingml/2006/chart" r:id="Re504628e81824d5b"/>
           </a:graphicData>
         </a:graphic>
       </p:graphicFrame>
@@ -9269,7 +9269,7 @@
           <p:cNvPr id="3" name="">
             <a:extLst xmlns:a="http://schemas.openxmlformats.org/drawingml/2006/main">
               <a:ext uri="{FF2B5EF4-FFF2-40B4-BE49-F238E27FC236}">
-                <a16:creationId xmlns:a16="http://schemas.microsoft.com/office/drawing/2014/main" id="{BA91A604-253A-49D0-995F-8B3A3ED09BD1}"/>
+                <a16:creationId xmlns:a16="http://schemas.microsoft.com/office/drawing/2014/main" id="{1A05E781-A8B0-4EF3-90AC-262805634BFA}"/>
               </a:ext>
             </a:extLst>
           </p:cNvPr>
@@ -9335,7 +9335,7 @@
           <p:cNvPr id="4" name="">
             <a:extLst xmlns:a="http://schemas.openxmlformats.org/drawingml/2006/main">
               <a:ext uri="{FF2B5EF4-FFF2-40B4-BE49-F238E27FC236}">
-                <a16:creationId xmlns:a16="http://schemas.microsoft.com/office/drawing/2014/main" id="{320D7F03-108D-41F6-ADC5-84E97C975166}"/>
+                <a16:creationId xmlns:a16="http://schemas.microsoft.com/office/drawing/2014/main" id="{52639FE2-7D62-42A4-ABAC-EF5B3CB016FF}"/>
               </a:ext>
             </a:extLst>
           </p:cNvPr>
@@ -9447,7 +9447,7 @@
           <p:cNvPr id="5" name="">
             <a:extLst xmlns:a="http://schemas.openxmlformats.org/drawingml/2006/main">
               <a:ext uri="{FF2B5EF4-FFF2-40B4-BE49-F238E27FC236}">
-                <a16:creationId xmlns:a16="http://schemas.microsoft.com/office/drawing/2014/main" id="{2FCEB659-D08C-4794-B3E8-0D554418AE68}"/>
+                <a16:creationId xmlns:a16="http://schemas.microsoft.com/office/drawing/2014/main" id="{707E8136-7A44-42AA-833E-72216180999A}"/>
               </a:ext>
             </a:extLst>
           </p:cNvPr>
@@ -9511,7 +9511,7 @@
     </p:spTree>
     <p:extLst>
       <p:ext uri="{BB962C8B-B14F-4D97-AF65-F5344CB8AC3E}">
-        <p14:creationId xmlns:p14="http://schemas.microsoft.com/office/powerpoint/2010/main" val="501492124"/>
+        <p14:creationId xmlns:p14="http://schemas.microsoft.com/office/powerpoint/2010/main" val="1639815905"/>
       </p:ext>
     </p:extLst>
   </p:cSld>
@@ -9542,7 +9542,7 @@
           <p:cNvPr id="6" name="">
             <a:extLst xmlns:a="http://schemas.openxmlformats.org/drawingml/2006/main">
               <a:ext uri="{FF2B5EF4-FFF2-40B4-BE49-F238E27FC236}">
-                <a16:creationId xmlns:a16="http://schemas.microsoft.com/office/drawing/2014/main" id="{BDFB734F-D774-4D8D-86F9-BF1B2C22C4CE}"/>
+                <a16:creationId xmlns:a16="http://schemas.microsoft.com/office/drawing/2014/main" id="{6A7F7D2D-9CE8-4F93-9A1D-7AD0A26EC994}"/>
               </a:ext>
             </a:extLst>
           </p:cNvPr>
@@ -9608,7 +9608,7 @@
           <p:cNvPr id="2" name="">
             <a:extLst xmlns:a="http://schemas.openxmlformats.org/drawingml/2006/main">
               <a:ext uri="{FF2B5EF4-FFF2-40B4-BE49-F238E27FC236}">
-                <a16:creationId xmlns:a16="http://schemas.microsoft.com/office/drawing/2014/main" id="{337AA4E8-2ADE-4762-BF06-4F9ABDCA7B19}"/>
+                <a16:creationId xmlns:a16="http://schemas.microsoft.com/office/drawing/2014/main" id="{35144AD8-50AA-4153-ABDA-25732CAF519E}"/>
               </a:ext>
             </a:extLst>
           </p:cNvPr>
@@ -9674,7 +9674,7 @@
           <p:cNvPr id="3" name="">
             <a:extLst xmlns:a="http://schemas.openxmlformats.org/drawingml/2006/main">
               <a:ext uri="{FF2B5EF4-FFF2-40B4-BE49-F238E27FC236}">
-                <a16:creationId xmlns:a16="http://schemas.microsoft.com/office/drawing/2014/main" id="{CCEA5656-0C86-4CD6-B804-8B7E6BEDD1EA}"/>
+                <a16:creationId xmlns:a16="http://schemas.microsoft.com/office/drawing/2014/main" id="{E2FCF62B-C1CF-4A60-8256-93DA3655352F}"/>
               </a:ext>
             </a:extLst>
           </p:cNvPr>
@@ -9763,7 +9763,7 @@
           <p:cNvPr id="4" name="">
             <a:extLst xmlns:a="http://schemas.openxmlformats.org/drawingml/2006/main">
               <a:ext uri="{FF2B5EF4-FFF2-40B4-BE49-F238E27FC236}">
-                <a16:creationId xmlns:a16="http://schemas.microsoft.com/office/drawing/2014/main" id="{3DF8510A-72BE-44D2-B032-3BDE0A881FBC}"/>
+                <a16:creationId xmlns:a16="http://schemas.microsoft.com/office/drawing/2014/main" id="{8899B8CD-4E10-4FFB-820B-E3990AB10C16}"/>
               </a:ext>
             </a:extLst>
           </p:cNvPr>
@@ -9829,7 +9829,7 @@
           <p:cNvPr id="5" name="">
             <a:extLst xmlns:a="http://schemas.openxmlformats.org/drawingml/2006/main">
               <a:ext uri="{FF2B5EF4-FFF2-40B4-BE49-F238E27FC236}">
-                <a16:creationId xmlns:a16="http://schemas.microsoft.com/office/drawing/2014/main" id="{B7102E5A-937D-41BA-99C2-EA02824245F6}"/>
+                <a16:creationId xmlns:a16="http://schemas.microsoft.com/office/drawing/2014/main" id="{D1836AC1-7EED-43C1-BF5A-CC6882A96B18}"/>
               </a:ext>
             </a:extLst>
           </p:cNvPr>
@@ -9916,7 +9916,7 @@
     </p:spTree>
     <p:extLst>
       <p:ext uri="{BB962C8B-B14F-4D97-AF65-F5344CB8AC3E}">
-        <p14:creationId xmlns:p14="http://schemas.microsoft.com/office/powerpoint/2010/main" val="666144972"/>
+        <p14:creationId xmlns:p14="http://schemas.microsoft.com/office/powerpoint/2010/main" val="62820365"/>
       </p:ext>
     </p:extLst>
   </p:cSld>
@@ -9947,7 +9947,7 @@
           <p:cNvPr id="4" name="">
             <a:extLst xmlns:a="http://schemas.openxmlformats.org/drawingml/2006/main">
               <a:ext uri="{FF2B5EF4-FFF2-40B4-BE49-F238E27FC236}">
-                <a16:creationId xmlns:a16="http://schemas.microsoft.com/office/drawing/2014/main" id="{9775C78B-A776-4BA1-AF24-7DCF291F9AE6}"/>
+                <a16:creationId xmlns:a16="http://schemas.microsoft.com/office/drawing/2014/main" id="{A2C4AA25-657D-4E96-A1FB-909E3897C17C}"/>
               </a:ext>
             </a:extLst>
           </p:cNvPr>
@@ -10013,7 +10013,7 @@
           <p:cNvPr id="2" name="">
             <a:extLst xmlns:a="http://schemas.openxmlformats.org/drawingml/2006/main">
               <a:ext uri="{FF2B5EF4-FFF2-40B4-BE49-F238E27FC236}">
-                <a16:creationId xmlns:a16="http://schemas.microsoft.com/office/drawing/2014/main" id="{6E590E1C-3E41-46A3-B6ED-F3CE6B182268}"/>
+                <a16:creationId xmlns:a16="http://schemas.microsoft.com/office/drawing/2014/main" id="{D9D70178-3369-4651-82CF-A0E3D8AF5230}"/>
               </a:ext>
             </a:extLst>
           </p:cNvPr>
@@ -10338,7 +10338,7 @@
           <p:cNvPr id="3" name="">
             <a:extLst xmlns:a="http://schemas.openxmlformats.org/drawingml/2006/main">
               <a:ext uri="{FF2B5EF4-FFF2-40B4-BE49-F238E27FC236}">
-                <a16:creationId xmlns:a16="http://schemas.microsoft.com/office/drawing/2014/main" id="{04DF56A4-BC1E-45C8-863C-C7B887D8020A}"/>
+                <a16:creationId xmlns:a16="http://schemas.microsoft.com/office/drawing/2014/main" id="{CD3FDD71-197B-469F-8BF8-36A5D63A915C}"/>
               </a:ext>
             </a:extLst>
           </p:cNvPr>
@@ -10425,7 +10425,7 @@
     </p:spTree>
     <p:extLst>
       <p:ext uri="{BB962C8B-B14F-4D97-AF65-F5344CB8AC3E}">
-        <p14:creationId xmlns:p14="http://schemas.microsoft.com/office/powerpoint/2010/main" val="1852941735"/>
+        <p14:creationId xmlns:p14="http://schemas.microsoft.com/office/powerpoint/2010/main" val="1080685892"/>
       </p:ext>
     </p:extLst>
   </p:cSld>
@@ -10456,7 +10456,7 @@
           <p:cNvPr id="4" name="">
             <a:extLst xmlns:a="http://schemas.openxmlformats.org/drawingml/2006/main">
               <a:ext uri="{FF2B5EF4-FFF2-40B4-BE49-F238E27FC236}">
-                <a16:creationId xmlns:a16="http://schemas.microsoft.com/office/drawing/2014/main" id="{CF3E46A0-D5CC-4314-9ED1-06B8D2163B53}"/>
+                <a16:creationId xmlns:a16="http://schemas.microsoft.com/office/drawing/2014/main" id="{342070F9-32D0-4D87-975F-9DFB6BB5674B}"/>
               </a:ext>
             </a:extLst>
           </p:cNvPr>
@@ -10522,7 +10522,7 @@
           <p:cNvPr id="2" name="">
             <a:extLst xmlns:a="http://schemas.openxmlformats.org/drawingml/2006/main">
               <a:ext uri="{FF2B5EF4-FFF2-40B4-BE49-F238E27FC236}">
-                <a16:creationId xmlns:a16="http://schemas.microsoft.com/office/drawing/2014/main" id="{D0E3E948-F167-4847-923A-80441F722D04}"/>
+                <a16:creationId xmlns:a16="http://schemas.microsoft.com/office/drawing/2014/main" id="{A97C67AF-DE39-4929-B89D-DE457AF83A0C}"/>
               </a:ext>
             </a:extLst>
           </p:cNvPr>
@@ -10800,7 +10800,7 @@
           <p:cNvPr id="3" name="">
             <a:extLst xmlns:a="http://schemas.openxmlformats.org/drawingml/2006/main">
               <a:ext uri="{FF2B5EF4-FFF2-40B4-BE49-F238E27FC236}">
-                <a16:creationId xmlns:a16="http://schemas.microsoft.com/office/drawing/2014/main" id="{3846EBB6-26BA-447B-A22D-8B32737B882C}"/>
+                <a16:creationId xmlns:a16="http://schemas.microsoft.com/office/drawing/2014/main" id="{FDDECB37-A6FA-480A-9A82-D3338C80D0BB}"/>
               </a:ext>
             </a:extLst>
           </p:cNvPr>
@@ -10864,7 +10864,7 @@
     </p:spTree>
     <p:extLst>
       <p:ext uri="{BB962C8B-B14F-4D97-AF65-F5344CB8AC3E}">
-        <p14:creationId xmlns:p14="http://schemas.microsoft.com/office/powerpoint/2010/main" val="1506148383"/>
+        <p14:creationId xmlns:p14="http://schemas.microsoft.com/office/powerpoint/2010/main" val="1760200533"/>
       </p:ext>
     </p:extLst>
   </p:cSld>

</xml_diff>

<commit_message>
Align submission materials with public repository and current deployment
</commit_message>
<xml_diff>
--- a/submission/AlphaVault-Presentation.pptx
+++ b/submission/AlphaVault-Presentation.pptx
@@ -2,24 +2,24 @@
 <file path=ppt/presentation.xml><?xml version="1.0" encoding="utf-8"?>
 <p:presentation xmlns:p="http://schemas.openxmlformats.org/presentationml/2006/main">
   <p:sldMasterIdLst>
-    <p:sldMasterId xmlns:r="http://schemas.openxmlformats.org/officeDocument/2006/relationships" id="2147483648" r:id="Rb310d442b94b4b92"/>
+    <p:sldMasterId xmlns:r="http://schemas.openxmlformats.org/officeDocument/2006/relationships" id="2147483648" r:id="R4d3d154819f94cd3"/>
   </p:sldMasterIdLst>
   <p:notesMasterIdLst>
-    <p:notesMasterId xmlns:r="http://schemas.openxmlformats.org/officeDocument/2006/relationships" r:id="R46d5ab7ce2fd46f9"/>
+    <p:notesMasterId xmlns:r="http://schemas.openxmlformats.org/officeDocument/2006/relationships" r:id="R7633797fe63045f9"/>
   </p:notesMasterIdLst>
   <p:sldIdLst>
-    <p:sldId xmlns:r="http://schemas.openxmlformats.org/officeDocument/2006/relationships" id="256" r:id="R0e4f70de742740a2"/>
-    <p:sldId xmlns:r="http://schemas.openxmlformats.org/officeDocument/2006/relationships" id="257" r:id="R34dc6d6458d946c5"/>
-    <p:sldId xmlns:r="http://schemas.openxmlformats.org/officeDocument/2006/relationships" id="258" r:id="Ra53262d7109e4b75"/>
-    <p:sldId xmlns:r="http://schemas.openxmlformats.org/officeDocument/2006/relationships" id="259" r:id="R6e2da4232ca143e1"/>
-    <p:sldId xmlns:r="http://schemas.openxmlformats.org/officeDocument/2006/relationships" id="260" r:id="R41fb08e627124e9e"/>
-    <p:sldId xmlns:r="http://schemas.openxmlformats.org/officeDocument/2006/relationships" id="261" r:id="R886491b66d684c11"/>
-    <p:sldId xmlns:r="http://schemas.openxmlformats.org/officeDocument/2006/relationships" id="262" r:id="Rb3359ff5e07a4e31"/>
-    <p:sldId xmlns:r="http://schemas.openxmlformats.org/officeDocument/2006/relationships" id="263" r:id="Rb32e7893935f4fc9"/>
-    <p:sldId xmlns:r="http://schemas.openxmlformats.org/officeDocument/2006/relationships" id="264" r:id="R3761ce16d6e64dc7"/>
-    <p:sldId xmlns:r="http://schemas.openxmlformats.org/officeDocument/2006/relationships" id="265" r:id="R04e975cb953745b5"/>
-    <p:sldId xmlns:r="http://schemas.openxmlformats.org/officeDocument/2006/relationships" id="266" r:id="R041ea3e7b7e04fec"/>
-    <p:sldId xmlns:r="http://schemas.openxmlformats.org/officeDocument/2006/relationships" id="267" r:id="R4fe4ca9e1fef4d95"/>
+    <p:sldId xmlns:r="http://schemas.openxmlformats.org/officeDocument/2006/relationships" id="256" r:id="R34ee6d8936e541eb"/>
+    <p:sldId xmlns:r="http://schemas.openxmlformats.org/officeDocument/2006/relationships" id="257" r:id="Rf622a2ce1dda4853"/>
+    <p:sldId xmlns:r="http://schemas.openxmlformats.org/officeDocument/2006/relationships" id="258" r:id="R2d6377340a7844d7"/>
+    <p:sldId xmlns:r="http://schemas.openxmlformats.org/officeDocument/2006/relationships" id="259" r:id="R955e607e30d24ea4"/>
+    <p:sldId xmlns:r="http://schemas.openxmlformats.org/officeDocument/2006/relationships" id="260" r:id="R4ab07de2eb734eec"/>
+    <p:sldId xmlns:r="http://schemas.openxmlformats.org/officeDocument/2006/relationships" id="261" r:id="R596f287c33f847b7"/>
+    <p:sldId xmlns:r="http://schemas.openxmlformats.org/officeDocument/2006/relationships" id="262" r:id="R30a88f7fdad04ff6"/>
+    <p:sldId xmlns:r="http://schemas.openxmlformats.org/officeDocument/2006/relationships" id="263" r:id="R61c85e0deea544d1"/>
+    <p:sldId xmlns:r="http://schemas.openxmlformats.org/officeDocument/2006/relationships" id="264" r:id="R0486eae28b0445b8"/>
+    <p:sldId xmlns:r="http://schemas.openxmlformats.org/officeDocument/2006/relationships" id="265" r:id="R33391cd129674e27"/>
+    <p:sldId xmlns:r="http://schemas.openxmlformats.org/officeDocument/2006/relationships" id="266" r:id="R8cb8460dd3ef466d"/>
+    <p:sldId xmlns:r="http://schemas.openxmlformats.org/officeDocument/2006/relationships" id="267" r:id="Rb387f8e8ec62482d"/>
   </p:sldIdLst>
   <p:sldSz cx="12192000" cy="6858000"/>
   <p:notesSz cx="6858000" cy="9144000"/>
@@ -533,7 +533,7 @@
           </a:p>
           <a:p xmlns:a="http://schemas.openxmlformats.org/drawingml/2006/main">
             <a:r>
-              <a:t>Source: evidence/submission-tests.tap, submission-hosted-check.json, hosted-jobs-*.json.</a:t>
+              <a:t>Source: evidence/current-tests.tap, submission-hosted-check.json, hosted-jobs-*.json.</a:t>
             </a:r>
           </a:p>
         </p:txBody>
@@ -1330,7 +1330,7 @@
           <p:cNvPr id="3" name="Title">
             <a:extLst xmlns:a="http://schemas.openxmlformats.org/drawingml/2006/main">
               <a:ext uri="{FF2B5EF4-FFF2-40B4-BE49-F238E27FC236}">
-                <a16:creationId xmlns:a16="http://schemas.microsoft.com/office/drawing/2014/main" id="{481690E9-AA6A-4679-BE4F-98C76EA79C45}"/>
+                <a16:creationId xmlns:a16="http://schemas.microsoft.com/office/drawing/2014/main" id="{DC6729F1-B238-4EAB-B5C0-D9513F57776E}"/>
               </a:ext>
             </a:extLst>
           </p:cNvPr>
@@ -1487,7 +1487,7 @@
           <p:cNvPr id="2" name="Subtitle">
             <a:extLst xmlns:a="http://schemas.openxmlformats.org/drawingml/2006/main">
               <a:ext uri="{FF2B5EF4-FFF2-40B4-BE49-F238E27FC236}">
-                <a16:creationId xmlns:a16="http://schemas.microsoft.com/office/drawing/2014/main" id="{34196B3A-4D41-435B-906F-CC5F807E681E}"/>
+                <a16:creationId xmlns:a16="http://schemas.microsoft.com/office/drawing/2014/main" id="{ECAD22F5-9169-4FA5-9BF8-B2F7C3F09076}"/>
               </a:ext>
             </a:extLst>
           </p:cNvPr>
@@ -1661,7 +1661,7 @@
           <p:cNvPr id="2" name="Section title">
             <a:extLst xmlns:a="http://schemas.openxmlformats.org/drawingml/2006/main">
               <a:ext uri="{FF2B5EF4-FFF2-40B4-BE49-F238E27FC236}">
-                <a16:creationId xmlns:a16="http://schemas.microsoft.com/office/drawing/2014/main" id="{45E4476E-492E-4952-A41B-E8A8F5C71D1C}"/>
+                <a16:creationId xmlns:a16="http://schemas.microsoft.com/office/drawing/2014/main" id="{72F6C952-BE07-4644-A26A-FA2DFCEAE99C}"/>
               </a:ext>
             </a:extLst>
           </p:cNvPr>
@@ -1835,7 +1835,7 @@
           <p:cNvPr id="3" name="Title">
             <a:extLst xmlns:a="http://schemas.openxmlformats.org/drawingml/2006/main">
               <a:ext uri="{FF2B5EF4-FFF2-40B4-BE49-F238E27FC236}">
-                <a16:creationId xmlns:a16="http://schemas.microsoft.com/office/drawing/2014/main" id="{9AA0D517-AA5C-4309-B800-0FD668C79478}"/>
+                <a16:creationId xmlns:a16="http://schemas.microsoft.com/office/drawing/2014/main" id="{57E36E3B-C7A4-4B64-A1CC-FB04CB540177}"/>
               </a:ext>
             </a:extLst>
           </p:cNvPr>
@@ -1992,7 +1992,7 @@
           <p:cNvPr id="2" name="Body">
             <a:extLst xmlns:a="http://schemas.openxmlformats.org/drawingml/2006/main">
               <a:ext uri="{FF2B5EF4-FFF2-40B4-BE49-F238E27FC236}">
-                <a16:creationId xmlns:a16="http://schemas.microsoft.com/office/drawing/2014/main" id="{3E918968-9305-4780-A662-220F980E3067}"/>
+                <a16:creationId xmlns:a16="http://schemas.microsoft.com/office/drawing/2014/main" id="{22999E9B-22A1-42F0-8C16-CC72A516CA2F}"/>
               </a:ext>
             </a:extLst>
           </p:cNvPr>
@@ -2166,7 +2166,7 @@
           <p:cNvPr id="4" name="Title">
             <a:extLst xmlns:a="http://schemas.openxmlformats.org/drawingml/2006/main">
               <a:ext uri="{FF2B5EF4-FFF2-40B4-BE49-F238E27FC236}">
-                <a16:creationId xmlns:a16="http://schemas.microsoft.com/office/drawing/2014/main" id="{BFB42CBF-A35E-413A-803F-43F278710B5F}"/>
+                <a16:creationId xmlns:a16="http://schemas.microsoft.com/office/drawing/2014/main" id="{D07EA27B-A04B-4755-9996-1A53151CD943}"/>
               </a:ext>
             </a:extLst>
           </p:cNvPr>
@@ -2323,7 +2323,7 @@
           <p:cNvPr id="2" name="Left column">
             <a:extLst xmlns:a="http://schemas.openxmlformats.org/drawingml/2006/main">
               <a:ext uri="{FF2B5EF4-FFF2-40B4-BE49-F238E27FC236}">
-                <a16:creationId xmlns:a16="http://schemas.microsoft.com/office/drawing/2014/main" id="{C5A2805E-C94F-404B-B903-074C2FFE74C1}"/>
+                <a16:creationId xmlns:a16="http://schemas.microsoft.com/office/drawing/2014/main" id="{3D5027CC-D9BB-492A-8569-A8BE5175FD84}"/>
               </a:ext>
             </a:extLst>
           </p:cNvPr>
@@ -2480,7 +2480,7 @@
           <p:cNvPr id="3" name="Right column">
             <a:extLst xmlns:a="http://schemas.openxmlformats.org/drawingml/2006/main">
               <a:ext uri="{FF2B5EF4-FFF2-40B4-BE49-F238E27FC236}">
-                <a16:creationId xmlns:a16="http://schemas.microsoft.com/office/drawing/2014/main" id="{51D2295E-2AC7-40E6-87CE-D09D8F735F60}"/>
+                <a16:creationId xmlns:a16="http://schemas.microsoft.com/office/drawing/2014/main" id="{7D5650A0-E0A2-4C16-A6E3-8F2E57D28444}"/>
               </a:ext>
             </a:extLst>
           </p:cNvPr>
@@ -2654,7 +2654,7 @@
           <p:cNvPr id="3" name="Title">
             <a:extLst xmlns:a="http://schemas.openxmlformats.org/drawingml/2006/main">
               <a:ext uri="{FF2B5EF4-FFF2-40B4-BE49-F238E27FC236}">
-                <a16:creationId xmlns:a16="http://schemas.microsoft.com/office/drawing/2014/main" id="{31E41049-5EA2-4725-AEA5-9ACEE47E9378}"/>
+                <a16:creationId xmlns:a16="http://schemas.microsoft.com/office/drawing/2014/main" id="{DD938C23-2A31-4131-9EF1-802C583F594B}"/>
               </a:ext>
             </a:extLst>
           </p:cNvPr>
@@ -2811,7 +2811,7 @@
           <p:cNvPr id="2" name="Left column">
             <a:extLst xmlns:a="http://schemas.openxmlformats.org/drawingml/2006/main">
               <a:ext uri="{FF2B5EF4-FFF2-40B4-BE49-F238E27FC236}">
-                <a16:creationId xmlns:a16="http://schemas.microsoft.com/office/drawing/2014/main" id="{09D32AEA-E6A6-4A77-90A3-7E4AF04E7B6D}"/>
+                <a16:creationId xmlns:a16="http://schemas.microsoft.com/office/drawing/2014/main" id="{866E9B17-126B-4793-B297-CE4B05D9D73F}"/>
               </a:ext>
             </a:extLst>
           </p:cNvPr>
@@ -3006,12 +3006,12 @@
   </p:cSld>
   <p:clrMap bg1="lt1" tx1="dk1" bg2="lt2" tx2="dk2" accent1="accent1" accent2="accent2" accent3="accent3" accent4="accent4" accent5="accent5" accent6="accent6" hlink="hlink" folHlink="folHlink"/>
   <p:sldLayoutIdLst>
-    <p:sldLayoutId xmlns:r="http://schemas.openxmlformats.org/officeDocument/2006/relationships" id="2147483649" r:id="Rad52270d19ac49b5"/>
-    <p:sldLayoutId xmlns:r="http://schemas.openxmlformats.org/officeDocument/2006/relationships" id="2147483650" r:id="R7934a89b3ed24b71"/>
-    <p:sldLayoutId xmlns:r="http://schemas.openxmlformats.org/officeDocument/2006/relationships" id="2147483651" r:id="Rafea1ca58fbd45b2"/>
-    <p:sldLayoutId xmlns:r="http://schemas.openxmlformats.org/officeDocument/2006/relationships" id="2147483652" r:id="R93cc497d6bf84a1d"/>
-    <p:sldLayoutId xmlns:r="http://schemas.openxmlformats.org/officeDocument/2006/relationships" id="2147483653" r:id="Rd2320585865542b9"/>
-    <p:sldLayoutId xmlns:r="http://schemas.openxmlformats.org/officeDocument/2006/relationships" id="2147483654" r:id="Rd0d25dd5b1ec494b"/>
+    <p:sldLayoutId xmlns:r="http://schemas.openxmlformats.org/officeDocument/2006/relationships" id="2147483649" r:id="R10b2d90a032c4c5d"/>
+    <p:sldLayoutId xmlns:r="http://schemas.openxmlformats.org/officeDocument/2006/relationships" id="2147483650" r:id="R9694ddf139ac498a"/>
+    <p:sldLayoutId xmlns:r="http://schemas.openxmlformats.org/officeDocument/2006/relationships" id="2147483651" r:id="Ra16a9d3efc51409e"/>
+    <p:sldLayoutId xmlns:r="http://schemas.openxmlformats.org/officeDocument/2006/relationships" id="2147483652" r:id="Re703a2dd755c4f4b"/>
+    <p:sldLayoutId xmlns:r="http://schemas.openxmlformats.org/officeDocument/2006/relationships" id="2147483653" r:id="Rd600115218164805"/>
+    <p:sldLayoutId xmlns:r="http://schemas.openxmlformats.org/officeDocument/2006/relationships" id="2147483654" r:id="R3bea4adc9cb64e77"/>
   </p:sldLayoutIdLst>
   <p:txStyles>
     <p:titleStyle>
@@ -5771,7 +5771,7 @@
           <p:cNvPr id="6" name="">
             <a:extLst xmlns:a="http://schemas.openxmlformats.org/drawingml/2006/main">
               <a:ext uri="{FF2B5EF4-FFF2-40B4-BE49-F238E27FC236}">
-                <a16:creationId xmlns:a16="http://schemas.microsoft.com/office/drawing/2014/main" id="{0F89C895-799E-42B9-8FBA-D458452B34B2}"/>
+                <a16:creationId xmlns:a16="http://schemas.microsoft.com/office/drawing/2014/main" id="{E4A1AE86-F336-4033-BABA-96A204513821}"/>
               </a:ext>
             </a:extLst>
           </p:cNvPr>
@@ -5837,7 +5837,7 @@
           <p:cNvPr id="2" name="">
             <a:extLst xmlns:a="http://schemas.openxmlformats.org/drawingml/2006/main">
               <a:ext uri="{FF2B5EF4-FFF2-40B4-BE49-F238E27FC236}">
-                <a16:creationId xmlns:a16="http://schemas.microsoft.com/office/drawing/2014/main" id="{C9C24825-3A93-4695-B5B3-A0525397E07D}"/>
+                <a16:creationId xmlns:a16="http://schemas.microsoft.com/office/drawing/2014/main" id="{A7EFEF95-9532-4040-8CA3-24A7D4DC237A}"/>
               </a:ext>
             </a:extLst>
           </p:cNvPr>
@@ -5903,7 +5903,7 @@
           <p:cNvPr id="3" name="">
             <a:extLst xmlns:a="http://schemas.openxmlformats.org/drawingml/2006/main">
               <a:ext uri="{FF2B5EF4-FFF2-40B4-BE49-F238E27FC236}">
-                <a16:creationId xmlns:a16="http://schemas.microsoft.com/office/drawing/2014/main" id="{D1765612-B461-4C8D-AD4A-6D7545318FE4}"/>
+                <a16:creationId xmlns:a16="http://schemas.microsoft.com/office/drawing/2014/main" id="{9E422F67-F541-44AA-A018-F7A407B19A92}"/>
               </a:ext>
             </a:extLst>
           </p:cNvPr>
@@ -5992,7 +5992,7 @@
           <p:cNvPr id="4" name="">
             <a:extLst xmlns:a="http://schemas.openxmlformats.org/drawingml/2006/main">
               <a:ext uri="{FF2B5EF4-FFF2-40B4-BE49-F238E27FC236}">
-                <a16:creationId xmlns:a16="http://schemas.microsoft.com/office/drawing/2014/main" id="{2AFB83D0-5AD4-4904-9283-7C7024274AF2}"/>
+                <a16:creationId xmlns:a16="http://schemas.microsoft.com/office/drawing/2014/main" id="{C810D2CA-4C8F-40BA-B699-4FA28E197FC7}"/>
               </a:ext>
             </a:extLst>
           </p:cNvPr>
@@ -6058,7 +6058,7 @@
           <p:cNvPr id="5" name="">
             <a:extLst xmlns:a="http://schemas.openxmlformats.org/drawingml/2006/main">
               <a:ext uri="{FF2B5EF4-FFF2-40B4-BE49-F238E27FC236}">
-                <a16:creationId xmlns:a16="http://schemas.microsoft.com/office/drawing/2014/main" id="{BB8AADA0-606A-4765-9AB4-E5679D657902}"/>
+                <a16:creationId xmlns:a16="http://schemas.microsoft.com/office/drawing/2014/main" id="{554C910A-45C1-4BA9-AD16-141F69B90599}"/>
               </a:ext>
             </a:extLst>
           </p:cNvPr>
@@ -6145,7 +6145,7 @@
     </p:spTree>
     <p:extLst>
       <p:ext uri="{BB962C8B-B14F-4D97-AF65-F5344CB8AC3E}">
-        <p14:creationId xmlns:p14="http://schemas.microsoft.com/office/powerpoint/2010/main" val="267604934"/>
+        <p14:creationId xmlns:p14="http://schemas.microsoft.com/office/powerpoint/2010/main" val="547702832"/>
       </p:ext>
     </p:extLst>
   </p:cSld>
@@ -6176,7 +6176,7 @@
           <p:cNvPr id="4" name="">
             <a:extLst xmlns:a="http://schemas.openxmlformats.org/drawingml/2006/main">
               <a:ext uri="{FF2B5EF4-FFF2-40B4-BE49-F238E27FC236}">
-                <a16:creationId xmlns:a16="http://schemas.microsoft.com/office/drawing/2014/main" id="{3296DC30-76B5-4E3B-A5BC-EAB2B245AB9B}"/>
+                <a16:creationId xmlns:a16="http://schemas.microsoft.com/office/drawing/2014/main" id="{ED0725BF-4C13-41B2-93D3-24CCDB3ABB70}"/>
               </a:ext>
             </a:extLst>
           </p:cNvPr>
@@ -6242,7 +6242,7 @@
           <p:cNvPr id="2" name="">
             <a:extLst xmlns:a="http://schemas.openxmlformats.org/drawingml/2006/main">
               <a:ext uri="{FF2B5EF4-FFF2-40B4-BE49-F238E27FC236}">
-                <a16:creationId xmlns:a16="http://schemas.microsoft.com/office/drawing/2014/main" id="{1D129130-16D7-4840-B038-AA1E93B43CBD}"/>
+                <a16:creationId xmlns:a16="http://schemas.microsoft.com/office/drawing/2014/main" id="{FAC7D85C-5931-489A-A150-6E68995EAA41}"/>
               </a:ext>
             </a:extLst>
           </p:cNvPr>
@@ -6308,7 +6308,7 @@
           <p:cNvPr id="3" name="">
             <a:extLst xmlns:a="http://schemas.openxmlformats.org/drawingml/2006/main">
               <a:ext uri="{FF2B5EF4-FFF2-40B4-BE49-F238E27FC236}">
-                <a16:creationId xmlns:a16="http://schemas.microsoft.com/office/drawing/2014/main" id="{874B7543-EA19-4640-BE72-476EF4FF0D34}"/>
+                <a16:creationId xmlns:a16="http://schemas.microsoft.com/office/drawing/2014/main" id="{4A0A2394-8603-4B65-A90D-600D9944AE57}"/>
               </a:ext>
             </a:extLst>
           </p:cNvPr>
@@ -6634,7 +6634,7 @@
     </p:spTree>
     <p:extLst>
       <p:ext uri="{BB962C8B-B14F-4D97-AF65-F5344CB8AC3E}">
-        <p14:creationId xmlns:p14="http://schemas.microsoft.com/office/powerpoint/2010/main" val="758618456"/>
+        <p14:creationId xmlns:p14="http://schemas.microsoft.com/office/powerpoint/2010/main" val="1087988805"/>
       </p:ext>
     </p:extLst>
   </p:cSld>
@@ -6665,7 +6665,7 @@
           <p:cNvPr id="5" name="">
             <a:extLst xmlns:a="http://schemas.openxmlformats.org/drawingml/2006/main">
               <a:ext uri="{FF2B5EF4-FFF2-40B4-BE49-F238E27FC236}">
-                <a16:creationId xmlns:a16="http://schemas.microsoft.com/office/drawing/2014/main" id="{2E840AAA-0B7A-4412-B640-C68006E0EA3E}"/>
+                <a16:creationId xmlns:a16="http://schemas.microsoft.com/office/drawing/2014/main" id="{40D9ED46-EC85-4E29-92FB-FDDF1F064BDB}"/>
               </a:ext>
             </a:extLst>
           </p:cNvPr>
@@ -6731,7 +6731,7 @@
           <p:cNvPr id="2" name="">
             <a:extLst xmlns:a="http://schemas.openxmlformats.org/drawingml/2006/main">
               <a:ext uri="{FF2B5EF4-FFF2-40B4-BE49-F238E27FC236}">
-                <a16:creationId xmlns:a16="http://schemas.microsoft.com/office/drawing/2014/main" id="{D1272EDF-4320-4D11-B895-FDF48833E5DB}"/>
+                <a16:creationId xmlns:a16="http://schemas.microsoft.com/office/drawing/2014/main" id="{69A4576C-E3CD-4E0D-9D05-2A269F99C638}"/>
               </a:ext>
             </a:extLst>
           </p:cNvPr>
@@ -6797,7 +6797,7 @@
           <p:cNvPr id="3" name="">
             <a:extLst xmlns:a="http://schemas.openxmlformats.org/drawingml/2006/main">
               <a:ext uri="{FF2B5EF4-FFF2-40B4-BE49-F238E27FC236}">
-                <a16:creationId xmlns:a16="http://schemas.microsoft.com/office/drawing/2014/main" id="{082CC478-788C-4DCD-80D0-F9E54227402F}"/>
+                <a16:creationId xmlns:a16="http://schemas.microsoft.com/office/drawing/2014/main" id="{66B75B10-EE55-4679-AC07-254E11B1EE26}"/>
               </a:ext>
             </a:extLst>
           </p:cNvPr>
@@ -7075,7 +7075,7 @@
           <p:cNvPr id="4" name="">
             <a:extLst xmlns:a="http://schemas.openxmlformats.org/drawingml/2006/main">
               <a:ext uri="{FF2B5EF4-FFF2-40B4-BE49-F238E27FC236}">
-                <a16:creationId xmlns:a16="http://schemas.microsoft.com/office/drawing/2014/main" id="{6961A65D-9EC2-43B6-8692-64885945D8A9}"/>
+                <a16:creationId xmlns:a16="http://schemas.microsoft.com/office/drawing/2014/main" id="{669EFEDE-B69A-4BEC-B28C-270868244DD4}"/>
               </a:ext>
             </a:extLst>
           </p:cNvPr>
@@ -7139,7 +7139,7 @@
     </p:spTree>
     <p:extLst>
       <p:ext uri="{BB962C8B-B14F-4D97-AF65-F5344CB8AC3E}">
-        <p14:creationId xmlns:p14="http://schemas.microsoft.com/office/powerpoint/2010/main" val="282749582"/>
+        <p14:creationId xmlns:p14="http://schemas.microsoft.com/office/powerpoint/2010/main" val="1774197682"/>
       </p:ext>
     </p:extLst>
   </p:cSld>
@@ -7170,7 +7170,7 @@
           <p:cNvPr id="7" name="">
             <a:extLst xmlns:a="http://schemas.openxmlformats.org/drawingml/2006/main">
               <a:ext uri="{FF2B5EF4-FFF2-40B4-BE49-F238E27FC236}">
-                <a16:creationId xmlns:a16="http://schemas.microsoft.com/office/drawing/2014/main" id="{6604213F-DB21-491B-9805-1142AD90F0E3}"/>
+                <a16:creationId xmlns:a16="http://schemas.microsoft.com/office/drawing/2014/main" id="{4D3A732F-3C95-48BF-8EE4-F2D58FB4A5C8}"/>
               </a:ext>
             </a:extLst>
           </p:cNvPr>
@@ -7236,7 +7236,7 @@
           <p:cNvPr id="2" name="">
             <a:extLst xmlns:a="http://schemas.openxmlformats.org/drawingml/2006/main">
               <a:ext uri="{FF2B5EF4-FFF2-40B4-BE49-F238E27FC236}">
-                <a16:creationId xmlns:a16="http://schemas.microsoft.com/office/drawing/2014/main" id="{68EBA814-4123-45D3-831A-3AE2E58804E5}"/>
+                <a16:creationId xmlns:a16="http://schemas.microsoft.com/office/drawing/2014/main" id="{AC40F984-6419-4F2E-A3A7-F65A4738642B}"/>
               </a:ext>
             </a:extLst>
           </p:cNvPr>
@@ -7302,7 +7302,7 @@
           <p:cNvPr id="3" name="">
             <a:extLst xmlns:a="http://schemas.openxmlformats.org/drawingml/2006/main">
               <a:ext uri="{FF2B5EF4-FFF2-40B4-BE49-F238E27FC236}">
-                <a16:creationId xmlns:a16="http://schemas.microsoft.com/office/drawing/2014/main" id="{04643F29-873D-4908-9963-93163F425462}"/>
+                <a16:creationId xmlns:a16="http://schemas.microsoft.com/office/drawing/2014/main" id="{1A1942DC-CF05-4460-9029-C87C99F77FD3}"/>
               </a:ext>
             </a:extLst>
           </p:cNvPr>
@@ -7368,7 +7368,7 @@
           <p:cNvPr id="4" name="">
             <a:extLst xmlns:a="http://schemas.openxmlformats.org/drawingml/2006/main">
               <a:ext uri="{FF2B5EF4-FFF2-40B4-BE49-F238E27FC236}">
-                <a16:creationId xmlns:a16="http://schemas.microsoft.com/office/drawing/2014/main" id="{A9188912-DCDA-44EA-BDA6-83203F01B2A3}"/>
+                <a16:creationId xmlns:a16="http://schemas.microsoft.com/office/drawing/2014/main" id="{7C40D4A2-45E2-4E44-A87F-5D653BDC2B16}"/>
               </a:ext>
             </a:extLst>
           </p:cNvPr>
@@ -7480,7 +7480,7 @@
           <p:cNvPr id="5" name="">
             <a:extLst xmlns:a="http://schemas.openxmlformats.org/drawingml/2006/main">
               <a:ext uri="{FF2B5EF4-FFF2-40B4-BE49-F238E27FC236}">
-                <a16:creationId xmlns:a16="http://schemas.microsoft.com/office/drawing/2014/main" id="{1E599176-35DB-47FA-A73C-A0411DA2E5DB}"/>
+                <a16:creationId xmlns:a16="http://schemas.microsoft.com/office/drawing/2014/main" id="{7511D013-9AD9-4118-98D0-874565138A4E}"/>
               </a:ext>
             </a:extLst>
           </p:cNvPr>
@@ -7569,7 +7569,7 @@
           <p:cNvPr id="6" name="">
             <a:extLst xmlns:a="http://schemas.openxmlformats.org/drawingml/2006/main">
               <a:ext uri="{FF2B5EF4-FFF2-40B4-BE49-F238E27FC236}">
-                <a16:creationId xmlns:a16="http://schemas.microsoft.com/office/drawing/2014/main" id="{97F21E24-A090-4E0B-81DC-AFC5022AECCE}"/>
+                <a16:creationId xmlns:a16="http://schemas.microsoft.com/office/drawing/2014/main" id="{AF60B599-CD24-4E25-A127-938DC9CC3038}"/>
               </a:ext>
             </a:extLst>
           </p:cNvPr>
@@ -7625,7 +7625,7 @@
                 <a:ea typeface="Arial"/>
                 <a:cs typeface="Arial"/>
               </a:rPr>
-              <a:t>Private repository: arrange assessor access or provide the source ZIP.</a:t>
+              <a:t>Public repository: source code and contribution history are accessible.</a:t>
             </a:r>
           </a:p>
         </p:txBody>
@@ -7633,7 +7633,7 @@
     </p:spTree>
     <p:extLst>
       <p:ext uri="{BB962C8B-B14F-4D97-AF65-F5344CB8AC3E}">
-        <p14:creationId xmlns:p14="http://schemas.microsoft.com/office/powerpoint/2010/main" val="1367804120"/>
+        <p14:creationId xmlns:p14="http://schemas.microsoft.com/office/powerpoint/2010/main" val="724485892"/>
       </p:ext>
     </p:extLst>
   </p:cSld>
@@ -7664,7 +7664,7 @@
           <p:cNvPr id="6" name="">
             <a:extLst xmlns:a="http://schemas.openxmlformats.org/drawingml/2006/main">
               <a:ext uri="{FF2B5EF4-FFF2-40B4-BE49-F238E27FC236}">
-                <a16:creationId xmlns:a16="http://schemas.microsoft.com/office/drawing/2014/main" id="{86455833-10CF-45BD-B163-02E2DB7E3EEC}"/>
+                <a16:creationId xmlns:a16="http://schemas.microsoft.com/office/drawing/2014/main" id="{1137ECF9-6CDC-4DEA-AD54-BCDC99109B4C}"/>
               </a:ext>
             </a:extLst>
           </p:cNvPr>
@@ -7730,7 +7730,7 @@
           <p:cNvPr id="2" name="">
             <a:extLst xmlns:a="http://schemas.openxmlformats.org/drawingml/2006/main">
               <a:ext uri="{FF2B5EF4-FFF2-40B4-BE49-F238E27FC236}">
-                <a16:creationId xmlns:a16="http://schemas.microsoft.com/office/drawing/2014/main" id="{C5E3A59B-1462-457B-80C6-319FBADEFB56}"/>
+                <a16:creationId xmlns:a16="http://schemas.microsoft.com/office/drawing/2014/main" id="{B6462613-2B2D-4649-AF7D-0CC81ADBE0A3}"/>
               </a:ext>
             </a:extLst>
           </p:cNvPr>
@@ -7796,7 +7796,7 @@
           <p:cNvPr id="3" name="">
             <a:extLst xmlns:a="http://schemas.openxmlformats.org/drawingml/2006/main">
               <a:ext uri="{FF2B5EF4-FFF2-40B4-BE49-F238E27FC236}">
-                <a16:creationId xmlns:a16="http://schemas.microsoft.com/office/drawing/2014/main" id="{DDBC2A47-38E1-4933-9E72-576098710FBA}"/>
+                <a16:creationId xmlns:a16="http://schemas.microsoft.com/office/drawing/2014/main" id="{821BCFF0-C9DF-4536-8A85-1E671361948C}"/>
               </a:ext>
             </a:extLst>
           </p:cNvPr>
@@ -7862,7 +7862,7 @@
           <p:cNvPr id="4" name="">
             <a:extLst xmlns:a="http://schemas.openxmlformats.org/drawingml/2006/main">
               <a:ext uri="{FF2B5EF4-FFF2-40B4-BE49-F238E27FC236}">
-                <a16:creationId xmlns:a16="http://schemas.microsoft.com/office/drawing/2014/main" id="{5EDBDDB5-BBB1-436B-9CBC-6BEAAB5132D0}"/>
+                <a16:creationId xmlns:a16="http://schemas.microsoft.com/office/drawing/2014/main" id="{D0AAD7D5-F348-407A-AE14-9F8407AAFFC8}"/>
               </a:ext>
             </a:extLst>
           </p:cNvPr>
@@ -8261,7 +8261,7 @@
           <p:cNvPr id="5" name="">
             <a:extLst xmlns:a="http://schemas.openxmlformats.org/drawingml/2006/main">
               <a:ext uri="{FF2B5EF4-FFF2-40B4-BE49-F238E27FC236}">
-                <a16:creationId xmlns:a16="http://schemas.microsoft.com/office/drawing/2014/main" id="{45775BDB-2D5D-472D-BA9A-A2D51558ABC9}"/>
+                <a16:creationId xmlns:a16="http://schemas.microsoft.com/office/drawing/2014/main" id="{04B8D09B-B52F-4BF6-81D4-C391988193AC}"/>
               </a:ext>
             </a:extLst>
           </p:cNvPr>
@@ -8325,7 +8325,7 @@
     </p:spTree>
     <p:extLst>
       <p:ext uri="{BB962C8B-B14F-4D97-AF65-F5344CB8AC3E}">
-        <p14:creationId xmlns:p14="http://schemas.microsoft.com/office/powerpoint/2010/main" val="267102355"/>
+        <p14:creationId xmlns:p14="http://schemas.microsoft.com/office/powerpoint/2010/main" val="112949998"/>
       </p:ext>
     </p:extLst>
   </p:cSld>
@@ -8356,7 +8356,7 @@
           <p:cNvPr id="4" name="">
             <a:extLst xmlns:a="http://schemas.openxmlformats.org/drawingml/2006/main">
               <a:ext uri="{FF2B5EF4-FFF2-40B4-BE49-F238E27FC236}">
-                <a16:creationId xmlns:a16="http://schemas.microsoft.com/office/drawing/2014/main" id="{1323AF9E-C8E1-4598-B326-19D2B610CF5C}"/>
+                <a16:creationId xmlns:a16="http://schemas.microsoft.com/office/drawing/2014/main" id="{3B23F519-ACC1-43D2-8F0B-946DD38232FA}"/>
               </a:ext>
             </a:extLst>
           </p:cNvPr>
@@ -8422,7 +8422,7 @@
           <p:cNvPr id="2" name="">
             <a:extLst xmlns:a="http://schemas.openxmlformats.org/drawingml/2006/main">
               <a:ext uri="{FF2B5EF4-FFF2-40B4-BE49-F238E27FC236}">
-                <a16:creationId xmlns:a16="http://schemas.microsoft.com/office/drawing/2014/main" id="{906499AF-5B75-4CDF-9CF4-CAE4A29F3C5E}"/>
+                <a16:creationId xmlns:a16="http://schemas.microsoft.com/office/drawing/2014/main" id="{106E10CC-728C-411B-BC5F-572B55CC37B5}"/>
               </a:ext>
             </a:extLst>
           </p:cNvPr>
@@ -8488,7 +8488,7 @@
           <p:cNvPr id="3" name="">
             <a:extLst xmlns:a="http://schemas.openxmlformats.org/drawingml/2006/main">
               <a:ext uri="{FF2B5EF4-FFF2-40B4-BE49-F238E27FC236}">
-                <a16:creationId xmlns:a16="http://schemas.microsoft.com/office/drawing/2014/main" id="{D48F032B-528F-4FA1-80ED-D55E42DA0866}"/>
+                <a16:creationId xmlns:a16="http://schemas.microsoft.com/office/drawing/2014/main" id="{99338077-604D-42B7-9E0D-6F987AEA43CA}"/>
               </a:ext>
             </a:extLst>
           </p:cNvPr>
@@ -8498,7 +8498,7 @@
           <p:nvPr/>
         </p:nvPicPr>
         <p:blipFill>
-          <a:blip xmlns:r="http://schemas.openxmlformats.org/officeDocument/2006/relationships" xmlns:a="http://schemas.openxmlformats.org/drawingml/2006/main" r:embed="R87e27e491f674b9d"/>
+          <a:blip xmlns:r="http://schemas.openxmlformats.org/officeDocument/2006/relationships" xmlns:a="http://schemas.openxmlformats.org/drawingml/2006/main" r:embed="R4f829fcbc2d24b06"/>
           <a:stretch xmlns:a="http://schemas.openxmlformats.org/drawingml/2006/main"/>
         </p:blipFill>
         <p:spPr>
@@ -8514,7 +8514,7 @@
     </p:spTree>
     <p:extLst>
       <p:ext uri="{BB962C8B-B14F-4D97-AF65-F5344CB8AC3E}">
-        <p14:creationId xmlns:p14="http://schemas.microsoft.com/office/powerpoint/2010/main" val="1145282952"/>
+        <p14:creationId xmlns:p14="http://schemas.microsoft.com/office/powerpoint/2010/main" val="2060427448"/>
       </p:ext>
     </p:extLst>
   </p:cSld>
@@ -8545,7 +8545,7 @@
           <p:cNvPr id="4" name="">
             <a:extLst xmlns:a="http://schemas.openxmlformats.org/drawingml/2006/main">
               <a:ext uri="{FF2B5EF4-FFF2-40B4-BE49-F238E27FC236}">
-                <a16:creationId xmlns:a16="http://schemas.microsoft.com/office/drawing/2014/main" id="{71116669-594C-4EC0-B60C-CD025521273B}"/>
+                <a16:creationId xmlns:a16="http://schemas.microsoft.com/office/drawing/2014/main" id="{6C977ADC-BE43-4B7E-B91F-4931457DF50B}"/>
               </a:ext>
             </a:extLst>
           </p:cNvPr>
@@ -8611,7 +8611,7 @@
           <p:cNvPr id="2" name="">
             <a:extLst xmlns:a="http://schemas.openxmlformats.org/drawingml/2006/main">
               <a:ext uri="{FF2B5EF4-FFF2-40B4-BE49-F238E27FC236}">
-                <a16:creationId xmlns:a16="http://schemas.microsoft.com/office/drawing/2014/main" id="{AFF06FC1-932F-482C-9882-6B1819D330F0}"/>
+                <a16:creationId xmlns:a16="http://schemas.microsoft.com/office/drawing/2014/main" id="{E8442D06-4BA9-4289-B898-C3E991E8094D}"/>
               </a:ext>
             </a:extLst>
           </p:cNvPr>
@@ -8677,7 +8677,7 @@
           <p:cNvPr id="3" name="">
             <a:extLst xmlns:a="http://schemas.openxmlformats.org/drawingml/2006/main">
               <a:ext uri="{FF2B5EF4-FFF2-40B4-BE49-F238E27FC236}">
-                <a16:creationId xmlns:a16="http://schemas.microsoft.com/office/drawing/2014/main" id="{9AFC25AE-3F76-4B10-8473-8CA9B2CFB1F6}"/>
+                <a16:creationId xmlns:a16="http://schemas.microsoft.com/office/drawing/2014/main" id="{E682898A-1F12-4E71-B5AA-FA63500C9DE9}"/>
               </a:ext>
             </a:extLst>
           </p:cNvPr>
@@ -8687,7 +8687,7 @@
           <p:nvPr/>
         </p:nvPicPr>
         <p:blipFill>
-          <a:blip xmlns:r="http://schemas.openxmlformats.org/officeDocument/2006/relationships" xmlns:a="http://schemas.openxmlformats.org/drawingml/2006/main" r:embed="Rce3041c29e96447d"/>
+          <a:blip xmlns:r="http://schemas.openxmlformats.org/officeDocument/2006/relationships" xmlns:a="http://schemas.openxmlformats.org/drawingml/2006/main" r:embed="R1284d3162df143bb"/>
           <a:stretch xmlns:a="http://schemas.openxmlformats.org/drawingml/2006/main"/>
         </p:blipFill>
         <p:spPr>
@@ -8703,7 +8703,7 @@
     </p:spTree>
     <p:extLst>
       <p:ext uri="{BB962C8B-B14F-4D97-AF65-F5344CB8AC3E}">
-        <p14:creationId xmlns:p14="http://schemas.microsoft.com/office/powerpoint/2010/main" val="273336503"/>
+        <p14:creationId xmlns:p14="http://schemas.microsoft.com/office/powerpoint/2010/main" val="1063482501"/>
       </p:ext>
     </p:extLst>
   </p:cSld>
@@ -8734,7 +8734,7 @@
           <p:cNvPr id="4" name="">
             <a:extLst xmlns:a="http://schemas.openxmlformats.org/drawingml/2006/main">
               <a:ext uri="{FF2B5EF4-FFF2-40B4-BE49-F238E27FC236}">
-                <a16:creationId xmlns:a16="http://schemas.microsoft.com/office/drawing/2014/main" id="{0ED6394C-7667-41B9-992C-4D5FFF7E897D}"/>
+                <a16:creationId xmlns:a16="http://schemas.microsoft.com/office/drawing/2014/main" id="{E2F626E5-D8CF-4B70-A3F1-9117133D5562}"/>
               </a:ext>
             </a:extLst>
           </p:cNvPr>
@@ -8800,7 +8800,7 @@
           <p:cNvPr id="2" name="">
             <a:extLst xmlns:a="http://schemas.openxmlformats.org/drawingml/2006/main">
               <a:ext uri="{FF2B5EF4-FFF2-40B4-BE49-F238E27FC236}">
-                <a16:creationId xmlns:a16="http://schemas.microsoft.com/office/drawing/2014/main" id="{06DA32B4-BAC0-4FB3-8E90-16CFBFCFF56F}"/>
+                <a16:creationId xmlns:a16="http://schemas.microsoft.com/office/drawing/2014/main" id="{6C490842-3543-4CC2-A974-CB37AF1E37DF}"/>
               </a:ext>
             </a:extLst>
           </p:cNvPr>
@@ -8866,7 +8866,7 @@
           <p:cNvPr id="3" name="">
             <a:extLst xmlns:a="http://schemas.openxmlformats.org/drawingml/2006/main">
               <a:ext uri="{FF2B5EF4-FFF2-40B4-BE49-F238E27FC236}">
-                <a16:creationId xmlns:a16="http://schemas.microsoft.com/office/drawing/2014/main" id="{69482C5C-A948-4414-90EC-6DE1B88FC7F1}"/>
+                <a16:creationId xmlns:a16="http://schemas.microsoft.com/office/drawing/2014/main" id="{96B370E7-821B-488C-865C-816ACBB1C651}"/>
               </a:ext>
             </a:extLst>
           </p:cNvPr>
@@ -8876,7 +8876,7 @@
           <p:nvPr/>
         </p:nvPicPr>
         <p:blipFill>
-          <a:blip xmlns:r="http://schemas.openxmlformats.org/officeDocument/2006/relationships" xmlns:a="http://schemas.openxmlformats.org/drawingml/2006/main" r:embed="Rc3f6d6b967c74c84"/>
+          <a:blip xmlns:r="http://schemas.openxmlformats.org/officeDocument/2006/relationships" xmlns:a="http://schemas.openxmlformats.org/drawingml/2006/main" r:embed="Rd39015293c2f46b7"/>
           <a:stretch xmlns:a="http://schemas.openxmlformats.org/drawingml/2006/main"/>
         </p:blipFill>
         <p:spPr>
@@ -8892,7 +8892,7 @@
     </p:spTree>
     <p:extLst>
       <p:ext uri="{BB962C8B-B14F-4D97-AF65-F5344CB8AC3E}">
-        <p14:creationId xmlns:p14="http://schemas.microsoft.com/office/powerpoint/2010/main" val="1695419233"/>
+        <p14:creationId xmlns:p14="http://schemas.microsoft.com/office/powerpoint/2010/main" val="1965633632"/>
       </p:ext>
     </p:extLst>
   </p:cSld>
@@ -8923,7 +8923,7 @@
           <p:cNvPr id="4" name="">
             <a:extLst xmlns:a="http://schemas.openxmlformats.org/drawingml/2006/main">
               <a:ext uri="{FF2B5EF4-FFF2-40B4-BE49-F238E27FC236}">
-                <a16:creationId xmlns:a16="http://schemas.microsoft.com/office/drawing/2014/main" id="{FFCE66BF-04A3-421C-96CD-711490BE8574}"/>
+                <a16:creationId xmlns:a16="http://schemas.microsoft.com/office/drawing/2014/main" id="{F97ECC5C-A8E6-4BB6-B761-789E9CE34FA4}"/>
               </a:ext>
             </a:extLst>
           </p:cNvPr>
@@ -8989,7 +8989,7 @@
           <p:cNvPr id="2" name="">
             <a:extLst xmlns:a="http://schemas.openxmlformats.org/drawingml/2006/main">
               <a:ext uri="{FF2B5EF4-FFF2-40B4-BE49-F238E27FC236}">
-                <a16:creationId xmlns:a16="http://schemas.microsoft.com/office/drawing/2014/main" id="{3606A252-C425-4131-B4BF-6F0D44FBD371}"/>
+                <a16:creationId xmlns:a16="http://schemas.microsoft.com/office/drawing/2014/main" id="{7F8C87B4-9891-4C95-86F7-5C910748FDA6}"/>
               </a:ext>
             </a:extLst>
           </p:cNvPr>
@@ -9055,7 +9055,7 @@
           <p:cNvPr id="3" name="">
             <a:extLst xmlns:a="http://schemas.openxmlformats.org/drawingml/2006/main">
               <a:ext uri="{FF2B5EF4-FFF2-40B4-BE49-F238E27FC236}">
-                <a16:creationId xmlns:a16="http://schemas.microsoft.com/office/drawing/2014/main" id="{5EF80752-0A46-4A4A-A0BB-4C5D31C224FE}"/>
+                <a16:creationId xmlns:a16="http://schemas.microsoft.com/office/drawing/2014/main" id="{B8DDE488-402F-4C28-9223-05564650C59E}"/>
               </a:ext>
             </a:extLst>
           </p:cNvPr>
@@ -9065,7 +9065,7 @@
           <p:nvPr/>
         </p:nvPicPr>
         <p:blipFill>
-          <a:blip xmlns:r="http://schemas.openxmlformats.org/officeDocument/2006/relationships" xmlns:a="http://schemas.openxmlformats.org/drawingml/2006/main" r:embed="R1dc5373e1cff4486"/>
+          <a:blip xmlns:r="http://schemas.openxmlformats.org/officeDocument/2006/relationships" xmlns:a="http://schemas.openxmlformats.org/drawingml/2006/main" r:embed="Re92afcfa1b0c4ee8"/>
           <a:stretch xmlns:a="http://schemas.openxmlformats.org/drawingml/2006/main"/>
         </p:blipFill>
         <p:spPr>
@@ -9081,7 +9081,7 @@
     </p:spTree>
     <p:extLst>
       <p:ext uri="{BB962C8B-B14F-4D97-AF65-F5344CB8AC3E}">
-        <p14:creationId xmlns:p14="http://schemas.microsoft.com/office/powerpoint/2010/main" val="820277130"/>
+        <p14:creationId xmlns:p14="http://schemas.microsoft.com/office/powerpoint/2010/main" val="1901831797"/>
       </p:ext>
     </p:extLst>
   </p:cSld>
@@ -9112,7 +9112,7 @@
           <p:cNvPr id="4" name="">
             <a:extLst xmlns:a="http://schemas.openxmlformats.org/drawingml/2006/main">
               <a:ext uri="{FF2B5EF4-FFF2-40B4-BE49-F238E27FC236}">
-                <a16:creationId xmlns:a16="http://schemas.microsoft.com/office/drawing/2014/main" id="{F70C1916-B49E-44BF-9A1A-A920AF6DCC47}"/>
+                <a16:creationId xmlns:a16="http://schemas.microsoft.com/office/drawing/2014/main" id="{8D517A40-78E6-455D-B1E6-2A53C30354E5}"/>
               </a:ext>
             </a:extLst>
           </p:cNvPr>
@@ -9178,7 +9178,7 @@
           <p:cNvPr id="2" name="">
             <a:extLst xmlns:a="http://schemas.openxmlformats.org/drawingml/2006/main">
               <a:ext uri="{FF2B5EF4-FFF2-40B4-BE49-F238E27FC236}">
-                <a16:creationId xmlns:a16="http://schemas.microsoft.com/office/drawing/2014/main" id="{4E3B06C7-EC5E-41A5-B0CD-4DB25B3AB4D1}"/>
+                <a16:creationId xmlns:a16="http://schemas.microsoft.com/office/drawing/2014/main" id="{FE489CDC-3085-472F-A489-5C373A7327F9}"/>
               </a:ext>
             </a:extLst>
           </p:cNvPr>
@@ -9244,7 +9244,7 @@
           <p:cNvPr id="3" name="">
             <a:extLst xmlns:a="http://schemas.openxmlformats.org/drawingml/2006/main">
               <a:ext uri="{FF2B5EF4-FFF2-40B4-BE49-F238E27FC236}">
-                <a16:creationId xmlns:a16="http://schemas.microsoft.com/office/drawing/2014/main" id="{B9C8FD83-0F81-4BE0-BFD1-E624038028A5}"/>
+                <a16:creationId xmlns:a16="http://schemas.microsoft.com/office/drawing/2014/main" id="{E9A658A7-E507-4F7E-8F98-EF54E271E663}"/>
               </a:ext>
             </a:extLst>
           </p:cNvPr>
@@ -9254,7 +9254,7 @@
           <p:nvPr/>
         </p:nvPicPr>
         <p:blipFill>
-          <a:blip xmlns:r="http://schemas.openxmlformats.org/officeDocument/2006/relationships" xmlns:a="http://schemas.openxmlformats.org/drawingml/2006/main" r:embed="R327d6743fc7e4d64"/>
+          <a:blip xmlns:r="http://schemas.openxmlformats.org/officeDocument/2006/relationships" xmlns:a="http://schemas.openxmlformats.org/drawingml/2006/main" r:embed="R5c8c652bae904467"/>
           <a:stretch xmlns:a="http://schemas.openxmlformats.org/drawingml/2006/main"/>
         </p:blipFill>
         <p:spPr>
@@ -9270,7 +9270,7 @@
     </p:spTree>
     <p:extLst>
       <p:ext uri="{BB962C8B-B14F-4D97-AF65-F5344CB8AC3E}">
-        <p14:creationId xmlns:p14="http://schemas.microsoft.com/office/powerpoint/2010/main" val="1937676620"/>
+        <p14:creationId xmlns:p14="http://schemas.microsoft.com/office/powerpoint/2010/main" val="733498719"/>
       </p:ext>
     </p:extLst>
   </p:cSld>
@@ -9301,7 +9301,7 @@
           <p:cNvPr id="5" name="">
             <a:extLst xmlns:a="http://schemas.openxmlformats.org/drawingml/2006/main">
               <a:ext uri="{FF2B5EF4-FFF2-40B4-BE49-F238E27FC236}">
-                <a16:creationId xmlns:a16="http://schemas.microsoft.com/office/drawing/2014/main" id="{9B3EC46A-1B4A-4DD9-9391-FEA30D39DB7F}"/>
+                <a16:creationId xmlns:a16="http://schemas.microsoft.com/office/drawing/2014/main" id="{28A65407-9A9A-4499-AD3C-FDBDAE6382F3}"/>
               </a:ext>
             </a:extLst>
           </p:cNvPr>
@@ -9367,7 +9367,7 @@
           <p:cNvPr id="2" name="">
             <a:extLst xmlns:a="http://schemas.openxmlformats.org/drawingml/2006/main">
               <a:ext uri="{FF2B5EF4-FFF2-40B4-BE49-F238E27FC236}">
-                <a16:creationId xmlns:a16="http://schemas.microsoft.com/office/drawing/2014/main" id="{7A89DDAB-9900-40E5-9E21-2B40CF6FC3D7}"/>
+                <a16:creationId xmlns:a16="http://schemas.microsoft.com/office/drawing/2014/main" id="{98868D13-58F5-4677-86FC-355900E63A70}"/>
               </a:ext>
             </a:extLst>
           </p:cNvPr>
@@ -9433,7 +9433,7 @@
           <p:cNvPr id="3" name="">
             <a:extLst xmlns:a="http://schemas.openxmlformats.org/drawingml/2006/main">
               <a:ext uri="{FF2B5EF4-FFF2-40B4-BE49-F238E27FC236}">
-                <a16:creationId xmlns:a16="http://schemas.microsoft.com/office/drawing/2014/main" id="{5CAE1380-9E14-4692-B0BB-E5EB4B318119}"/>
+                <a16:creationId xmlns:a16="http://schemas.microsoft.com/office/drawing/2014/main" id="{BFB1332F-6439-4C31-8D05-8FD0097790A7}"/>
               </a:ext>
             </a:extLst>
           </p:cNvPr>
@@ -9711,7 +9711,7 @@
           <p:cNvPr id="4" name="">
             <a:extLst xmlns:a="http://schemas.openxmlformats.org/drawingml/2006/main">
               <a:ext uri="{FF2B5EF4-FFF2-40B4-BE49-F238E27FC236}">
-                <a16:creationId xmlns:a16="http://schemas.microsoft.com/office/drawing/2014/main" id="{6614335B-D3A1-4FBF-8579-30CEED9DC136}"/>
+                <a16:creationId xmlns:a16="http://schemas.microsoft.com/office/drawing/2014/main" id="{579F12F4-10D9-4B52-BB7C-566207FE7F7F}"/>
               </a:ext>
             </a:extLst>
           </p:cNvPr>
@@ -9775,7 +9775,7 @@
     </p:spTree>
     <p:extLst>
       <p:ext uri="{BB962C8B-B14F-4D97-AF65-F5344CB8AC3E}">
-        <p14:creationId xmlns:p14="http://schemas.microsoft.com/office/powerpoint/2010/main" val="2069192816"/>
+        <p14:creationId xmlns:p14="http://schemas.microsoft.com/office/powerpoint/2010/main" val="323585427"/>
       </p:ext>
     </p:extLst>
   </p:cSld>
@@ -9806,7 +9806,7 @@
           <p:cNvPr id="8" name="">
             <a:extLst xmlns:a="http://schemas.openxmlformats.org/drawingml/2006/main">
               <a:ext uri="{FF2B5EF4-FFF2-40B4-BE49-F238E27FC236}">
-                <a16:creationId xmlns:a16="http://schemas.microsoft.com/office/drawing/2014/main" id="{4FFE2501-59B0-4A82-BCAD-441A99C75594}"/>
+                <a16:creationId xmlns:a16="http://schemas.microsoft.com/office/drawing/2014/main" id="{EF902AB2-1ED0-411E-AFC0-C521B2338209}"/>
               </a:ext>
             </a:extLst>
           </p:cNvPr>
@@ -9872,7 +9872,7 @@
           <p:cNvPr id="2" name="">
             <a:extLst xmlns:a="http://schemas.openxmlformats.org/drawingml/2006/main">
               <a:ext uri="{FF2B5EF4-FFF2-40B4-BE49-F238E27FC236}">
-                <a16:creationId xmlns:a16="http://schemas.microsoft.com/office/drawing/2014/main" id="{417494E7-D7C2-444C-A143-4A0DCF2E2BD7}"/>
+                <a16:creationId xmlns:a16="http://schemas.microsoft.com/office/drawing/2014/main" id="{A88F5FF6-8E77-4997-B638-851326EAAD6F}"/>
               </a:ext>
             </a:extLst>
           </p:cNvPr>
@@ -9938,7 +9938,7 @@
           <p:cNvPr id="3" name="Chart">
             <a:extLst xmlns:a="http://schemas.openxmlformats.org/drawingml/2006/main">
               <a:ext uri="{FF2B5EF4-FFF2-40B4-BE49-F238E27FC236}">
-                <a16:creationId xmlns:a16="http://schemas.microsoft.com/office/drawing/2014/main" id="{CE64D9C6-E6EB-46A8-BFC5-A71AEC105DF5}"/>
+                <a16:creationId xmlns:a16="http://schemas.microsoft.com/office/drawing/2014/main" id="{B3304E44-B74F-4B0D-B577-9512D9F0B905}"/>
               </a:ext>
             </a:extLst>
           </p:cNvPr>
@@ -9951,7 +9951,7 @@
         </p:xfrm>
         <a:graphic xmlns:a="http://schemas.openxmlformats.org/drawingml/2006/main">
           <a:graphicData uri="http://schemas.openxmlformats.org/drawingml/2006/chart">
-            <c:chart xmlns:r="http://schemas.openxmlformats.org/officeDocument/2006/relationships" xmlns:c="http://schemas.openxmlformats.org/drawingml/2006/chart" r:id="Rd4d73446b8e742bb"/>
+            <c:chart xmlns:r="http://schemas.openxmlformats.org/officeDocument/2006/relationships" xmlns:c="http://schemas.openxmlformats.org/drawingml/2006/chart" r:id="R1b6134dcca054da0"/>
           </a:graphicData>
         </a:graphic>
       </p:graphicFrame>
@@ -9960,7 +9960,7 @@
           <p:cNvPr id="4" name="">
             <a:extLst xmlns:a="http://schemas.openxmlformats.org/drawingml/2006/main">
               <a:ext uri="{FF2B5EF4-FFF2-40B4-BE49-F238E27FC236}">
-                <a16:creationId xmlns:a16="http://schemas.microsoft.com/office/drawing/2014/main" id="{FD45E6AF-1C9A-44B2-92B1-970DE6E15424}"/>
+                <a16:creationId xmlns:a16="http://schemas.microsoft.com/office/drawing/2014/main" id="{49EC08B6-3E5B-4C37-A7DD-134549F9CC45}"/>
               </a:ext>
             </a:extLst>
           </p:cNvPr>
@@ -10026,7 +10026,7 @@
           <p:cNvPr id="5" name="">
             <a:extLst xmlns:a="http://schemas.openxmlformats.org/drawingml/2006/main">
               <a:ext uri="{FF2B5EF4-FFF2-40B4-BE49-F238E27FC236}">
-                <a16:creationId xmlns:a16="http://schemas.microsoft.com/office/drawing/2014/main" id="{5E744B6B-DC8D-4900-BC2F-D6989694E1E2}"/>
+                <a16:creationId xmlns:a16="http://schemas.microsoft.com/office/drawing/2014/main" id="{DA8EDBC4-D19C-405A-8847-FFB3217405E1}"/>
               </a:ext>
             </a:extLst>
           </p:cNvPr>
@@ -10138,7 +10138,7 @@
           <p:cNvPr id="6" name="">
             <a:extLst xmlns:a="http://schemas.openxmlformats.org/drawingml/2006/main">
               <a:ext uri="{FF2B5EF4-FFF2-40B4-BE49-F238E27FC236}">
-                <a16:creationId xmlns:a16="http://schemas.microsoft.com/office/drawing/2014/main" id="{243CAAF0-6652-434F-995E-C2D6295B98A0}"/>
+                <a16:creationId xmlns:a16="http://schemas.microsoft.com/office/drawing/2014/main" id="{9776E638-2928-4583-AD52-AA0BEF400674}"/>
               </a:ext>
             </a:extLst>
           </p:cNvPr>
@@ -10227,7 +10227,7 @@
           <p:cNvPr id="7" name="">
             <a:extLst xmlns:a="http://schemas.openxmlformats.org/drawingml/2006/main">
               <a:ext uri="{FF2B5EF4-FFF2-40B4-BE49-F238E27FC236}">
-                <a16:creationId xmlns:a16="http://schemas.microsoft.com/office/drawing/2014/main" id="{063AB8B8-B338-4130-A638-7235AC69C17B}"/>
+                <a16:creationId xmlns:a16="http://schemas.microsoft.com/office/drawing/2014/main" id="{9EB99D40-62AB-489B-A382-8601167081D4}"/>
               </a:ext>
             </a:extLst>
           </p:cNvPr>
@@ -10291,7 +10291,7 @@
     </p:spTree>
     <p:extLst>
       <p:ext uri="{BB962C8B-B14F-4D97-AF65-F5344CB8AC3E}">
-        <p14:creationId xmlns:p14="http://schemas.microsoft.com/office/powerpoint/2010/main" val="2059476196"/>
+        <p14:creationId xmlns:p14="http://schemas.microsoft.com/office/powerpoint/2010/main" val="1891562127"/>
       </p:ext>
     </p:extLst>
   </p:cSld>

</xml_diff>

<commit_message>
Remove demonstration duration label from presentation and video opening
</commit_message>
<xml_diff>
--- a/submission/AlphaVault-Presentation.pptx
+++ b/submission/AlphaVault-Presentation.pptx
@@ -2,24 +2,24 @@
 <file path=ppt/presentation.xml><?xml version="1.0" encoding="utf-8"?>
 <p:presentation xmlns:p="http://schemas.openxmlformats.org/presentationml/2006/main">
   <p:sldMasterIdLst>
-    <p:sldMasterId xmlns:r="http://schemas.openxmlformats.org/officeDocument/2006/relationships" id="2147483648" r:id="R4d3d154819f94cd3"/>
+    <p:sldMasterId xmlns:r="http://schemas.openxmlformats.org/officeDocument/2006/relationships" id="2147483648" r:id="R609d156055d64dfa"/>
   </p:sldMasterIdLst>
   <p:notesMasterIdLst>
-    <p:notesMasterId xmlns:r="http://schemas.openxmlformats.org/officeDocument/2006/relationships" r:id="R7633797fe63045f9"/>
+    <p:notesMasterId xmlns:r="http://schemas.openxmlformats.org/officeDocument/2006/relationships" r:id="Rbbc84ff9878e439f"/>
   </p:notesMasterIdLst>
   <p:sldIdLst>
-    <p:sldId xmlns:r="http://schemas.openxmlformats.org/officeDocument/2006/relationships" id="256" r:id="R34ee6d8936e541eb"/>
-    <p:sldId xmlns:r="http://schemas.openxmlformats.org/officeDocument/2006/relationships" id="257" r:id="Rf622a2ce1dda4853"/>
-    <p:sldId xmlns:r="http://schemas.openxmlformats.org/officeDocument/2006/relationships" id="258" r:id="R2d6377340a7844d7"/>
-    <p:sldId xmlns:r="http://schemas.openxmlformats.org/officeDocument/2006/relationships" id="259" r:id="R955e607e30d24ea4"/>
-    <p:sldId xmlns:r="http://schemas.openxmlformats.org/officeDocument/2006/relationships" id="260" r:id="R4ab07de2eb734eec"/>
-    <p:sldId xmlns:r="http://schemas.openxmlformats.org/officeDocument/2006/relationships" id="261" r:id="R596f287c33f847b7"/>
-    <p:sldId xmlns:r="http://schemas.openxmlformats.org/officeDocument/2006/relationships" id="262" r:id="R30a88f7fdad04ff6"/>
-    <p:sldId xmlns:r="http://schemas.openxmlformats.org/officeDocument/2006/relationships" id="263" r:id="R61c85e0deea544d1"/>
-    <p:sldId xmlns:r="http://schemas.openxmlformats.org/officeDocument/2006/relationships" id="264" r:id="R0486eae28b0445b8"/>
-    <p:sldId xmlns:r="http://schemas.openxmlformats.org/officeDocument/2006/relationships" id="265" r:id="R33391cd129674e27"/>
-    <p:sldId xmlns:r="http://schemas.openxmlformats.org/officeDocument/2006/relationships" id="266" r:id="R8cb8460dd3ef466d"/>
-    <p:sldId xmlns:r="http://schemas.openxmlformats.org/officeDocument/2006/relationships" id="267" r:id="Rb387f8e8ec62482d"/>
+    <p:sldId xmlns:r="http://schemas.openxmlformats.org/officeDocument/2006/relationships" id="256" r:id="Rc05baf8aadb8411f"/>
+    <p:sldId xmlns:r="http://schemas.openxmlformats.org/officeDocument/2006/relationships" id="257" r:id="R2f73189136e14807"/>
+    <p:sldId xmlns:r="http://schemas.openxmlformats.org/officeDocument/2006/relationships" id="258" r:id="R7947501dc2a14026"/>
+    <p:sldId xmlns:r="http://schemas.openxmlformats.org/officeDocument/2006/relationships" id="259" r:id="Rb618d6ebffc94973"/>
+    <p:sldId xmlns:r="http://schemas.openxmlformats.org/officeDocument/2006/relationships" id="260" r:id="R8e5bd2ae9fe04050"/>
+    <p:sldId xmlns:r="http://schemas.openxmlformats.org/officeDocument/2006/relationships" id="261" r:id="Rea04d83747764b83"/>
+    <p:sldId xmlns:r="http://schemas.openxmlformats.org/officeDocument/2006/relationships" id="262" r:id="R2f8d8c5304354e64"/>
+    <p:sldId xmlns:r="http://schemas.openxmlformats.org/officeDocument/2006/relationships" id="263" r:id="Rf5363a246863449b"/>
+    <p:sldId xmlns:r="http://schemas.openxmlformats.org/officeDocument/2006/relationships" id="264" r:id="R551a99692fa049bd"/>
+    <p:sldId xmlns:r="http://schemas.openxmlformats.org/officeDocument/2006/relationships" id="265" r:id="R006f49c2e5c44ee5"/>
+    <p:sldId xmlns:r="http://schemas.openxmlformats.org/officeDocument/2006/relationships" id="266" r:id="R23efde10454e4636"/>
+    <p:sldId xmlns:r="http://schemas.openxmlformats.org/officeDocument/2006/relationships" id="267" r:id="R74c4d260c744490f"/>
   </p:sldIdLst>
   <p:sldSz cx="12192000" cy="6858000"/>
   <p:notesSz cx="6858000" cy="9144000"/>
@@ -1330,7 +1330,7 @@
           <p:cNvPr id="3" name="Title">
             <a:extLst xmlns:a="http://schemas.openxmlformats.org/drawingml/2006/main">
               <a:ext uri="{FF2B5EF4-FFF2-40B4-BE49-F238E27FC236}">
-                <a16:creationId xmlns:a16="http://schemas.microsoft.com/office/drawing/2014/main" id="{DC6729F1-B238-4EAB-B5C0-D9513F57776E}"/>
+                <a16:creationId xmlns:a16="http://schemas.microsoft.com/office/drawing/2014/main" id="{B5E7D587-1C68-4D6A-981C-4964C81F2C2F}"/>
               </a:ext>
             </a:extLst>
           </p:cNvPr>
@@ -1487,7 +1487,7 @@
           <p:cNvPr id="2" name="Subtitle">
             <a:extLst xmlns:a="http://schemas.openxmlformats.org/drawingml/2006/main">
               <a:ext uri="{FF2B5EF4-FFF2-40B4-BE49-F238E27FC236}">
-                <a16:creationId xmlns:a16="http://schemas.microsoft.com/office/drawing/2014/main" id="{ECAD22F5-9169-4FA5-9BF8-B2F7C3F09076}"/>
+                <a16:creationId xmlns:a16="http://schemas.microsoft.com/office/drawing/2014/main" id="{251CF352-4A0C-4F24-B4E2-A6AE5EB12549}"/>
               </a:ext>
             </a:extLst>
           </p:cNvPr>
@@ -1661,7 +1661,7 @@
           <p:cNvPr id="2" name="Section title">
             <a:extLst xmlns:a="http://schemas.openxmlformats.org/drawingml/2006/main">
               <a:ext uri="{FF2B5EF4-FFF2-40B4-BE49-F238E27FC236}">
-                <a16:creationId xmlns:a16="http://schemas.microsoft.com/office/drawing/2014/main" id="{72F6C952-BE07-4644-A26A-FA2DFCEAE99C}"/>
+                <a16:creationId xmlns:a16="http://schemas.microsoft.com/office/drawing/2014/main" id="{88816E27-5A4D-4F3B-BC3E-4C1F924BDC48}"/>
               </a:ext>
             </a:extLst>
           </p:cNvPr>
@@ -1835,7 +1835,7 @@
           <p:cNvPr id="3" name="Title">
             <a:extLst xmlns:a="http://schemas.openxmlformats.org/drawingml/2006/main">
               <a:ext uri="{FF2B5EF4-FFF2-40B4-BE49-F238E27FC236}">
-                <a16:creationId xmlns:a16="http://schemas.microsoft.com/office/drawing/2014/main" id="{57E36E3B-C7A4-4B64-A1CC-FB04CB540177}"/>
+                <a16:creationId xmlns:a16="http://schemas.microsoft.com/office/drawing/2014/main" id="{3BE13B4F-217F-4592-9FD2-A9A1B23A053D}"/>
               </a:ext>
             </a:extLst>
           </p:cNvPr>
@@ -1992,7 +1992,7 @@
           <p:cNvPr id="2" name="Body">
             <a:extLst xmlns:a="http://schemas.openxmlformats.org/drawingml/2006/main">
               <a:ext uri="{FF2B5EF4-FFF2-40B4-BE49-F238E27FC236}">
-                <a16:creationId xmlns:a16="http://schemas.microsoft.com/office/drawing/2014/main" id="{22999E9B-22A1-42F0-8C16-CC72A516CA2F}"/>
+                <a16:creationId xmlns:a16="http://schemas.microsoft.com/office/drawing/2014/main" id="{ABEB5F58-C70A-482F-A979-C1082DB6AB95}"/>
               </a:ext>
             </a:extLst>
           </p:cNvPr>
@@ -2166,7 +2166,7 @@
           <p:cNvPr id="4" name="Title">
             <a:extLst xmlns:a="http://schemas.openxmlformats.org/drawingml/2006/main">
               <a:ext uri="{FF2B5EF4-FFF2-40B4-BE49-F238E27FC236}">
-                <a16:creationId xmlns:a16="http://schemas.microsoft.com/office/drawing/2014/main" id="{D07EA27B-A04B-4755-9996-1A53151CD943}"/>
+                <a16:creationId xmlns:a16="http://schemas.microsoft.com/office/drawing/2014/main" id="{A5AA1548-9770-4FA1-8538-B4C419EAEF58}"/>
               </a:ext>
             </a:extLst>
           </p:cNvPr>
@@ -2323,7 +2323,7 @@
           <p:cNvPr id="2" name="Left column">
             <a:extLst xmlns:a="http://schemas.openxmlformats.org/drawingml/2006/main">
               <a:ext uri="{FF2B5EF4-FFF2-40B4-BE49-F238E27FC236}">
-                <a16:creationId xmlns:a16="http://schemas.microsoft.com/office/drawing/2014/main" id="{3D5027CC-D9BB-492A-8569-A8BE5175FD84}"/>
+                <a16:creationId xmlns:a16="http://schemas.microsoft.com/office/drawing/2014/main" id="{B6820C06-C09B-43C4-BA64-1BFC11043113}"/>
               </a:ext>
             </a:extLst>
           </p:cNvPr>
@@ -2480,7 +2480,7 @@
           <p:cNvPr id="3" name="Right column">
             <a:extLst xmlns:a="http://schemas.openxmlformats.org/drawingml/2006/main">
               <a:ext uri="{FF2B5EF4-FFF2-40B4-BE49-F238E27FC236}">
-                <a16:creationId xmlns:a16="http://schemas.microsoft.com/office/drawing/2014/main" id="{7D5650A0-E0A2-4C16-A6E3-8F2E57D28444}"/>
+                <a16:creationId xmlns:a16="http://schemas.microsoft.com/office/drawing/2014/main" id="{75965FCD-895B-4B86-87C3-E479FB858832}"/>
               </a:ext>
             </a:extLst>
           </p:cNvPr>
@@ -2654,7 +2654,7 @@
           <p:cNvPr id="3" name="Title">
             <a:extLst xmlns:a="http://schemas.openxmlformats.org/drawingml/2006/main">
               <a:ext uri="{FF2B5EF4-FFF2-40B4-BE49-F238E27FC236}">
-                <a16:creationId xmlns:a16="http://schemas.microsoft.com/office/drawing/2014/main" id="{DD938C23-2A31-4131-9EF1-802C583F594B}"/>
+                <a16:creationId xmlns:a16="http://schemas.microsoft.com/office/drawing/2014/main" id="{4B6EC008-8520-423A-BD53-6FBF79D02AAA}"/>
               </a:ext>
             </a:extLst>
           </p:cNvPr>
@@ -2811,7 +2811,7 @@
           <p:cNvPr id="2" name="Left column">
             <a:extLst xmlns:a="http://schemas.openxmlformats.org/drawingml/2006/main">
               <a:ext uri="{FF2B5EF4-FFF2-40B4-BE49-F238E27FC236}">
-                <a16:creationId xmlns:a16="http://schemas.microsoft.com/office/drawing/2014/main" id="{866E9B17-126B-4793-B297-CE4B05D9D73F}"/>
+                <a16:creationId xmlns:a16="http://schemas.microsoft.com/office/drawing/2014/main" id="{018AAA3E-DC5A-4D1C-BE01-FA6777DE1438}"/>
               </a:ext>
             </a:extLst>
           </p:cNvPr>
@@ -3006,12 +3006,12 @@
   </p:cSld>
   <p:clrMap bg1="lt1" tx1="dk1" bg2="lt2" tx2="dk2" accent1="accent1" accent2="accent2" accent3="accent3" accent4="accent4" accent5="accent5" accent6="accent6" hlink="hlink" folHlink="folHlink"/>
   <p:sldLayoutIdLst>
-    <p:sldLayoutId xmlns:r="http://schemas.openxmlformats.org/officeDocument/2006/relationships" id="2147483649" r:id="R10b2d90a032c4c5d"/>
-    <p:sldLayoutId xmlns:r="http://schemas.openxmlformats.org/officeDocument/2006/relationships" id="2147483650" r:id="R9694ddf139ac498a"/>
-    <p:sldLayoutId xmlns:r="http://schemas.openxmlformats.org/officeDocument/2006/relationships" id="2147483651" r:id="Ra16a9d3efc51409e"/>
-    <p:sldLayoutId xmlns:r="http://schemas.openxmlformats.org/officeDocument/2006/relationships" id="2147483652" r:id="Re703a2dd755c4f4b"/>
-    <p:sldLayoutId xmlns:r="http://schemas.openxmlformats.org/officeDocument/2006/relationships" id="2147483653" r:id="Rd600115218164805"/>
-    <p:sldLayoutId xmlns:r="http://schemas.openxmlformats.org/officeDocument/2006/relationships" id="2147483654" r:id="R3bea4adc9cb64e77"/>
+    <p:sldLayoutId xmlns:r="http://schemas.openxmlformats.org/officeDocument/2006/relationships" id="2147483649" r:id="R574a24bf91354821"/>
+    <p:sldLayoutId xmlns:r="http://schemas.openxmlformats.org/officeDocument/2006/relationships" id="2147483650" r:id="R9e29d66b16834e1a"/>
+    <p:sldLayoutId xmlns:r="http://schemas.openxmlformats.org/officeDocument/2006/relationships" id="2147483651" r:id="Rb7f5fa4cb24f439a"/>
+    <p:sldLayoutId xmlns:r="http://schemas.openxmlformats.org/officeDocument/2006/relationships" id="2147483652" r:id="R48f32a2f06674395"/>
+    <p:sldLayoutId xmlns:r="http://schemas.openxmlformats.org/officeDocument/2006/relationships" id="2147483653" r:id="Rd83ed97b59fd4521"/>
+    <p:sldLayoutId xmlns:r="http://schemas.openxmlformats.org/officeDocument/2006/relationships" id="2147483654" r:id="R9a921f819d034631"/>
   </p:sldLayoutIdLst>
   <p:txStyles>
     <p:titleStyle>
@@ -5771,7 +5771,7 @@
           <p:cNvPr id="6" name="">
             <a:extLst xmlns:a="http://schemas.openxmlformats.org/drawingml/2006/main">
               <a:ext uri="{FF2B5EF4-FFF2-40B4-BE49-F238E27FC236}">
-                <a16:creationId xmlns:a16="http://schemas.microsoft.com/office/drawing/2014/main" id="{E4A1AE86-F336-4033-BABA-96A204513821}"/>
+                <a16:creationId xmlns:a16="http://schemas.microsoft.com/office/drawing/2014/main" id="{FA07DF03-45C4-4D56-8004-4107CD4B7288}"/>
               </a:ext>
             </a:extLst>
           </p:cNvPr>
@@ -5837,7 +5837,7 @@
           <p:cNvPr id="2" name="">
             <a:extLst xmlns:a="http://schemas.openxmlformats.org/drawingml/2006/main">
               <a:ext uri="{FF2B5EF4-FFF2-40B4-BE49-F238E27FC236}">
-                <a16:creationId xmlns:a16="http://schemas.microsoft.com/office/drawing/2014/main" id="{A7EFEF95-9532-4040-8CA3-24A7D4DC237A}"/>
+                <a16:creationId xmlns:a16="http://schemas.microsoft.com/office/drawing/2014/main" id="{58337263-B639-4CBA-A558-44CBB3B398B4}"/>
               </a:ext>
             </a:extLst>
           </p:cNvPr>
@@ -5903,7 +5903,7 @@
           <p:cNvPr id="3" name="">
             <a:extLst xmlns:a="http://schemas.openxmlformats.org/drawingml/2006/main">
               <a:ext uri="{FF2B5EF4-FFF2-40B4-BE49-F238E27FC236}">
-                <a16:creationId xmlns:a16="http://schemas.microsoft.com/office/drawing/2014/main" id="{9E422F67-F541-44AA-A018-F7A407B19A92}"/>
+                <a16:creationId xmlns:a16="http://schemas.microsoft.com/office/drawing/2014/main" id="{01E2B7B0-F77C-45F3-B1B4-E470F452EDFC}"/>
               </a:ext>
             </a:extLst>
           </p:cNvPr>
@@ -5992,7 +5992,7 @@
           <p:cNvPr id="4" name="">
             <a:extLst xmlns:a="http://schemas.openxmlformats.org/drawingml/2006/main">
               <a:ext uri="{FF2B5EF4-FFF2-40B4-BE49-F238E27FC236}">
-                <a16:creationId xmlns:a16="http://schemas.microsoft.com/office/drawing/2014/main" id="{C810D2CA-4C8F-40BA-B699-4FA28E197FC7}"/>
+                <a16:creationId xmlns:a16="http://schemas.microsoft.com/office/drawing/2014/main" id="{2AEBD797-55AB-4B2F-BF97-5D4E1EDDA80B}"/>
               </a:ext>
             </a:extLst>
           </p:cNvPr>
@@ -6058,7 +6058,7 @@
           <p:cNvPr id="5" name="">
             <a:extLst xmlns:a="http://schemas.openxmlformats.org/drawingml/2006/main">
               <a:ext uri="{FF2B5EF4-FFF2-40B4-BE49-F238E27FC236}">
-                <a16:creationId xmlns:a16="http://schemas.microsoft.com/office/drawing/2014/main" id="{554C910A-45C1-4BA9-AD16-141F69B90599}"/>
+                <a16:creationId xmlns:a16="http://schemas.microsoft.com/office/drawing/2014/main" id="{9CA01499-12F1-484C-B9CD-4A8E9E211D44}"/>
               </a:ext>
             </a:extLst>
           </p:cNvPr>
@@ -6117,35 +6117,12 @@
               <a:t>Du zhuotong  |  SC6113</a:t>
             </a:r>
           </a:p>
-          <a:p xmlns:a="http://schemas.openxmlformats.org/drawingml/2006/main">
-            <a:pPr>
-              <a:defRPr sz="2100" b="0">
-                <a:solidFill>
-                  <a:srgbClr val="173F50"/>
-                </a:solidFill>
-                <a:latin typeface="Arial"/>
-                <a:ea typeface="Arial"/>
-                <a:cs typeface="Arial"/>
-              </a:defRPr>
-            </a:pPr>
-            <a:r>
-              <a:rPr sz="2100" b="0">
-                <a:solidFill>
-                  <a:srgbClr val="173F50"/>
-                </a:solidFill>
-                <a:latin typeface="Arial"/>
-                <a:ea typeface="Arial"/>
-                <a:cs typeface="Arial"/>
-              </a:rPr>
-              <a:t>Ten-minute project demonstration</a:t>
-            </a:r>
-          </a:p>
         </p:txBody>
       </p:sp>
     </p:spTree>
     <p:extLst>
       <p:ext uri="{BB962C8B-B14F-4D97-AF65-F5344CB8AC3E}">
-        <p14:creationId xmlns:p14="http://schemas.microsoft.com/office/powerpoint/2010/main" val="547702832"/>
+        <p14:creationId xmlns:p14="http://schemas.microsoft.com/office/powerpoint/2010/main" val="716744108"/>
       </p:ext>
     </p:extLst>
   </p:cSld>
@@ -6176,7 +6153,7 @@
           <p:cNvPr id="4" name="">
             <a:extLst xmlns:a="http://schemas.openxmlformats.org/drawingml/2006/main">
               <a:ext uri="{FF2B5EF4-FFF2-40B4-BE49-F238E27FC236}">
-                <a16:creationId xmlns:a16="http://schemas.microsoft.com/office/drawing/2014/main" id="{ED0725BF-4C13-41B2-93D3-24CCDB3ABB70}"/>
+                <a16:creationId xmlns:a16="http://schemas.microsoft.com/office/drawing/2014/main" id="{376662A6-48E4-4251-9329-E576257AB1F5}"/>
               </a:ext>
             </a:extLst>
           </p:cNvPr>
@@ -6242,7 +6219,7 @@
           <p:cNvPr id="2" name="">
             <a:extLst xmlns:a="http://schemas.openxmlformats.org/drawingml/2006/main">
               <a:ext uri="{FF2B5EF4-FFF2-40B4-BE49-F238E27FC236}">
-                <a16:creationId xmlns:a16="http://schemas.microsoft.com/office/drawing/2014/main" id="{FAC7D85C-5931-489A-A150-6E68995EAA41}"/>
+                <a16:creationId xmlns:a16="http://schemas.microsoft.com/office/drawing/2014/main" id="{365367DA-8A36-4598-A965-7ACCA2F7C12B}"/>
               </a:ext>
             </a:extLst>
           </p:cNvPr>
@@ -6308,7 +6285,7 @@
           <p:cNvPr id="3" name="">
             <a:extLst xmlns:a="http://schemas.openxmlformats.org/drawingml/2006/main">
               <a:ext uri="{FF2B5EF4-FFF2-40B4-BE49-F238E27FC236}">
-                <a16:creationId xmlns:a16="http://schemas.microsoft.com/office/drawing/2014/main" id="{4A0A2394-8603-4B65-A90D-600D9944AE57}"/>
+                <a16:creationId xmlns:a16="http://schemas.microsoft.com/office/drawing/2014/main" id="{5D4F5C1E-1CA8-4D4B-9E70-B65E2E11E7E6}"/>
               </a:ext>
             </a:extLst>
           </p:cNvPr>
@@ -6634,7 +6611,7 @@
     </p:spTree>
     <p:extLst>
       <p:ext uri="{BB962C8B-B14F-4D97-AF65-F5344CB8AC3E}">
-        <p14:creationId xmlns:p14="http://schemas.microsoft.com/office/powerpoint/2010/main" val="1087988805"/>
+        <p14:creationId xmlns:p14="http://schemas.microsoft.com/office/powerpoint/2010/main" val="2118534275"/>
       </p:ext>
     </p:extLst>
   </p:cSld>
@@ -6665,7 +6642,7 @@
           <p:cNvPr id="5" name="">
             <a:extLst xmlns:a="http://schemas.openxmlformats.org/drawingml/2006/main">
               <a:ext uri="{FF2B5EF4-FFF2-40B4-BE49-F238E27FC236}">
-                <a16:creationId xmlns:a16="http://schemas.microsoft.com/office/drawing/2014/main" id="{40D9ED46-EC85-4E29-92FB-FDDF1F064BDB}"/>
+                <a16:creationId xmlns:a16="http://schemas.microsoft.com/office/drawing/2014/main" id="{13AB003C-960C-416F-9EB4-3DD1E8B42CBB}"/>
               </a:ext>
             </a:extLst>
           </p:cNvPr>
@@ -6731,7 +6708,7 @@
           <p:cNvPr id="2" name="">
             <a:extLst xmlns:a="http://schemas.openxmlformats.org/drawingml/2006/main">
               <a:ext uri="{FF2B5EF4-FFF2-40B4-BE49-F238E27FC236}">
-                <a16:creationId xmlns:a16="http://schemas.microsoft.com/office/drawing/2014/main" id="{69A4576C-E3CD-4E0D-9D05-2A269F99C638}"/>
+                <a16:creationId xmlns:a16="http://schemas.microsoft.com/office/drawing/2014/main" id="{AB747BF9-A620-4E7A-96CB-A6D9EEDF92C8}"/>
               </a:ext>
             </a:extLst>
           </p:cNvPr>
@@ -6797,7 +6774,7 @@
           <p:cNvPr id="3" name="">
             <a:extLst xmlns:a="http://schemas.openxmlformats.org/drawingml/2006/main">
               <a:ext uri="{FF2B5EF4-FFF2-40B4-BE49-F238E27FC236}">
-                <a16:creationId xmlns:a16="http://schemas.microsoft.com/office/drawing/2014/main" id="{66B75B10-EE55-4679-AC07-254E11B1EE26}"/>
+                <a16:creationId xmlns:a16="http://schemas.microsoft.com/office/drawing/2014/main" id="{1430A4ED-BD32-410C-B5A8-D843ACAE2A44}"/>
               </a:ext>
             </a:extLst>
           </p:cNvPr>
@@ -7075,7 +7052,7 @@
           <p:cNvPr id="4" name="">
             <a:extLst xmlns:a="http://schemas.openxmlformats.org/drawingml/2006/main">
               <a:ext uri="{FF2B5EF4-FFF2-40B4-BE49-F238E27FC236}">
-                <a16:creationId xmlns:a16="http://schemas.microsoft.com/office/drawing/2014/main" id="{669EFEDE-B69A-4BEC-B28C-270868244DD4}"/>
+                <a16:creationId xmlns:a16="http://schemas.microsoft.com/office/drawing/2014/main" id="{FAD78490-9152-4A4D-8A11-5E26A4AEB88D}"/>
               </a:ext>
             </a:extLst>
           </p:cNvPr>
@@ -7139,7 +7116,7 @@
     </p:spTree>
     <p:extLst>
       <p:ext uri="{BB962C8B-B14F-4D97-AF65-F5344CB8AC3E}">
-        <p14:creationId xmlns:p14="http://schemas.microsoft.com/office/powerpoint/2010/main" val="1774197682"/>
+        <p14:creationId xmlns:p14="http://schemas.microsoft.com/office/powerpoint/2010/main" val="2118817506"/>
       </p:ext>
     </p:extLst>
   </p:cSld>
@@ -7170,7 +7147,7 @@
           <p:cNvPr id="7" name="">
             <a:extLst xmlns:a="http://schemas.openxmlformats.org/drawingml/2006/main">
               <a:ext uri="{FF2B5EF4-FFF2-40B4-BE49-F238E27FC236}">
-                <a16:creationId xmlns:a16="http://schemas.microsoft.com/office/drawing/2014/main" id="{4D3A732F-3C95-48BF-8EE4-F2D58FB4A5C8}"/>
+                <a16:creationId xmlns:a16="http://schemas.microsoft.com/office/drawing/2014/main" id="{1FF62769-75A3-447B-BFA9-D97F5FB18D6E}"/>
               </a:ext>
             </a:extLst>
           </p:cNvPr>
@@ -7236,7 +7213,7 @@
           <p:cNvPr id="2" name="">
             <a:extLst xmlns:a="http://schemas.openxmlformats.org/drawingml/2006/main">
               <a:ext uri="{FF2B5EF4-FFF2-40B4-BE49-F238E27FC236}">
-                <a16:creationId xmlns:a16="http://schemas.microsoft.com/office/drawing/2014/main" id="{AC40F984-6419-4F2E-A3A7-F65A4738642B}"/>
+                <a16:creationId xmlns:a16="http://schemas.microsoft.com/office/drawing/2014/main" id="{159BF2E5-5C8C-484F-AFE7-E8BA3DABA9BA}"/>
               </a:ext>
             </a:extLst>
           </p:cNvPr>
@@ -7302,7 +7279,7 @@
           <p:cNvPr id="3" name="">
             <a:extLst xmlns:a="http://schemas.openxmlformats.org/drawingml/2006/main">
               <a:ext uri="{FF2B5EF4-FFF2-40B4-BE49-F238E27FC236}">
-                <a16:creationId xmlns:a16="http://schemas.microsoft.com/office/drawing/2014/main" id="{1A1942DC-CF05-4460-9029-C87C99F77FD3}"/>
+                <a16:creationId xmlns:a16="http://schemas.microsoft.com/office/drawing/2014/main" id="{6CFFBAA9-90EE-4393-9EFA-F446A6312245}"/>
               </a:ext>
             </a:extLst>
           </p:cNvPr>
@@ -7368,7 +7345,7 @@
           <p:cNvPr id="4" name="">
             <a:extLst xmlns:a="http://schemas.openxmlformats.org/drawingml/2006/main">
               <a:ext uri="{FF2B5EF4-FFF2-40B4-BE49-F238E27FC236}">
-                <a16:creationId xmlns:a16="http://schemas.microsoft.com/office/drawing/2014/main" id="{7C40D4A2-45E2-4E44-A87F-5D653BDC2B16}"/>
+                <a16:creationId xmlns:a16="http://schemas.microsoft.com/office/drawing/2014/main" id="{929C84EE-E440-4BD3-AAC3-85270F61AA92}"/>
               </a:ext>
             </a:extLst>
           </p:cNvPr>
@@ -7480,7 +7457,7 @@
           <p:cNvPr id="5" name="">
             <a:extLst xmlns:a="http://schemas.openxmlformats.org/drawingml/2006/main">
               <a:ext uri="{FF2B5EF4-FFF2-40B4-BE49-F238E27FC236}">
-                <a16:creationId xmlns:a16="http://schemas.microsoft.com/office/drawing/2014/main" id="{7511D013-9AD9-4118-98D0-874565138A4E}"/>
+                <a16:creationId xmlns:a16="http://schemas.microsoft.com/office/drawing/2014/main" id="{86D3133E-D3AC-4B70-B35D-B8B2CBFFBEB2}"/>
               </a:ext>
             </a:extLst>
           </p:cNvPr>
@@ -7569,7 +7546,7 @@
           <p:cNvPr id="6" name="">
             <a:extLst xmlns:a="http://schemas.openxmlformats.org/drawingml/2006/main">
               <a:ext uri="{FF2B5EF4-FFF2-40B4-BE49-F238E27FC236}">
-                <a16:creationId xmlns:a16="http://schemas.microsoft.com/office/drawing/2014/main" id="{AF60B599-CD24-4E25-A127-938DC9CC3038}"/>
+                <a16:creationId xmlns:a16="http://schemas.microsoft.com/office/drawing/2014/main" id="{3306AEB2-1F10-4225-832B-69B0A8382F7A}"/>
               </a:ext>
             </a:extLst>
           </p:cNvPr>
@@ -7633,7 +7610,7 @@
     </p:spTree>
     <p:extLst>
       <p:ext uri="{BB962C8B-B14F-4D97-AF65-F5344CB8AC3E}">
-        <p14:creationId xmlns:p14="http://schemas.microsoft.com/office/powerpoint/2010/main" val="724485892"/>
+        <p14:creationId xmlns:p14="http://schemas.microsoft.com/office/powerpoint/2010/main" val="2109374202"/>
       </p:ext>
     </p:extLst>
   </p:cSld>
@@ -7664,7 +7641,7 @@
           <p:cNvPr id="6" name="">
             <a:extLst xmlns:a="http://schemas.openxmlformats.org/drawingml/2006/main">
               <a:ext uri="{FF2B5EF4-FFF2-40B4-BE49-F238E27FC236}">
-                <a16:creationId xmlns:a16="http://schemas.microsoft.com/office/drawing/2014/main" id="{1137ECF9-6CDC-4DEA-AD54-BCDC99109B4C}"/>
+                <a16:creationId xmlns:a16="http://schemas.microsoft.com/office/drawing/2014/main" id="{B607A217-EF57-4F81-A82E-0C7A8E40BB0F}"/>
               </a:ext>
             </a:extLst>
           </p:cNvPr>
@@ -7730,7 +7707,7 @@
           <p:cNvPr id="2" name="">
             <a:extLst xmlns:a="http://schemas.openxmlformats.org/drawingml/2006/main">
               <a:ext uri="{FF2B5EF4-FFF2-40B4-BE49-F238E27FC236}">
-                <a16:creationId xmlns:a16="http://schemas.microsoft.com/office/drawing/2014/main" id="{B6462613-2B2D-4649-AF7D-0CC81ADBE0A3}"/>
+                <a16:creationId xmlns:a16="http://schemas.microsoft.com/office/drawing/2014/main" id="{7A5B61CC-EC38-4969-BF3E-B9ED74DBD1D6}"/>
               </a:ext>
             </a:extLst>
           </p:cNvPr>
@@ -7796,7 +7773,7 @@
           <p:cNvPr id="3" name="">
             <a:extLst xmlns:a="http://schemas.openxmlformats.org/drawingml/2006/main">
               <a:ext uri="{FF2B5EF4-FFF2-40B4-BE49-F238E27FC236}">
-                <a16:creationId xmlns:a16="http://schemas.microsoft.com/office/drawing/2014/main" id="{821BCFF0-C9DF-4536-8A85-1E671361948C}"/>
+                <a16:creationId xmlns:a16="http://schemas.microsoft.com/office/drawing/2014/main" id="{2D54F241-BB2A-4A12-BC9E-D58F480EFE9F}"/>
               </a:ext>
             </a:extLst>
           </p:cNvPr>
@@ -7862,7 +7839,7 @@
           <p:cNvPr id="4" name="">
             <a:extLst xmlns:a="http://schemas.openxmlformats.org/drawingml/2006/main">
               <a:ext uri="{FF2B5EF4-FFF2-40B4-BE49-F238E27FC236}">
-                <a16:creationId xmlns:a16="http://schemas.microsoft.com/office/drawing/2014/main" id="{D0AAD7D5-F348-407A-AE14-9F8407AAFFC8}"/>
+                <a16:creationId xmlns:a16="http://schemas.microsoft.com/office/drawing/2014/main" id="{F89E3A2B-5D58-420D-8A44-9C81017C9354}"/>
               </a:ext>
             </a:extLst>
           </p:cNvPr>
@@ -8261,7 +8238,7 @@
           <p:cNvPr id="5" name="">
             <a:extLst xmlns:a="http://schemas.openxmlformats.org/drawingml/2006/main">
               <a:ext uri="{FF2B5EF4-FFF2-40B4-BE49-F238E27FC236}">
-                <a16:creationId xmlns:a16="http://schemas.microsoft.com/office/drawing/2014/main" id="{04B8D09B-B52F-4BF6-81D4-C391988193AC}"/>
+                <a16:creationId xmlns:a16="http://schemas.microsoft.com/office/drawing/2014/main" id="{A61A8D73-7E10-4915-BF97-74623B960D6F}"/>
               </a:ext>
             </a:extLst>
           </p:cNvPr>
@@ -8325,7 +8302,7 @@
     </p:spTree>
     <p:extLst>
       <p:ext uri="{BB962C8B-B14F-4D97-AF65-F5344CB8AC3E}">
-        <p14:creationId xmlns:p14="http://schemas.microsoft.com/office/powerpoint/2010/main" val="112949998"/>
+        <p14:creationId xmlns:p14="http://schemas.microsoft.com/office/powerpoint/2010/main" val="2133195321"/>
       </p:ext>
     </p:extLst>
   </p:cSld>
@@ -8356,7 +8333,7 @@
           <p:cNvPr id="4" name="">
             <a:extLst xmlns:a="http://schemas.openxmlformats.org/drawingml/2006/main">
               <a:ext uri="{FF2B5EF4-FFF2-40B4-BE49-F238E27FC236}">
-                <a16:creationId xmlns:a16="http://schemas.microsoft.com/office/drawing/2014/main" id="{3B23F519-ACC1-43D2-8F0B-946DD38232FA}"/>
+                <a16:creationId xmlns:a16="http://schemas.microsoft.com/office/drawing/2014/main" id="{CA846238-02FA-44A9-934A-5CEA4833196F}"/>
               </a:ext>
             </a:extLst>
           </p:cNvPr>
@@ -8422,7 +8399,7 @@
           <p:cNvPr id="2" name="">
             <a:extLst xmlns:a="http://schemas.openxmlformats.org/drawingml/2006/main">
               <a:ext uri="{FF2B5EF4-FFF2-40B4-BE49-F238E27FC236}">
-                <a16:creationId xmlns:a16="http://schemas.microsoft.com/office/drawing/2014/main" id="{106E10CC-728C-411B-BC5F-572B55CC37B5}"/>
+                <a16:creationId xmlns:a16="http://schemas.microsoft.com/office/drawing/2014/main" id="{4E5966B3-44FF-44B9-B88E-F69424C1F0CA}"/>
               </a:ext>
             </a:extLst>
           </p:cNvPr>
@@ -8488,7 +8465,7 @@
           <p:cNvPr id="3" name="">
             <a:extLst xmlns:a="http://schemas.openxmlformats.org/drawingml/2006/main">
               <a:ext uri="{FF2B5EF4-FFF2-40B4-BE49-F238E27FC236}">
-                <a16:creationId xmlns:a16="http://schemas.microsoft.com/office/drawing/2014/main" id="{99338077-604D-42B7-9E0D-6F987AEA43CA}"/>
+                <a16:creationId xmlns:a16="http://schemas.microsoft.com/office/drawing/2014/main" id="{A73CFBFC-89AC-4E02-B594-DF5721A17A02}"/>
               </a:ext>
             </a:extLst>
           </p:cNvPr>
@@ -8498,7 +8475,7 @@
           <p:nvPr/>
         </p:nvPicPr>
         <p:blipFill>
-          <a:blip xmlns:r="http://schemas.openxmlformats.org/officeDocument/2006/relationships" xmlns:a="http://schemas.openxmlformats.org/drawingml/2006/main" r:embed="R4f829fcbc2d24b06"/>
+          <a:blip xmlns:r="http://schemas.openxmlformats.org/officeDocument/2006/relationships" xmlns:a="http://schemas.openxmlformats.org/drawingml/2006/main" r:embed="Rf4be8d3056bb43c8"/>
           <a:stretch xmlns:a="http://schemas.openxmlformats.org/drawingml/2006/main"/>
         </p:blipFill>
         <p:spPr>
@@ -8514,7 +8491,7 @@
     </p:spTree>
     <p:extLst>
       <p:ext uri="{BB962C8B-B14F-4D97-AF65-F5344CB8AC3E}">
-        <p14:creationId xmlns:p14="http://schemas.microsoft.com/office/powerpoint/2010/main" val="2060427448"/>
+        <p14:creationId xmlns:p14="http://schemas.microsoft.com/office/powerpoint/2010/main" val="1549362706"/>
       </p:ext>
     </p:extLst>
   </p:cSld>
@@ -8545,7 +8522,7 @@
           <p:cNvPr id="4" name="">
             <a:extLst xmlns:a="http://schemas.openxmlformats.org/drawingml/2006/main">
               <a:ext uri="{FF2B5EF4-FFF2-40B4-BE49-F238E27FC236}">
-                <a16:creationId xmlns:a16="http://schemas.microsoft.com/office/drawing/2014/main" id="{6C977ADC-BE43-4B7E-B91F-4931457DF50B}"/>
+                <a16:creationId xmlns:a16="http://schemas.microsoft.com/office/drawing/2014/main" id="{695579E5-5F21-468D-8B11-010C6EE0222F}"/>
               </a:ext>
             </a:extLst>
           </p:cNvPr>
@@ -8611,7 +8588,7 @@
           <p:cNvPr id="2" name="">
             <a:extLst xmlns:a="http://schemas.openxmlformats.org/drawingml/2006/main">
               <a:ext uri="{FF2B5EF4-FFF2-40B4-BE49-F238E27FC236}">
-                <a16:creationId xmlns:a16="http://schemas.microsoft.com/office/drawing/2014/main" id="{E8442D06-4BA9-4289-B898-C3E991E8094D}"/>
+                <a16:creationId xmlns:a16="http://schemas.microsoft.com/office/drawing/2014/main" id="{9DBD8525-DF91-4417-8D26-7DC150061606}"/>
               </a:ext>
             </a:extLst>
           </p:cNvPr>
@@ -8677,7 +8654,7 @@
           <p:cNvPr id="3" name="">
             <a:extLst xmlns:a="http://schemas.openxmlformats.org/drawingml/2006/main">
               <a:ext uri="{FF2B5EF4-FFF2-40B4-BE49-F238E27FC236}">
-                <a16:creationId xmlns:a16="http://schemas.microsoft.com/office/drawing/2014/main" id="{E682898A-1F12-4E71-B5AA-FA63500C9DE9}"/>
+                <a16:creationId xmlns:a16="http://schemas.microsoft.com/office/drawing/2014/main" id="{596BB8E3-1E82-4D93-8DF8-EFC26ADD66B6}"/>
               </a:ext>
             </a:extLst>
           </p:cNvPr>
@@ -8687,7 +8664,7 @@
           <p:nvPr/>
         </p:nvPicPr>
         <p:blipFill>
-          <a:blip xmlns:r="http://schemas.openxmlformats.org/officeDocument/2006/relationships" xmlns:a="http://schemas.openxmlformats.org/drawingml/2006/main" r:embed="R1284d3162df143bb"/>
+          <a:blip xmlns:r="http://schemas.openxmlformats.org/officeDocument/2006/relationships" xmlns:a="http://schemas.openxmlformats.org/drawingml/2006/main" r:embed="Rea0675274145406f"/>
           <a:stretch xmlns:a="http://schemas.openxmlformats.org/drawingml/2006/main"/>
         </p:blipFill>
         <p:spPr>
@@ -8703,7 +8680,7 @@
     </p:spTree>
     <p:extLst>
       <p:ext uri="{BB962C8B-B14F-4D97-AF65-F5344CB8AC3E}">
-        <p14:creationId xmlns:p14="http://schemas.microsoft.com/office/powerpoint/2010/main" val="1063482501"/>
+        <p14:creationId xmlns:p14="http://schemas.microsoft.com/office/powerpoint/2010/main" val="579562243"/>
       </p:ext>
     </p:extLst>
   </p:cSld>
@@ -8734,7 +8711,7 @@
           <p:cNvPr id="4" name="">
             <a:extLst xmlns:a="http://schemas.openxmlformats.org/drawingml/2006/main">
               <a:ext uri="{FF2B5EF4-FFF2-40B4-BE49-F238E27FC236}">
-                <a16:creationId xmlns:a16="http://schemas.microsoft.com/office/drawing/2014/main" id="{E2F626E5-D8CF-4B70-A3F1-9117133D5562}"/>
+                <a16:creationId xmlns:a16="http://schemas.microsoft.com/office/drawing/2014/main" id="{FEC4B659-2D22-40FE-B7BD-976D1A2A4251}"/>
               </a:ext>
             </a:extLst>
           </p:cNvPr>
@@ -8800,7 +8777,7 @@
           <p:cNvPr id="2" name="">
             <a:extLst xmlns:a="http://schemas.openxmlformats.org/drawingml/2006/main">
               <a:ext uri="{FF2B5EF4-FFF2-40B4-BE49-F238E27FC236}">
-                <a16:creationId xmlns:a16="http://schemas.microsoft.com/office/drawing/2014/main" id="{6C490842-3543-4CC2-A974-CB37AF1E37DF}"/>
+                <a16:creationId xmlns:a16="http://schemas.microsoft.com/office/drawing/2014/main" id="{1A65C9F7-5DE8-4093-A834-7B7C87267D42}"/>
               </a:ext>
             </a:extLst>
           </p:cNvPr>
@@ -8866,7 +8843,7 @@
           <p:cNvPr id="3" name="">
             <a:extLst xmlns:a="http://schemas.openxmlformats.org/drawingml/2006/main">
               <a:ext uri="{FF2B5EF4-FFF2-40B4-BE49-F238E27FC236}">
-                <a16:creationId xmlns:a16="http://schemas.microsoft.com/office/drawing/2014/main" id="{96B370E7-821B-488C-865C-816ACBB1C651}"/>
+                <a16:creationId xmlns:a16="http://schemas.microsoft.com/office/drawing/2014/main" id="{F5E9F3D8-74F1-4908-9C19-8A5B50707EF2}"/>
               </a:ext>
             </a:extLst>
           </p:cNvPr>
@@ -8876,7 +8853,7 @@
           <p:nvPr/>
         </p:nvPicPr>
         <p:blipFill>
-          <a:blip xmlns:r="http://schemas.openxmlformats.org/officeDocument/2006/relationships" xmlns:a="http://schemas.openxmlformats.org/drawingml/2006/main" r:embed="Rd39015293c2f46b7"/>
+          <a:blip xmlns:r="http://schemas.openxmlformats.org/officeDocument/2006/relationships" xmlns:a="http://schemas.openxmlformats.org/drawingml/2006/main" r:embed="Rb738d4e2f8314c9e"/>
           <a:stretch xmlns:a="http://schemas.openxmlformats.org/drawingml/2006/main"/>
         </p:blipFill>
         <p:spPr>
@@ -8892,7 +8869,7 @@
     </p:spTree>
     <p:extLst>
       <p:ext uri="{BB962C8B-B14F-4D97-AF65-F5344CB8AC3E}">
-        <p14:creationId xmlns:p14="http://schemas.microsoft.com/office/powerpoint/2010/main" val="1965633632"/>
+        <p14:creationId xmlns:p14="http://schemas.microsoft.com/office/powerpoint/2010/main" val="642832048"/>
       </p:ext>
     </p:extLst>
   </p:cSld>
@@ -8923,7 +8900,7 @@
           <p:cNvPr id="4" name="">
             <a:extLst xmlns:a="http://schemas.openxmlformats.org/drawingml/2006/main">
               <a:ext uri="{FF2B5EF4-FFF2-40B4-BE49-F238E27FC236}">
-                <a16:creationId xmlns:a16="http://schemas.microsoft.com/office/drawing/2014/main" id="{F97ECC5C-A8E6-4BB6-B761-789E9CE34FA4}"/>
+                <a16:creationId xmlns:a16="http://schemas.microsoft.com/office/drawing/2014/main" id="{E448EAD9-201C-4C83-A00A-A464B53E6D67}"/>
               </a:ext>
             </a:extLst>
           </p:cNvPr>
@@ -8989,7 +8966,7 @@
           <p:cNvPr id="2" name="">
             <a:extLst xmlns:a="http://schemas.openxmlformats.org/drawingml/2006/main">
               <a:ext uri="{FF2B5EF4-FFF2-40B4-BE49-F238E27FC236}">
-                <a16:creationId xmlns:a16="http://schemas.microsoft.com/office/drawing/2014/main" id="{7F8C87B4-9891-4C95-86F7-5C910748FDA6}"/>
+                <a16:creationId xmlns:a16="http://schemas.microsoft.com/office/drawing/2014/main" id="{81357DD9-05F4-484D-9EEB-A931FE15B3BB}"/>
               </a:ext>
             </a:extLst>
           </p:cNvPr>
@@ -9055,7 +9032,7 @@
           <p:cNvPr id="3" name="">
             <a:extLst xmlns:a="http://schemas.openxmlformats.org/drawingml/2006/main">
               <a:ext uri="{FF2B5EF4-FFF2-40B4-BE49-F238E27FC236}">
-                <a16:creationId xmlns:a16="http://schemas.microsoft.com/office/drawing/2014/main" id="{B8DDE488-402F-4C28-9223-05564650C59E}"/>
+                <a16:creationId xmlns:a16="http://schemas.microsoft.com/office/drawing/2014/main" id="{4F0B614A-3811-4FEB-A2DA-AAB71FFE6515}"/>
               </a:ext>
             </a:extLst>
           </p:cNvPr>
@@ -9065,7 +9042,7 @@
           <p:nvPr/>
         </p:nvPicPr>
         <p:blipFill>
-          <a:blip xmlns:r="http://schemas.openxmlformats.org/officeDocument/2006/relationships" xmlns:a="http://schemas.openxmlformats.org/drawingml/2006/main" r:embed="Re92afcfa1b0c4ee8"/>
+          <a:blip xmlns:r="http://schemas.openxmlformats.org/officeDocument/2006/relationships" xmlns:a="http://schemas.openxmlformats.org/drawingml/2006/main" r:embed="R5caaa120b1da4f32"/>
           <a:stretch xmlns:a="http://schemas.openxmlformats.org/drawingml/2006/main"/>
         </p:blipFill>
         <p:spPr>
@@ -9081,7 +9058,7 @@
     </p:spTree>
     <p:extLst>
       <p:ext uri="{BB962C8B-B14F-4D97-AF65-F5344CB8AC3E}">
-        <p14:creationId xmlns:p14="http://schemas.microsoft.com/office/powerpoint/2010/main" val="1901831797"/>
+        <p14:creationId xmlns:p14="http://schemas.microsoft.com/office/powerpoint/2010/main" val="1902113514"/>
       </p:ext>
     </p:extLst>
   </p:cSld>
@@ -9112,7 +9089,7 @@
           <p:cNvPr id="4" name="">
             <a:extLst xmlns:a="http://schemas.openxmlformats.org/drawingml/2006/main">
               <a:ext uri="{FF2B5EF4-FFF2-40B4-BE49-F238E27FC236}">
-                <a16:creationId xmlns:a16="http://schemas.microsoft.com/office/drawing/2014/main" id="{8D517A40-78E6-455D-B1E6-2A53C30354E5}"/>
+                <a16:creationId xmlns:a16="http://schemas.microsoft.com/office/drawing/2014/main" id="{37390D7D-9B4F-4668-86E1-895F91C5B30F}"/>
               </a:ext>
             </a:extLst>
           </p:cNvPr>
@@ -9178,7 +9155,7 @@
           <p:cNvPr id="2" name="">
             <a:extLst xmlns:a="http://schemas.openxmlformats.org/drawingml/2006/main">
               <a:ext uri="{FF2B5EF4-FFF2-40B4-BE49-F238E27FC236}">
-                <a16:creationId xmlns:a16="http://schemas.microsoft.com/office/drawing/2014/main" id="{FE489CDC-3085-472F-A489-5C373A7327F9}"/>
+                <a16:creationId xmlns:a16="http://schemas.microsoft.com/office/drawing/2014/main" id="{9E1215D9-D31C-4F2D-90A0-0CA45F887C49}"/>
               </a:ext>
             </a:extLst>
           </p:cNvPr>
@@ -9244,7 +9221,7 @@
           <p:cNvPr id="3" name="">
             <a:extLst xmlns:a="http://schemas.openxmlformats.org/drawingml/2006/main">
               <a:ext uri="{FF2B5EF4-FFF2-40B4-BE49-F238E27FC236}">
-                <a16:creationId xmlns:a16="http://schemas.microsoft.com/office/drawing/2014/main" id="{E9A658A7-E507-4F7E-8F98-EF54E271E663}"/>
+                <a16:creationId xmlns:a16="http://schemas.microsoft.com/office/drawing/2014/main" id="{00765441-7EFD-4E43-B128-572D0C83365C}"/>
               </a:ext>
             </a:extLst>
           </p:cNvPr>
@@ -9254,7 +9231,7 @@
           <p:nvPr/>
         </p:nvPicPr>
         <p:blipFill>
-          <a:blip xmlns:r="http://schemas.openxmlformats.org/officeDocument/2006/relationships" xmlns:a="http://schemas.openxmlformats.org/drawingml/2006/main" r:embed="R5c8c652bae904467"/>
+          <a:blip xmlns:r="http://schemas.openxmlformats.org/officeDocument/2006/relationships" xmlns:a="http://schemas.openxmlformats.org/drawingml/2006/main" r:embed="R175dfccffde949ec"/>
           <a:stretch xmlns:a="http://schemas.openxmlformats.org/drawingml/2006/main"/>
         </p:blipFill>
         <p:spPr>
@@ -9270,7 +9247,7 @@
     </p:spTree>
     <p:extLst>
       <p:ext uri="{BB962C8B-B14F-4D97-AF65-F5344CB8AC3E}">
-        <p14:creationId xmlns:p14="http://schemas.microsoft.com/office/powerpoint/2010/main" val="733498719"/>
+        <p14:creationId xmlns:p14="http://schemas.microsoft.com/office/powerpoint/2010/main" val="1547733013"/>
       </p:ext>
     </p:extLst>
   </p:cSld>
@@ -9301,7 +9278,7 @@
           <p:cNvPr id="5" name="">
             <a:extLst xmlns:a="http://schemas.openxmlformats.org/drawingml/2006/main">
               <a:ext uri="{FF2B5EF4-FFF2-40B4-BE49-F238E27FC236}">
-                <a16:creationId xmlns:a16="http://schemas.microsoft.com/office/drawing/2014/main" id="{28A65407-9A9A-4499-AD3C-FDBDAE6382F3}"/>
+                <a16:creationId xmlns:a16="http://schemas.microsoft.com/office/drawing/2014/main" id="{1F7E19A0-3425-463E-99C7-DE2F49183143}"/>
               </a:ext>
             </a:extLst>
           </p:cNvPr>
@@ -9367,7 +9344,7 @@
           <p:cNvPr id="2" name="">
             <a:extLst xmlns:a="http://schemas.openxmlformats.org/drawingml/2006/main">
               <a:ext uri="{FF2B5EF4-FFF2-40B4-BE49-F238E27FC236}">
-                <a16:creationId xmlns:a16="http://schemas.microsoft.com/office/drawing/2014/main" id="{98868D13-58F5-4677-86FC-355900E63A70}"/>
+                <a16:creationId xmlns:a16="http://schemas.microsoft.com/office/drawing/2014/main" id="{8009FFAC-B425-46E0-826C-58119D28B62F}"/>
               </a:ext>
             </a:extLst>
           </p:cNvPr>
@@ -9433,7 +9410,7 @@
           <p:cNvPr id="3" name="">
             <a:extLst xmlns:a="http://schemas.openxmlformats.org/drawingml/2006/main">
               <a:ext uri="{FF2B5EF4-FFF2-40B4-BE49-F238E27FC236}">
-                <a16:creationId xmlns:a16="http://schemas.microsoft.com/office/drawing/2014/main" id="{BFB1332F-6439-4C31-8D05-8FD0097790A7}"/>
+                <a16:creationId xmlns:a16="http://schemas.microsoft.com/office/drawing/2014/main" id="{2D6EBD2D-350E-45BB-AA0E-96B3ABB9AC63}"/>
               </a:ext>
             </a:extLst>
           </p:cNvPr>
@@ -9711,7 +9688,7 @@
           <p:cNvPr id="4" name="">
             <a:extLst xmlns:a="http://schemas.openxmlformats.org/drawingml/2006/main">
               <a:ext uri="{FF2B5EF4-FFF2-40B4-BE49-F238E27FC236}">
-                <a16:creationId xmlns:a16="http://schemas.microsoft.com/office/drawing/2014/main" id="{579F12F4-10D9-4B52-BB7C-566207FE7F7F}"/>
+                <a16:creationId xmlns:a16="http://schemas.microsoft.com/office/drawing/2014/main" id="{BCF79EAE-F9C7-4E11-B368-447C99428F2E}"/>
               </a:ext>
             </a:extLst>
           </p:cNvPr>
@@ -9775,7 +9752,7 @@
     </p:spTree>
     <p:extLst>
       <p:ext uri="{BB962C8B-B14F-4D97-AF65-F5344CB8AC3E}">
-        <p14:creationId xmlns:p14="http://schemas.microsoft.com/office/powerpoint/2010/main" val="323585427"/>
+        <p14:creationId xmlns:p14="http://schemas.microsoft.com/office/powerpoint/2010/main" val="1303080640"/>
       </p:ext>
     </p:extLst>
   </p:cSld>
@@ -9806,7 +9783,7 @@
           <p:cNvPr id="8" name="">
             <a:extLst xmlns:a="http://schemas.openxmlformats.org/drawingml/2006/main">
               <a:ext uri="{FF2B5EF4-FFF2-40B4-BE49-F238E27FC236}">
-                <a16:creationId xmlns:a16="http://schemas.microsoft.com/office/drawing/2014/main" id="{EF902AB2-1ED0-411E-AFC0-C521B2338209}"/>
+                <a16:creationId xmlns:a16="http://schemas.microsoft.com/office/drawing/2014/main" id="{0AB3978F-718F-48DE-9822-A7EFB59B882C}"/>
               </a:ext>
             </a:extLst>
           </p:cNvPr>
@@ -9872,7 +9849,7 @@
           <p:cNvPr id="2" name="">
             <a:extLst xmlns:a="http://schemas.openxmlformats.org/drawingml/2006/main">
               <a:ext uri="{FF2B5EF4-FFF2-40B4-BE49-F238E27FC236}">
-                <a16:creationId xmlns:a16="http://schemas.microsoft.com/office/drawing/2014/main" id="{A88F5FF6-8E77-4997-B638-851326EAAD6F}"/>
+                <a16:creationId xmlns:a16="http://schemas.microsoft.com/office/drawing/2014/main" id="{D6A6915B-10B2-4F2F-B3EC-F342DB6F87F3}"/>
               </a:ext>
             </a:extLst>
           </p:cNvPr>
@@ -9938,7 +9915,7 @@
           <p:cNvPr id="3" name="Chart">
             <a:extLst xmlns:a="http://schemas.openxmlformats.org/drawingml/2006/main">
               <a:ext uri="{FF2B5EF4-FFF2-40B4-BE49-F238E27FC236}">
-                <a16:creationId xmlns:a16="http://schemas.microsoft.com/office/drawing/2014/main" id="{B3304E44-B74F-4B0D-B577-9512D9F0B905}"/>
+                <a16:creationId xmlns:a16="http://schemas.microsoft.com/office/drawing/2014/main" id="{0E4F35ED-482B-438F-8643-98CE7E94DC7F}"/>
               </a:ext>
             </a:extLst>
           </p:cNvPr>
@@ -9951,7 +9928,7 @@
         </p:xfrm>
         <a:graphic xmlns:a="http://schemas.openxmlformats.org/drawingml/2006/main">
           <a:graphicData uri="http://schemas.openxmlformats.org/drawingml/2006/chart">
-            <c:chart xmlns:r="http://schemas.openxmlformats.org/officeDocument/2006/relationships" xmlns:c="http://schemas.openxmlformats.org/drawingml/2006/chart" r:id="R1b6134dcca054da0"/>
+            <c:chart xmlns:r="http://schemas.openxmlformats.org/officeDocument/2006/relationships" xmlns:c="http://schemas.openxmlformats.org/drawingml/2006/chart" r:id="R6cc0ac5a66294808"/>
           </a:graphicData>
         </a:graphic>
       </p:graphicFrame>
@@ -9960,7 +9937,7 @@
           <p:cNvPr id="4" name="">
             <a:extLst xmlns:a="http://schemas.openxmlformats.org/drawingml/2006/main">
               <a:ext uri="{FF2B5EF4-FFF2-40B4-BE49-F238E27FC236}">
-                <a16:creationId xmlns:a16="http://schemas.microsoft.com/office/drawing/2014/main" id="{49EC08B6-3E5B-4C37-A7DD-134549F9CC45}"/>
+                <a16:creationId xmlns:a16="http://schemas.microsoft.com/office/drawing/2014/main" id="{CEEF3F1C-5DF8-4C5B-A4E3-7ABC16DE1129}"/>
               </a:ext>
             </a:extLst>
           </p:cNvPr>
@@ -10026,7 +10003,7 @@
           <p:cNvPr id="5" name="">
             <a:extLst xmlns:a="http://schemas.openxmlformats.org/drawingml/2006/main">
               <a:ext uri="{FF2B5EF4-FFF2-40B4-BE49-F238E27FC236}">
-                <a16:creationId xmlns:a16="http://schemas.microsoft.com/office/drawing/2014/main" id="{DA8EDBC4-D19C-405A-8847-FFB3217405E1}"/>
+                <a16:creationId xmlns:a16="http://schemas.microsoft.com/office/drawing/2014/main" id="{2A48E8B5-D784-4523-8F0C-9EB3303C7782}"/>
               </a:ext>
             </a:extLst>
           </p:cNvPr>
@@ -10138,7 +10115,7 @@
           <p:cNvPr id="6" name="">
             <a:extLst xmlns:a="http://schemas.openxmlformats.org/drawingml/2006/main">
               <a:ext uri="{FF2B5EF4-FFF2-40B4-BE49-F238E27FC236}">
-                <a16:creationId xmlns:a16="http://schemas.microsoft.com/office/drawing/2014/main" id="{9776E638-2928-4583-AD52-AA0BEF400674}"/>
+                <a16:creationId xmlns:a16="http://schemas.microsoft.com/office/drawing/2014/main" id="{8AC8DF61-AFF6-45E3-80EA-8E7D97B45855}"/>
               </a:ext>
             </a:extLst>
           </p:cNvPr>
@@ -10227,7 +10204,7 @@
           <p:cNvPr id="7" name="">
             <a:extLst xmlns:a="http://schemas.openxmlformats.org/drawingml/2006/main">
               <a:ext uri="{FF2B5EF4-FFF2-40B4-BE49-F238E27FC236}">
-                <a16:creationId xmlns:a16="http://schemas.microsoft.com/office/drawing/2014/main" id="{9EB99D40-62AB-489B-A382-8601167081D4}"/>
+                <a16:creationId xmlns:a16="http://schemas.microsoft.com/office/drawing/2014/main" id="{AA5A2DF1-B71D-479A-A07F-DB683B5D0E74}"/>
               </a:ext>
             </a:extLst>
           </p:cNvPr>
@@ -10291,7 +10268,7 @@
     </p:spTree>
     <p:extLst>
       <p:ext uri="{BB962C8B-B14F-4D97-AF65-F5344CB8AC3E}">
-        <p14:creationId xmlns:p14="http://schemas.microsoft.com/office/powerpoint/2010/main" val="1891562127"/>
+        <p14:creationId xmlns:p14="http://schemas.microsoft.com/office/powerpoint/2010/main" val="1906100928"/>
       </p:ext>
     </p:extLst>
   </p:cSld>

</xml_diff>

<commit_message>
Align submission documents and software demo with Flask deployment
</commit_message>
<xml_diff>
--- a/submission/AlphaVault-Presentation.pptx
+++ b/submission/AlphaVault-Presentation.pptx
@@ -2,24 +2,24 @@
 <file path=ppt/presentation.xml><?xml version="1.0" encoding="utf-8"?>
 <p:presentation xmlns:p="http://schemas.openxmlformats.org/presentationml/2006/main">
   <p:sldMasterIdLst>
-    <p:sldMasterId xmlns:r="http://schemas.openxmlformats.org/officeDocument/2006/relationships" id="2147483648" r:id="R609d156055d64dfa"/>
+    <p:sldMasterId xmlns:r="http://schemas.openxmlformats.org/officeDocument/2006/relationships" id="2147483648" r:id="Rb06d292233c54260"/>
   </p:sldMasterIdLst>
   <p:notesMasterIdLst>
-    <p:notesMasterId xmlns:r="http://schemas.openxmlformats.org/officeDocument/2006/relationships" r:id="Rbbc84ff9878e439f"/>
+    <p:notesMasterId xmlns:r="http://schemas.openxmlformats.org/officeDocument/2006/relationships" r:id="Ra4237e2ebead4998"/>
   </p:notesMasterIdLst>
   <p:sldIdLst>
-    <p:sldId xmlns:r="http://schemas.openxmlformats.org/officeDocument/2006/relationships" id="256" r:id="Rc05baf8aadb8411f"/>
-    <p:sldId xmlns:r="http://schemas.openxmlformats.org/officeDocument/2006/relationships" id="257" r:id="R2f73189136e14807"/>
-    <p:sldId xmlns:r="http://schemas.openxmlformats.org/officeDocument/2006/relationships" id="258" r:id="R7947501dc2a14026"/>
-    <p:sldId xmlns:r="http://schemas.openxmlformats.org/officeDocument/2006/relationships" id="259" r:id="Rb618d6ebffc94973"/>
-    <p:sldId xmlns:r="http://schemas.openxmlformats.org/officeDocument/2006/relationships" id="260" r:id="R8e5bd2ae9fe04050"/>
-    <p:sldId xmlns:r="http://schemas.openxmlformats.org/officeDocument/2006/relationships" id="261" r:id="Rea04d83747764b83"/>
-    <p:sldId xmlns:r="http://schemas.openxmlformats.org/officeDocument/2006/relationships" id="262" r:id="R2f8d8c5304354e64"/>
-    <p:sldId xmlns:r="http://schemas.openxmlformats.org/officeDocument/2006/relationships" id="263" r:id="Rf5363a246863449b"/>
-    <p:sldId xmlns:r="http://schemas.openxmlformats.org/officeDocument/2006/relationships" id="264" r:id="R551a99692fa049bd"/>
-    <p:sldId xmlns:r="http://schemas.openxmlformats.org/officeDocument/2006/relationships" id="265" r:id="R006f49c2e5c44ee5"/>
-    <p:sldId xmlns:r="http://schemas.openxmlformats.org/officeDocument/2006/relationships" id="266" r:id="R23efde10454e4636"/>
-    <p:sldId xmlns:r="http://schemas.openxmlformats.org/officeDocument/2006/relationships" id="267" r:id="R74c4d260c744490f"/>
+    <p:sldId xmlns:r="http://schemas.openxmlformats.org/officeDocument/2006/relationships" id="256" r:id="R9f4665fa40904cc8"/>
+    <p:sldId xmlns:r="http://schemas.openxmlformats.org/officeDocument/2006/relationships" id="257" r:id="R107c7480f0e14575"/>
+    <p:sldId xmlns:r="http://schemas.openxmlformats.org/officeDocument/2006/relationships" id="258" r:id="Ra11349612cae46c0"/>
+    <p:sldId xmlns:r="http://schemas.openxmlformats.org/officeDocument/2006/relationships" id="259" r:id="R0d00ef4edebc4d1f"/>
+    <p:sldId xmlns:r="http://schemas.openxmlformats.org/officeDocument/2006/relationships" id="260" r:id="R5996762fffbb44dc"/>
+    <p:sldId xmlns:r="http://schemas.openxmlformats.org/officeDocument/2006/relationships" id="261" r:id="Rcfa5bd752dc64b82"/>
+    <p:sldId xmlns:r="http://schemas.openxmlformats.org/officeDocument/2006/relationships" id="262" r:id="Ra978bf66fc094c26"/>
+    <p:sldId xmlns:r="http://schemas.openxmlformats.org/officeDocument/2006/relationships" id="263" r:id="R64967178054d4c84"/>
+    <p:sldId xmlns:r="http://schemas.openxmlformats.org/officeDocument/2006/relationships" id="264" r:id="Rd5832a61807f4c63"/>
+    <p:sldId xmlns:r="http://schemas.openxmlformats.org/officeDocument/2006/relationships" id="265" r:id="Rbd9d6a8b5e7b43f3"/>
+    <p:sldId xmlns:r="http://schemas.openxmlformats.org/officeDocument/2006/relationships" id="266" r:id="R0725a49b6d224c7b"/>
+    <p:sldId xmlns:r="http://schemas.openxmlformats.org/officeDocument/2006/relationships" id="267" r:id="Ra26da29fde7c4e21"/>
   </p:sldIdLst>
   <p:sldSz cx="12192000" cy="6858000"/>
   <p:notesSz cx="6858000" cy="9144000"/>
@@ -169,9 +169,9 @@
 </file>
 
 <file path=ppt/notesMasters/theme/theme3.xml><?xml version="1.0" encoding="utf-8"?>
-<a:theme xmlns:a="http://schemas.openxmlformats.org/drawingml/2006/main" name="ChatGPT">
+<a:theme xmlns:a="http://schemas.openxmlformats.org/drawingml/2006/main" name="AlphaVault">
   <a:themeElements>
-    <a:clrScheme name="ChatGPT">
+    <a:clrScheme name="AlphaVault">
       <a:dk1>
         <a:srgbClr val="000000"/>
       </a:dk1>
@@ -221,7 +221,7 @@
         <a:cs typeface=""/>
       </a:minorFont>
     </a:fontScheme>
-    <a:fmtScheme name="ChatGPT">
+    <a:fmtScheme name="AlphaVault">
       <a:fillStyleLst>
         <a:solidFill>
           <a:schemeClr val="phClr"/>
@@ -453,7 +453,7 @@
           <a:lstStyle xmlns:a="http://schemas.openxmlformats.org/drawingml/2006/main"/>
           <a:p xmlns:a="http://schemas.openxmlformats.org/drawingml/2006/main">
             <a:r>
-              <a:t>0–20 seconds. Welcome to AlphaVault, a quantitative portfolio management and risk controlled rebalancing application by Du zhuotong. This ten minute demonstration explains the problem, system design, actual application workflow, and measured results. The project uses mock assets on a local chain and the Sepolia test network.</a:t>
+              <a:t>0–20 seconds. Welcome to AlphaVault, a quantitative portfolio management and risk controlled rebalancing application by Du Zhuotong. This ten minute demonstration explains the problem, system design, actual application workflow, and measured results. The project uses mock assets on a local chain and the Sepolia test network.</a:t>
             </a:r>
           </a:p>
           <a:p xmlns:a="http://schemas.openxmlformats.org/drawingml/2006/main">
@@ -528,7 +528,7 @@
           <a:lstStyle xmlns:a="http://schemas.openxmlformats.org/drawingml/2006/main"/>
           <a:p xmlns:a="http://schemas.openxmlformats.org/drawingml/2006/main">
             <a:r>
-              <a:t>478–528 seconds. The latest full automated run passes sixty four tests with zero failures. Tests cover contract permissions, accounting, rollback, price freshness, pause behavior, API preparation and persistence. A new public acceptance check also passes: the service is in wallet mode, uses PostgreSQL, points to the expected Sepolia vault, and exposes ten verified transaction types. The earlier restart experiment provides a stronger storage check than event replay alone. A non chain jobs record remained identical after the Render service restarted. Because that record is not reconstructed from blockchain events, its retention demonstrates persistence across that observed restart. This is a specific acceptance result, not an uptime guarantee. The free service can still sleep.</a:t>
+              <a:t>478–528 seconds. The Python Flask suite passes thirty six tests and the contract and legacy regression suite passes sixty four tests. Tests cover contract permissions, accounting, rollback, price freshness, pause behavior, API preparation and persistence. A new public acceptance check also passes: the service is in wallet mode, uses PostgreSQL, points to the expected Sepolia vault, and exposes ten verified transaction types. The earlier restart experiment provides a stronger storage check than event replay alone. A non chain jobs record remained identical after the Render service restarted. Because that record is not reconstructed from blockchain events, its retention demonstrates persistence across that observed restart. This is a specific acceptance result, not an uptime guarantee. The free service can still sleep.</a:t>
             </a:r>
           </a:p>
           <a:p xmlns:a="http://schemas.openxmlformats.org/drawingml/2006/main">
@@ -833,7 +833,7 @@
           </a:p>
           <a:p xmlns:a="http://schemas.openxmlformats.org/drawingml/2006/main">
             <a:r>
-              <a:t>Source: Technical report p. 3; contracts/ and server/.</a:t>
+              <a:t>Source: Technical report p. 3; contracts/ and backend/.</a:t>
             </a:r>
           </a:p>
         </p:txBody>
@@ -983,7 +983,7 @@
           </a:p>
           <a:p xmlns:a="http://schemas.openxmlformats.org/drawingml/2006/main">
             <a:r>
-              <a:t>Source: Technical report p. 7; server/store.mjs, postgres-store.mjs.</a:t>
+              <a:t>Source: Technical report p. 7; backend/store.mjs, postgres-store.mjs.</a:t>
             </a:r>
           </a:p>
         </p:txBody>
@@ -1058,7 +1058,7 @@
           </a:p>
           <a:p xmlns:a="http://schemas.openxmlformats.org/drawingml/2006/main">
             <a:r>
-              <a:t>Source: Technical report p. 8; public/app.js and server/actions.mjs.</a:t>
+              <a:t>Source: Technical report p. 8; public/app.js and backend/actions.mjs.</a:t>
             </a:r>
           </a:p>
         </p:txBody>
@@ -1330,7 +1330,7 @@
           <p:cNvPr id="3" name="Title">
             <a:extLst xmlns:a="http://schemas.openxmlformats.org/drawingml/2006/main">
               <a:ext uri="{FF2B5EF4-FFF2-40B4-BE49-F238E27FC236}">
-                <a16:creationId xmlns:a16="http://schemas.microsoft.com/office/drawing/2014/main" id="{B5E7D587-1C68-4D6A-981C-4964C81F2C2F}"/>
+                <a16:creationId xmlns:a16="http://schemas.microsoft.com/office/drawing/2014/main" id="{2A81F570-29F2-4AD7-A191-AE0F577F6FBB}"/>
               </a:ext>
             </a:extLst>
           </p:cNvPr>
@@ -1381,6 +1381,7 @@
                 <a:spcPts val="0"/>
               </a:spcAft>
               <a:buNone/>
+              <a:defRPr/>
             </a:lvl1pPr>
             <a:lvl2pPr marL="0" indent="0">
               <a:lnSpc>
@@ -1393,6 +1394,7 @@
                 <a:spcPts val="0"/>
               </a:spcAft>
               <a:buNone/>
+              <a:defRPr/>
             </a:lvl2pPr>
             <a:lvl3pPr marL="0" indent="0">
               <a:lnSpc>
@@ -1405,6 +1407,7 @@
                 <a:spcPts val="0"/>
               </a:spcAft>
               <a:buNone/>
+              <a:defRPr/>
             </a:lvl3pPr>
             <a:lvl4pPr marL="0" indent="0">
               <a:lnSpc>
@@ -1417,6 +1420,7 @@
                 <a:spcPts val="0"/>
               </a:spcAft>
               <a:buNone/>
+              <a:defRPr/>
             </a:lvl4pPr>
             <a:lvl5pPr marL="0" indent="0">
               <a:lnSpc>
@@ -1429,6 +1433,7 @@
                 <a:spcPts val="0"/>
               </a:spcAft>
               <a:buNone/>
+              <a:defRPr/>
             </a:lvl5pPr>
             <a:lvl6pPr marL="0" indent="0">
               <a:lnSpc>
@@ -1441,6 +1446,7 @@
                 <a:spcPts val="0"/>
               </a:spcAft>
               <a:buNone/>
+              <a:defRPr/>
             </a:lvl6pPr>
             <a:lvl7pPr marL="0" indent="0">
               <a:lnSpc>
@@ -1453,6 +1459,7 @@
                 <a:spcPts val="0"/>
               </a:spcAft>
               <a:buNone/>
+              <a:defRPr/>
             </a:lvl7pPr>
             <a:lvl8pPr marL="0" indent="0">
               <a:lnSpc>
@@ -1465,6 +1472,7 @@
                 <a:spcPts val="0"/>
               </a:spcAft>
               <a:buNone/>
+              <a:defRPr/>
             </a:lvl8pPr>
             <a:lvl9pPr marL="0" indent="0">
               <a:lnSpc>
@@ -1477,6 +1485,7 @@
                 <a:spcPts val="0"/>
               </a:spcAft>
               <a:buNone/>
+              <a:defRPr/>
             </a:lvl9pPr>
           </a:lstStyle>
           <a:p xmlns:a="http://schemas.openxmlformats.org/drawingml/2006/main"/>
@@ -1487,7 +1496,7 @@
           <p:cNvPr id="2" name="Subtitle">
             <a:extLst xmlns:a="http://schemas.openxmlformats.org/drawingml/2006/main">
               <a:ext uri="{FF2B5EF4-FFF2-40B4-BE49-F238E27FC236}">
-                <a16:creationId xmlns:a16="http://schemas.microsoft.com/office/drawing/2014/main" id="{251CF352-4A0C-4F24-B4E2-A6AE5EB12549}"/>
+                <a16:creationId xmlns:a16="http://schemas.microsoft.com/office/drawing/2014/main" id="{27F04BF9-F635-4754-8FF1-BE67E25C9D7E}"/>
               </a:ext>
             </a:extLst>
           </p:cNvPr>
@@ -1538,6 +1547,7 @@
                 <a:spcPts val="0"/>
               </a:spcAft>
               <a:buNone/>
+              <a:defRPr/>
             </a:lvl1pPr>
             <a:lvl2pPr marL="0" indent="0">
               <a:lnSpc>
@@ -1550,6 +1560,7 @@
                 <a:spcPts val="0"/>
               </a:spcAft>
               <a:buNone/>
+              <a:defRPr/>
             </a:lvl2pPr>
             <a:lvl3pPr marL="0" indent="0">
               <a:lnSpc>
@@ -1562,6 +1573,7 @@
                 <a:spcPts val="0"/>
               </a:spcAft>
               <a:buNone/>
+              <a:defRPr/>
             </a:lvl3pPr>
             <a:lvl4pPr marL="0" indent="0">
               <a:lnSpc>
@@ -1574,6 +1586,7 @@
                 <a:spcPts val="0"/>
               </a:spcAft>
               <a:buNone/>
+              <a:defRPr/>
             </a:lvl4pPr>
             <a:lvl5pPr marL="0" indent="0">
               <a:lnSpc>
@@ -1586,6 +1599,7 @@
                 <a:spcPts val="0"/>
               </a:spcAft>
               <a:buNone/>
+              <a:defRPr/>
             </a:lvl5pPr>
             <a:lvl6pPr marL="0" indent="0">
               <a:lnSpc>
@@ -1598,6 +1612,7 @@
                 <a:spcPts val="0"/>
               </a:spcAft>
               <a:buNone/>
+              <a:defRPr/>
             </a:lvl6pPr>
             <a:lvl7pPr marL="0" indent="0">
               <a:lnSpc>
@@ -1610,6 +1625,7 @@
                 <a:spcPts val="0"/>
               </a:spcAft>
               <a:buNone/>
+              <a:defRPr/>
             </a:lvl7pPr>
             <a:lvl8pPr marL="0" indent="0">
               <a:lnSpc>
@@ -1622,6 +1638,7 @@
                 <a:spcPts val="0"/>
               </a:spcAft>
               <a:buNone/>
+              <a:defRPr/>
             </a:lvl8pPr>
             <a:lvl9pPr marL="0" indent="0">
               <a:lnSpc>
@@ -1634,6 +1651,7 @@
                 <a:spcPts val="0"/>
               </a:spcAft>
               <a:buNone/>
+              <a:defRPr/>
             </a:lvl9pPr>
           </a:lstStyle>
           <a:p xmlns:a="http://schemas.openxmlformats.org/drawingml/2006/main"/>
@@ -1661,7 +1679,7 @@
           <p:cNvPr id="2" name="Section title">
             <a:extLst xmlns:a="http://schemas.openxmlformats.org/drawingml/2006/main">
               <a:ext uri="{FF2B5EF4-FFF2-40B4-BE49-F238E27FC236}">
-                <a16:creationId xmlns:a16="http://schemas.microsoft.com/office/drawing/2014/main" id="{88816E27-5A4D-4F3B-BC3E-4C1F924BDC48}"/>
+                <a16:creationId xmlns:a16="http://schemas.microsoft.com/office/drawing/2014/main" id="{4E7BC990-30E0-433C-BA37-FCE1C5A2BC5A}"/>
               </a:ext>
             </a:extLst>
           </p:cNvPr>
@@ -1712,6 +1730,7 @@
                 <a:spcPts val="0"/>
               </a:spcAft>
               <a:buNone/>
+              <a:defRPr/>
             </a:lvl1pPr>
             <a:lvl2pPr marL="0" indent="0">
               <a:lnSpc>
@@ -1724,6 +1743,7 @@
                 <a:spcPts val="0"/>
               </a:spcAft>
               <a:buNone/>
+              <a:defRPr/>
             </a:lvl2pPr>
             <a:lvl3pPr marL="0" indent="0">
               <a:lnSpc>
@@ -1736,6 +1756,7 @@
                 <a:spcPts val="0"/>
               </a:spcAft>
               <a:buNone/>
+              <a:defRPr/>
             </a:lvl3pPr>
             <a:lvl4pPr marL="0" indent="0">
               <a:lnSpc>
@@ -1748,6 +1769,7 @@
                 <a:spcPts val="0"/>
               </a:spcAft>
               <a:buNone/>
+              <a:defRPr/>
             </a:lvl4pPr>
             <a:lvl5pPr marL="0" indent="0">
               <a:lnSpc>
@@ -1760,6 +1782,7 @@
                 <a:spcPts val="0"/>
               </a:spcAft>
               <a:buNone/>
+              <a:defRPr/>
             </a:lvl5pPr>
             <a:lvl6pPr marL="0" indent="0">
               <a:lnSpc>
@@ -1772,6 +1795,7 @@
                 <a:spcPts val="0"/>
               </a:spcAft>
               <a:buNone/>
+              <a:defRPr/>
             </a:lvl6pPr>
             <a:lvl7pPr marL="0" indent="0">
               <a:lnSpc>
@@ -1784,6 +1808,7 @@
                 <a:spcPts val="0"/>
               </a:spcAft>
               <a:buNone/>
+              <a:defRPr/>
             </a:lvl7pPr>
             <a:lvl8pPr marL="0" indent="0">
               <a:lnSpc>
@@ -1796,6 +1821,7 @@
                 <a:spcPts val="0"/>
               </a:spcAft>
               <a:buNone/>
+              <a:defRPr/>
             </a:lvl8pPr>
             <a:lvl9pPr marL="0" indent="0">
               <a:lnSpc>
@@ -1808,6 +1834,7 @@
                 <a:spcPts val="0"/>
               </a:spcAft>
               <a:buNone/>
+              <a:defRPr/>
             </a:lvl9pPr>
           </a:lstStyle>
           <a:p xmlns:a="http://schemas.openxmlformats.org/drawingml/2006/main"/>
@@ -1835,7 +1862,7 @@
           <p:cNvPr id="3" name="Title">
             <a:extLst xmlns:a="http://schemas.openxmlformats.org/drawingml/2006/main">
               <a:ext uri="{FF2B5EF4-FFF2-40B4-BE49-F238E27FC236}">
-                <a16:creationId xmlns:a16="http://schemas.microsoft.com/office/drawing/2014/main" id="{3BE13B4F-217F-4592-9FD2-A9A1B23A053D}"/>
+                <a16:creationId xmlns:a16="http://schemas.microsoft.com/office/drawing/2014/main" id="{9BB3CE10-6678-48A2-BA84-9161FD956F05}"/>
               </a:ext>
             </a:extLst>
           </p:cNvPr>
@@ -1886,6 +1913,7 @@
                 <a:spcPts val="0"/>
               </a:spcAft>
               <a:buNone/>
+              <a:defRPr/>
             </a:lvl1pPr>
             <a:lvl2pPr marL="0" indent="0">
               <a:lnSpc>
@@ -1898,6 +1926,7 @@
                 <a:spcPts val="0"/>
               </a:spcAft>
               <a:buNone/>
+              <a:defRPr/>
             </a:lvl2pPr>
             <a:lvl3pPr marL="0" indent="0">
               <a:lnSpc>
@@ -1910,6 +1939,7 @@
                 <a:spcPts val="0"/>
               </a:spcAft>
               <a:buNone/>
+              <a:defRPr/>
             </a:lvl3pPr>
             <a:lvl4pPr marL="0" indent="0">
               <a:lnSpc>
@@ -1922,6 +1952,7 @@
                 <a:spcPts val="0"/>
               </a:spcAft>
               <a:buNone/>
+              <a:defRPr/>
             </a:lvl4pPr>
             <a:lvl5pPr marL="0" indent="0">
               <a:lnSpc>
@@ -1934,6 +1965,7 @@
                 <a:spcPts val="0"/>
               </a:spcAft>
               <a:buNone/>
+              <a:defRPr/>
             </a:lvl5pPr>
             <a:lvl6pPr marL="0" indent="0">
               <a:lnSpc>
@@ -1946,6 +1978,7 @@
                 <a:spcPts val="0"/>
               </a:spcAft>
               <a:buNone/>
+              <a:defRPr/>
             </a:lvl6pPr>
             <a:lvl7pPr marL="0" indent="0">
               <a:lnSpc>
@@ -1958,6 +1991,7 @@
                 <a:spcPts val="0"/>
               </a:spcAft>
               <a:buNone/>
+              <a:defRPr/>
             </a:lvl7pPr>
             <a:lvl8pPr marL="0" indent="0">
               <a:lnSpc>
@@ -1970,6 +2004,7 @@
                 <a:spcPts val="0"/>
               </a:spcAft>
               <a:buNone/>
+              <a:defRPr/>
             </a:lvl8pPr>
             <a:lvl9pPr marL="0" indent="0">
               <a:lnSpc>
@@ -1982,6 +2017,7 @@
                 <a:spcPts val="0"/>
               </a:spcAft>
               <a:buNone/>
+              <a:defRPr/>
             </a:lvl9pPr>
           </a:lstStyle>
           <a:p xmlns:a="http://schemas.openxmlformats.org/drawingml/2006/main"/>
@@ -1992,7 +2028,7 @@
           <p:cNvPr id="2" name="Body">
             <a:extLst xmlns:a="http://schemas.openxmlformats.org/drawingml/2006/main">
               <a:ext uri="{FF2B5EF4-FFF2-40B4-BE49-F238E27FC236}">
-                <a16:creationId xmlns:a16="http://schemas.microsoft.com/office/drawing/2014/main" id="{ABEB5F58-C70A-482F-A979-C1082DB6AB95}"/>
+                <a16:creationId xmlns:a16="http://schemas.microsoft.com/office/drawing/2014/main" id="{AC5B51E5-FED3-4DEF-B3FF-E8F6462D5405}"/>
               </a:ext>
             </a:extLst>
           </p:cNvPr>
@@ -2043,6 +2079,7 @@
                 <a:spcPts val="1200"/>
               </a:spcAft>
               <a:buChar char="•"/>
+              <a:defRPr/>
             </a:lvl1pPr>
             <a:lvl2pPr marL="533400" indent="-228600">
               <a:lnSpc>
@@ -2055,6 +2092,7 @@
                 <a:spcPts val="1200"/>
               </a:spcAft>
               <a:buChar char="•"/>
+              <a:defRPr/>
             </a:lvl2pPr>
             <a:lvl3pPr marL="838200" indent="-228600">
               <a:lnSpc>
@@ -2067,6 +2105,7 @@
                 <a:spcPts val="1200"/>
               </a:spcAft>
               <a:buChar char="•"/>
+              <a:defRPr/>
             </a:lvl3pPr>
             <a:lvl4pPr marL="1143000" indent="-228600">
               <a:lnSpc>
@@ -2079,6 +2118,7 @@
                 <a:spcPts val="1200"/>
               </a:spcAft>
               <a:buChar char="•"/>
+              <a:defRPr/>
             </a:lvl4pPr>
             <a:lvl5pPr marL="1447800" indent="-228600">
               <a:lnSpc>
@@ -2091,6 +2131,7 @@
                 <a:spcPts val="1200"/>
               </a:spcAft>
               <a:buChar char="•"/>
+              <a:defRPr/>
             </a:lvl5pPr>
             <a:lvl6pPr marL="1752600" indent="-228600">
               <a:lnSpc>
@@ -2103,6 +2144,7 @@
                 <a:spcPts val="1200"/>
               </a:spcAft>
               <a:buChar char="•"/>
+              <a:defRPr/>
             </a:lvl6pPr>
             <a:lvl7pPr marL="2057400" indent="-228600">
               <a:lnSpc>
@@ -2115,6 +2157,7 @@
                 <a:spcPts val="1200"/>
               </a:spcAft>
               <a:buChar char="•"/>
+              <a:defRPr/>
             </a:lvl7pPr>
             <a:lvl8pPr marL="2362200" indent="-228600">
               <a:lnSpc>
@@ -2127,6 +2170,7 @@
                 <a:spcPts val="1200"/>
               </a:spcAft>
               <a:buChar char="•"/>
+              <a:defRPr/>
             </a:lvl8pPr>
             <a:lvl9pPr marL="2667000" indent="-228600">
               <a:lnSpc>
@@ -2139,6 +2183,7 @@
                 <a:spcPts val="1200"/>
               </a:spcAft>
               <a:buChar char="•"/>
+              <a:defRPr/>
             </a:lvl9pPr>
           </a:lstStyle>
           <a:p xmlns:a="http://schemas.openxmlformats.org/drawingml/2006/main"/>
@@ -2166,7 +2211,7 @@
           <p:cNvPr id="4" name="Title">
             <a:extLst xmlns:a="http://schemas.openxmlformats.org/drawingml/2006/main">
               <a:ext uri="{FF2B5EF4-FFF2-40B4-BE49-F238E27FC236}">
-                <a16:creationId xmlns:a16="http://schemas.microsoft.com/office/drawing/2014/main" id="{A5AA1548-9770-4FA1-8538-B4C419EAEF58}"/>
+                <a16:creationId xmlns:a16="http://schemas.microsoft.com/office/drawing/2014/main" id="{9225786A-9E1B-4C84-9BAC-6BDB8E9155E4}"/>
               </a:ext>
             </a:extLst>
           </p:cNvPr>
@@ -2217,6 +2262,7 @@
                 <a:spcPts val="0"/>
               </a:spcAft>
               <a:buNone/>
+              <a:defRPr/>
             </a:lvl1pPr>
             <a:lvl2pPr marL="0" indent="0">
               <a:lnSpc>
@@ -2229,6 +2275,7 @@
                 <a:spcPts val="0"/>
               </a:spcAft>
               <a:buNone/>
+              <a:defRPr/>
             </a:lvl2pPr>
             <a:lvl3pPr marL="0" indent="0">
               <a:lnSpc>
@@ -2241,6 +2288,7 @@
                 <a:spcPts val="0"/>
               </a:spcAft>
               <a:buNone/>
+              <a:defRPr/>
             </a:lvl3pPr>
             <a:lvl4pPr marL="0" indent="0">
               <a:lnSpc>
@@ -2253,6 +2301,7 @@
                 <a:spcPts val="0"/>
               </a:spcAft>
               <a:buNone/>
+              <a:defRPr/>
             </a:lvl4pPr>
             <a:lvl5pPr marL="0" indent="0">
               <a:lnSpc>
@@ -2265,6 +2314,7 @@
                 <a:spcPts val="0"/>
               </a:spcAft>
               <a:buNone/>
+              <a:defRPr/>
             </a:lvl5pPr>
             <a:lvl6pPr marL="0" indent="0">
               <a:lnSpc>
@@ -2277,6 +2327,7 @@
                 <a:spcPts val="0"/>
               </a:spcAft>
               <a:buNone/>
+              <a:defRPr/>
             </a:lvl6pPr>
             <a:lvl7pPr marL="0" indent="0">
               <a:lnSpc>
@@ -2289,6 +2340,7 @@
                 <a:spcPts val="0"/>
               </a:spcAft>
               <a:buNone/>
+              <a:defRPr/>
             </a:lvl7pPr>
             <a:lvl8pPr marL="0" indent="0">
               <a:lnSpc>
@@ -2301,6 +2353,7 @@
                 <a:spcPts val="0"/>
               </a:spcAft>
               <a:buNone/>
+              <a:defRPr/>
             </a:lvl8pPr>
             <a:lvl9pPr marL="0" indent="0">
               <a:lnSpc>
@@ -2313,6 +2366,7 @@
                 <a:spcPts val="0"/>
               </a:spcAft>
               <a:buNone/>
+              <a:defRPr/>
             </a:lvl9pPr>
           </a:lstStyle>
           <a:p xmlns:a="http://schemas.openxmlformats.org/drawingml/2006/main"/>
@@ -2323,7 +2377,7 @@
           <p:cNvPr id="2" name="Left column">
             <a:extLst xmlns:a="http://schemas.openxmlformats.org/drawingml/2006/main">
               <a:ext uri="{FF2B5EF4-FFF2-40B4-BE49-F238E27FC236}">
-                <a16:creationId xmlns:a16="http://schemas.microsoft.com/office/drawing/2014/main" id="{B6820C06-C09B-43C4-BA64-1BFC11043113}"/>
+                <a16:creationId xmlns:a16="http://schemas.microsoft.com/office/drawing/2014/main" id="{3F6624D7-229A-4C46-9624-5AD1F1F50645}"/>
               </a:ext>
             </a:extLst>
           </p:cNvPr>
@@ -2374,6 +2428,7 @@
                 <a:spcPts val="1200"/>
               </a:spcAft>
               <a:buChar char="•"/>
+              <a:defRPr/>
             </a:lvl1pPr>
             <a:lvl2pPr marL="533400" indent="-228600">
               <a:lnSpc>
@@ -2386,6 +2441,7 @@
                 <a:spcPts val="1200"/>
               </a:spcAft>
               <a:buChar char="•"/>
+              <a:defRPr/>
             </a:lvl2pPr>
             <a:lvl3pPr marL="838200" indent="-228600">
               <a:lnSpc>
@@ -2398,6 +2454,7 @@
                 <a:spcPts val="1200"/>
               </a:spcAft>
               <a:buChar char="•"/>
+              <a:defRPr/>
             </a:lvl3pPr>
             <a:lvl4pPr marL="1143000" indent="-228600">
               <a:lnSpc>
@@ -2410,6 +2467,7 @@
                 <a:spcPts val="1200"/>
               </a:spcAft>
               <a:buChar char="•"/>
+              <a:defRPr/>
             </a:lvl4pPr>
             <a:lvl5pPr marL="1447800" indent="-228600">
               <a:lnSpc>
@@ -2422,6 +2480,7 @@
                 <a:spcPts val="1200"/>
               </a:spcAft>
               <a:buChar char="•"/>
+              <a:defRPr/>
             </a:lvl5pPr>
             <a:lvl6pPr marL="1752600" indent="-228600">
               <a:lnSpc>
@@ -2434,6 +2493,7 @@
                 <a:spcPts val="1200"/>
               </a:spcAft>
               <a:buChar char="•"/>
+              <a:defRPr/>
             </a:lvl6pPr>
             <a:lvl7pPr marL="2057400" indent="-228600">
               <a:lnSpc>
@@ -2446,6 +2506,7 @@
                 <a:spcPts val="1200"/>
               </a:spcAft>
               <a:buChar char="•"/>
+              <a:defRPr/>
             </a:lvl7pPr>
             <a:lvl8pPr marL="2362200" indent="-228600">
               <a:lnSpc>
@@ -2458,6 +2519,7 @@
                 <a:spcPts val="1200"/>
               </a:spcAft>
               <a:buChar char="•"/>
+              <a:defRPr/>
             </a:lvl8pPr>
             <a:lvl9pPr marL="2667000" indent="-228600">
               <a:lnSpc>
@@ -2470,6 +2532,7 @@
                 <a:spcPts val="1200"/>
               </a:spcAft>
               <a:buChar char="•"/>
+              <a:defRPr/>
             </a:lvl9pPr>
           </a:lstStyle>
           <a:p xmlns:a="http://schemas.openxmlformats.org/drawingml/2006/main"/>
@@ -2480,7 +2543,7 @@
           <p:cNvPr id="3" name="Right column">
             <a:extLst xmlns:a="http://schemas.openxmlformats.org/drawingml/2006/main">
               <a:ext uri="{FF2B5EF4-FFF2-40B4-BE49-F238E27FC236}">
-                <a16:creationId xmlns:a16="http://schemas.microsoft.com/office/drawing/2014/main" id="{75965FCD-895B-4B86-87C3-E479FB858832}"/>
+                <a16:creationId xmlns:a16="http://schemas.microsoft.com/office/drawing/2014/main" id="{ACA06F98-2843-4F39-852A-72C46F90F4EB}"/>
               </a:ext>
             </a:extLst>
           </p:cNvPr>
@@ -2531,6 +2594,7 @@
                 <a:spcPts val="1200"/>
               </a:spcAft>
               <a:buChar char="•"/>
+              <a:defRPr/>
             </a:lvl1pPr>
             <a:lvl2pPr marL="533400" indent="-228600">
               <a:lnSpc>
@@ -2543,6 +2607,7 @@
                 <a:spcPts val="1200"/>
               </a:spcAft>
               <a:buChar char="•"/>
+              <a:defRPr/>
             </a:lvl2pPr>
             <a:lvl3pPr marL="838200" indent="-228600">
               <a:lnSpc>
@@ -2555,6 +2620,7 @@
                 <a:spcPts val="1200"/>
               </a:spcAft>
               <a:buChar char="•"/>
+              <a:defRPr/>
             </a:lvl3pPr>
             <a:lvl4pPr marL="1143000" indent="-228600">
               <a:lnSpc>
@@ -2567,6 +2633,7 @@
                 <a:spcPts val="1200"/>
               </a:spcAft>
               <a:buChar char="•"/>
+              <a:defRPr/>
             </a:lvl4pPr>
             <a:lvl5pPr marL="1447800" indent="-228600">
               <a:lnSpc>
@@ -2579,6 +2646,7 @@
                 <a:spcPts val="1200"/>
               </a:spcAft>
               <a:buChar char="•"/>
+              <a:defRPr/>
             </a:lvl5pPr>
             <a:lvl6pPr marL="1752600" indent="-228600">
               <a:lnSpc>
@@ -2591,6 +2659,7 @@
                 <a:spcPts val="1200"/>
               </a:spcAft>
               <a:buChar char="•"/>
+              <a:defRPr/>
             </a:lvl6pPr>
             <a:lvl7pPr marL="2057400" indent="-228600">
               <a:lnSpc>
@@ -2603,6 +2672,7 @@
                 <a:spcPts val="1200"/>
               </a:spcAft>
               <a:buChar char="•"/>
+              <a:defRPr/>
             </a:lvl7pPr>
             <a:lvl8pPr marL="2362200" indent="-228600">
               <a:lnSpc>
@@ -2615,6 +2685,7 @@
                 <a:spcPts val="1200"/>
               </a:spcAft>
               <a:buChar char="•"/>
+              <a:defRPr/>
             </a:lvl8pPr>
             <a:lvl9pPr marL="2667000" indent="-228600">
               <a:lnSpc>
@@ -2627,6 +2698,7 @@
                 <a:spcPts val="1200"/>
               </a:spcAft>
               <a:buChar char="•"/>
+              <a:defRPr/>
             </a:lvl9pPr>
           </a:lstStyle>
           <a:p xmlns:a="http://schemas.openxmlformats.org/drawingml/2006/main"/>
@@ -2654,7 +2726,7 @@
           <p:cNvPr id="3" name="Title">
             <a:extLst xmlns:a="http://schemas.openxmlformats.org/drawingml/2006/main">
               <a:ext uri="{FF2B5EF4-FFF2-40B4-BE49-F238E27FC236}">
-                <a16:creationId xmlns:a16="http://schemas.microsoft.com/office/drawing/2014/main" id="{4B6EC008-8520-423A-BD53-6FBF79D02AAA}"/>
+                <a16:creationId xmlns:a16="http://schemas.microsoft.com/office/drawing/2014/main" id="{97543824-B102-4332-A8A4-2A11B4BFA07E}"/>
               </a:ext>
             </a:extLst>
           </p:cNvPr>
@@ -2705,6 +2777,7 @@
                 <a:spcPts val="0"/>
               </a:spcAft>
               <a:buNone/>
+              <a:defRPr/>
             </a:lvl1pPr>
             <a:lvl2pPr marL="0" indent="0">
               <a:lnSpc>
@@ -2717,6 +2790,7 @@
                 <a:spcPts val="0"/>
               </a:spcAft>
               <a:buNone/>
+              <a:defRPr/>
             </a:lvl2pPr>
             <a:lvl3pPr marL="0" indent="0">
               <a:lnSpc>
@@ -2729,6 +2803,7 @@
                 <a:spcPts val="0"/>
               </a:spcAft>
               <a:buNone/>
+              <a:defRPr/>
             </a:lvl3pPr>
             <a:lvl4pPr marL="0" indent="0">
               <a:lnSpc>
@@ -2741,6 +2816,7 @@
                 <a:spcPts val="0"/>
               </a:spcAft>
               <a:buNone/>
+              <a:defRPr/>
             </a:lvl4pPr>
             <a:lvl5pPr marL="0" indent="0">
               <a:lnSpc>
@@ -2753,6 +2829,7 @@
                 <a:spcPts val="0"/>
               </a:spcAft>
               <a:buNone/>
+              <a:defRPr/>
             </a:lvl5pPr>
             <a:lvl6pPr marL="0" indent="0">
               <a:lnSpc>
@@ -2765,6 +2842,7 @@
                 <a:spcPts val="0"/>
               </a:spcAft>
               <a:buNone/>
+              <a:defRPr/>
             </a:lvl6pPr>
             <a:lvl7pPr marL="0" indent="0">
               <a:lnSpc>
@@ -2777,6 +2855,7 @@
                 <a:spcPts val="0"/>
               </a:spcAft>
               <a:buNone/>
+              <a:defRPr/>
             </a:lvl7pPr>
             <a:lvl8pPr marL="0" indent="0">
               <a:lnSpc>
@@ -2789,6 +2868,7 @@
                 <a:spcPts val="0"/>
               </a:spcAft>
               <a:buNone/>
+              <a:defRPr/>
             </a:lvl8pPr>
             <a:lvl9pPr marL="0" indent="0">
               <a:lnSpc>
@@ -2801,6 +2881,7 @@
                 <a:spcPts val="0"/>
               </a:spcAft>
               <a:buNone/>
+              <a:defRPr/>
             </a:lvl9pPr>
           </a:lstStyle>
           <a:p xmlns:a="http://schemas.openxmlformats.org/drawingml/2006/main"/>
@@ -2811,7 +2892,7 @@
           <p:cNvPr id="2" name="Left column">
             <a:extLst xmlns:a="http://schemas.openxmlformats.org/drawingml/2006/main">
               <a:ext uri="{FF2B5EF4-FFF2-40B4-BE49-F238E27FC236}">
-                <a16:creationId xmlns:a16="http://schemas.microsoft.com/office/drawing/2014/main" id="{018AAA3E-DC5A-4D1C-BE01-FA6777DE1438}"/>
+                <a16:creationId xmlns:a16="http://schemas.microsoft.com/office/drawing/2014/main" id="{D21578B8-C63C-420A-B973-011D580C8E7C}"/>
               </a:ext>
             </a:extLst>
           </p:cNvPr>
@@ -2862,6 +2943,7 @@
                 <a:spcPts val="1200"/>
               </a:spcAft>
               <a:buChar char="•"/>
+              <a:defRPr/>
             </a:lvl1pPr>
             <a:lvl2pPr marL="533400" indent="-228600">
               <a:lnSpc>
@@ -2874,6 +2956,7 @@
                 <a:spcPts val="1200"/>
               </a:spcAft>
               <a:buChar char="•"/>
+              <a:defRPr/>
             </a:lvl2pPr>
             <a:lvl3pPr marL="838200" indent="-228600">
               <a:lnSpc>
@@ -2886,6 +2969,7 @@
                 <a:spcPts val="1200"/>
               </a:spcAft>
               <a:buChar char="•"/>
+              <a:defRPr/>
             </a:lvl3pPr>
             <a:lvl4pPr marL="1143000" indent="-228600">
               <a:lnSpc>
@@ -2898,6 +2982,7 @@
                 <a:spcPts val="1200"/>
               </a:spcAft>
               <a:buChar char="•"/>
+              <a:defRPr/>
             </a:lvl4pPr>
             <a:lvl5pPr marL="1447800" indent="-228600">
               <a:lnSpc>
@@ -2910,6 +2995,7 @@
                 <a:spcPts val="1200"/>
               </a:spcAft>
               <a:buChar char="•"/>
+              <a:defRPr/>
             </a:lvl5pPr>
             <a:lvl6pPr marL="1752600" indent="-228600">
               <a:lnSpc>
@@ -2922,6 +3008,7 @@
                 <a:spcPts val="1200"/>
               </a:spcAft>
               <a:buChar char="•"/>
+              <a:defRPr/>
             </a:lvl6pPr>
             <a:lvl7pPr marL="2057400" indent="-228600">
               <a:lnSpc>
@@ -2934,6 +3021,7 @@
                 <a:spcPts val="1200"/>
               </a:spcAft>
               <a:buChar char="•"/>
+              <a:defRPr/>
             </a:lvl7pPr>
             <a:lvl8pPr marL="2362200" indent="-228600">
               <a:lnSpc>
@@ -2946,6 +3034,7 @@
                 <a:spcPts val="1200"/>
               </a:spcAft>
               <a:buChar char="•"/>
+              <a:defRPr/>
             </a:lvl8pPr>
             <a:lvl9pPr marL="2667000" indent="-228600">
               <a:lnSpc>
@@ -2958,6 +3047,7 @@
                 <a:spcPts val="1200"/>
               </a:spcAft>
               <a:buChar char="•"/>
+              <a:defRPr/>
             </a:lvl9pPr>
           </a:lstStyle>
           <a:p xmlns:a="http://schemas.openxmlformats.org/drawingml/2006/main"/>
@@ -3006,12 +3096,12 @@
   </p:cSld>
   <p:clrMap bg1="lt1" tx1="dk1" bg2="lt2" tx2="dk2" accent1="accent1" accent2="accent2" accent3="accent3" accent4="accent4" accent5="accent5" accent6="accent6" hlink="hlink" folHlink="folHlink"/>
   <p:sldLayoutIdLst>
-    <p:sldLayoutId xmlns:r="http://schemas.openxmlformats.org/officeDocument/2006/relationships" id="2147483649" r:id="R574a24bf91354821"/>
-    <p:sldLayoutId xmlns:r="http://schemas.openxmlformats.org/officeDocument/2006/relationships" id="2147483650" r:id="R9e29d66b16834e1a"/>
-    <p:sldLayoutId xmlns:r="http://schemas.openxmlformats.org/officeDocument/2006/relationships" id="2147483651" r:id="Rb7f5fa4cb24f439a"/>
-    <p:sldLayoutId xmlns:r="http://schemas.openxmlformats.org/officeDocument/2006/relationships" id="2147483652" r:id="R48f32a2f06674395"/>
-    <p:sldLayoutId xmlns:r="http://schemas.openxmlformats.org/officeDocument/2006/relationships" id="2147483653" r:id="Rd83ed97b59fd4521"/>
-    <p:sldLayoutId xmlns:r="http://schemas.openxmlformats.org/officeDocument/2006/relationships" id="2147483654" r:id="R9a921f819d034631"/>
+    <p:sldLayoutId xmlns:r="http://schemas.openxmlformats.org/officeDocument/2006/relationships" id="2147483649" r:id="R097c93bbbeec433d"/>
+    <p:sldLayoutId xmlns:r="http://schemas.openxmlformats.org/officeDocument/2006/relationships" id="2147483650" r:id="Rc493137d6e6e492f"/>
+    <p:sldLayoutId xmlns:r="http://schemas.openxmlformats.org/officeDocument/2006/relationships" id="2147483651" r:id="Rab77c39b35d44316"/>
+    <p:sldLayoutId xmlns:r="http://schemas.openxmlformats.org/officeDocument/2006/relationships" id="2147483652" r:id="R26542f41e1e2449d"/>
+    <p:sldLayoutId xmlns:r="http://schemas.openxmlformats.org/officeDocument/2006/relationships" id="2147483653" r:id="Rfd0dd7112dbc446a"/>
+    <p:sldLayoutId xmlns:r="http://schemas.openxmlformats.org/officeDocument/2006/relationships" id="2147483654" r:id="Rcec98640960f45b2"/>
   </p:sldLayoutIdLst>
   <p:txStyles>
     <p:titleStyle>
@@ -3294,9 +3384,9 @@
 </file>
 
 <file path=ppt/slideMasters/theme/theme2.xml><?xml version="1.0" encoding="utf-8"?>
-<a:theme xmlns:a="http://schemas.openxmlformats.org/drawingml/2006/main" name="ChatGPT">
+<a:theme xmlns:a="http://schemas.openxmlformats.org/drawingml/2006/main" name="AlphaVault">
   <a:themeElements>
-    <a:clrScheme name="ChatGPT">
+    <a:clrScheme name="AlphaVault">
       <a:dk1>
         <a:srgbClr val="000000"/>
       </a:dk1>
@@ -3346,7 +3436,7 @@
         <a:cs typeface=""/>
       </a:minorFont>
     </a:fontScheme>
-    <a:fmtScheme name="ChatGPT">
+    <a:fmtScheme name="AlphaVault">
       <a:fillStyleLst>
         <a:solidFill>
           <a:schemeClr val="phClr"/>
@@ -5771,7 +5861,7 @@
           <p:cNvPr id="6" name="">
             <a:extLst xmlns:a="http://schemas.openxmlformats.org/drawingml/2006/main">
               <a:ext uri="{FF2B5EF4-FFF2-40B4-BE49-F238E27FC236}">
-                <a16:creationId xmlns:a16="http://schemas.microsoft.com/office/drawing/2014/main" id="{FA07DF03-45C4-4D56-8004-4107CD4B7288}"/>
+                <a16:creationId xmlns:a16="http://schemas.microsoft.com/office/drawing/2014/main" id="{33480117-C91C-4DBB-916E-FE86581F9FEE}"/>
               </a:ext>
             </a:extLst>
           </p:cNvPr>
@@ -5809,6 +5899,7 @@
           </a:lstStyle>
           <a:p xmlns:a="http://schemas.openxmlformats.org/drawingml/2006/main">
             <a:pPr>
+              <a:buNone/>
               <a:defRPr sz="3150" b="1">
                 <a:solidFill>
                   <a:srgbClr val="173F50"/>
@@ -5837,7 +5928,7 @@
           <p:cNvPr id="2" name="">
             <a:extLst xmlns:a="http://schemas.openxmlformats.org/drawingml/2006/main">
               <a:ext uri="{FF2B5EF4-FFF2-40B4-BE49-F238E27FC236}">
-                <a16:creationId xmlns:a16="http://schemas.microsoft.com/office/drawing/2014/main" id="{58337263-B639-4CBA-A558-44CBB3B398B4}"/>
+                <a16:creationId xmlns:a16="http://schemas.microsoft.com/office/drawing/2014/main" id="{87FFB964-690B-4D40-B39C-A0139A5C4E96}"/>
               </a:ext>
             </a:extLst>
           </p:cNvPr>
@@ -5875,6 +5966,7 @@
           </a:lstStyle>
           <a:p xmlns:a="http://schemas.openxmlformats.org/drawingml/2006/main">
             <a:pPr>
+              <a:buNone/>
               <a:defRPr sz="1275" b="0">
                 <a:solidFill>
                   <a:srgbClr val="173F50"/>
@@ -5893,7 +5985,7 @@
                 <a:ea typeface="Arial"/>
                 <a:cs typeface="Arial"/>
               </a:rPr>
-              <a:t>AlphaVault  /  Du zhuotong  /  1 of 12</a:t>
+              <a:t>1 of 12</a:t>
             </a:r>
           </a:p>
         </p:txBody>
@@ -5903,7 +5995,7 @@
           <p:cNvPr id="3" name="">
             <a:extLst xmlns:a="http://schemas.openxmlformats.org/drawingml/2006/main">
               <a:ext uri="{FF2B5EF4-FFF2-40B4-BE49-F238E27FC236}">
-                <a16:creationId xmlns:a16="http://schemas.microsoft.com/office/drawing/2014/main" id="{01E2B7B0-F77C-45F3-B1B4-E470F452EDFC}"/>
+                <a16:creationId xmlns:a16="http://schemas.microsoft.com/office/drawing/2014/main" id="{3348060B-DF21-4BA2-9778-7E9FD1C633B7}"/>
               </a:ext>
             </a:extLst>
           </p:cNvPr>
@@ -5941,6 +6033,7 @@
           </a:lstStyle>
           <a:p xmlns:a="http://schemas.openxmlformats.org/drawingml/2006/main">
             <a:pPr>
+              <a:buNone/>
               <a:defRPr sz="4125" b="1">
                 <a:solidFill>
                   <a:srgbClr val="173F50"/>
@@ -5964,6 +6057,7 @@
           </a:p>
           <a:p xmlns:a="http://schemas.openxmlformats.org/drawingml/2006/main">
             <a:pPr>
+              <a:buNone/>
               <a:defRPr sz="4125" b="1">
                 <a:solidFill>
                   <a:srgbClr val="173F50"/>
@@ -5992,7 +6086,7 @@
           <p:cNvPr id="4" name="">
             <a:extLst xmlns:a="http://schemas.openxmlformats.org/drawingml/2006/main">
               <a:ext uri="{FF2B5EF4-FFF2-40B4-BE49-F238E27FC236}">
-                <a16:creationId xmlns:a16="http://schemas.microsoft.com/office/drawing/2014/main" id="{2AEBD797-55AB-4B2F-BF97-5D4E1EDDA80B}"/>
+                <a16:creationId xmlns:a16="http://schemas.microsoft.com/office/drawing/2014/main" id="{6060064A-58E9-4BEA-ACD6-AE8EAFE49FDD}"/>
               </a:ext>
             </a:extLst>
           </p:cNvPr>
@@ -6030,6 +6124,7 @@
           </a:lstStyle>
           <a:p xmlns:a="http://schemas.openxmlformats.org/drawingml/2006/main">
             <a:pPr>
+              <a:buNone/>
               <a:defRPr sz="2400" b="0">
                 <a:solidFill>
                   <a:srgbClr val="173F50"/>
@@ -6058,7 +6153,7 @@
           <p:cNvPr id="5" name="">
             <a:extLst xmlns:a="http://schemas.openxmlformats.org/drawingml/2006/main">
               <a:ext uri="{FF2B5EF4-FFF2-40B4-BE49-F238E27FC236}">
-                <a16:creationId xmlns:a16="http://schemas.microsoft.com/office/drawing/2014/main" id="{9CA01499-12F1-484C-B9CD-4A8E9E211D44}"/>
+                <a16:creationId xmlns:a16="http://schemas.microsoft.com/office/drawing/2014/main" id="{6BE71989-7980-435F-B39E-FB7CB9A98F66}"/>
               </a:ext>
             </a:extLst>
           </p:cNvPr>
@@ -6096,6 +6191,7 @@
           </a:lstStyle>
           <a:p xmlns:a="http://schemas.openxmlformats.org/drawingml/2006/main">
             <a:pPr>
+              <a:buNone/>
               <a:defRPr sz="2100" b="0">
                 <a:solidFill>
                   <a:srgbClr val="173F50"/>
@@ -6114,7 +6210,7 @@
                 <a:ea typeface="Arial"/>
                 <a:cs typeface="Arial"/>
               </a:rPr>
-              <a:t>Du zhuotong  |  SC6113</a:t>
+              <a:t>Du Zhuotong  |  SC6113</a:t>
             </a:r>
           </a:p>
         </p:txBody>
@@ -6122,7 +6218,7 @@
     </p:spTree>
     <p:extLst>
       <p:ext uri="{BB962C8B-B14F-4D97-AF65-F5344CB8AC3E}">
-        <p14:creationId xmlns:p14="http://schemas.microsoft.com/office/powerpoint/2010/main" val="716744108"/>
+        <p14:creationId xmlns:p14="http://schemas.microsoft.com/office/powerpoint/2010/main" val="55216392"/>
       </p:ext>
     </p:extLst>
   </p:cSld>
@@ -6153,7 +6249,7 @@
           <p:cNvPr id="4" name="">
             <a:extLst xmlns:a="http://schemas.openxmlformats.org/drawingml/2006/main">
               <a:ext uri="{FF2B5EF4-FFF2-40B4-BE49-F238E27FC236}">
-                <a16:creationId xmlns:a16="http://schemas.microsoft.com/office/drawing/2014/main" id="{376662A6-48E4-4251-9329-E576257AB1F5}"/>
+                <a16:creationId xmlns:a16="http://schemas.microsoft.com/office/drawing/2014/main" id="{743D0E54-53EA-4FAF-A58C-C1E918F90467}"/>
               </a:ext>
             </a:extLst>
           </p:cNvPr>
@@ -6191,6 +6287,7 @@
           </a:lstStyle>
           <a:p xmlns:a="http://schemas.openxmlformats.org/drawingml/2006/main">
             <a:pPr>
+              <a:buNone/>
               <a:defRPr sz="3150" b="1">
                 <a:solidFill>
                   <a:srgbClr val="173F50"/>
@@ -6219,7 +6316,7 @@
           <p:cNvPr id="2" name="">
             <a:extLst xmlns:a="http://schemas.openxmlformats.org/drawingml/2006/main">
               <a:ext uri="{FF2B5EF4-FFF2-40B4-BE49-F238E27FC236}">
-                <a16:creationId xmlns:a16="http://schemas.microsoft.com/office/drawing/2014/main" id="{365367DA-8A36-4598-A965-7ACCA2F7C12B}"/>
+                <a16:creationId xmlns:a16="http://schemas.microsoft.com/office/drawing/2014/main" id="{E28CCDEF-76E0-47F5-83C3-E1688A31EFFA}"/>
               </a:ext>
             </a:extLst>
           </p:cNvPr>
@@ -6257,6 +6354,7 @@
           </a:lstStyle>
           <a:p xmlns:a="http://schemas.openxmlformats.org/drawingml/2006/main">
             <a:pPr>
+              <a:buNone/>
               <a:defRPr sz="1275" b="0">
                 <a:solidFill>
                   <a:srgbClr val="173F50"/>
@@ -6275,7 +6373,7 @@
                 <a:ea typeface="Arial"/>
                 <a:cs typeface="Arial"/>
               </a:rPr>
-              <a:t>AlphaVault  /  Du zhuotong  /  10 of 12</a:t>
+              <a:t>10 of 12</a:t>
             </a:r>
           </a:p>
         </p:txBody>
@@ -6285,7 +6383,7 @@
           <p:cNvPr id="3" name="">
             <a:extLst xmlns:a="http://schemas.openxmlformats.org/drawingml/2006/main">
               <a:ext uri="{FF2B5EF4-FFF2-40B4-BE49-F238E27FC236}">
-                <a16:creationId xmlns:a16="http://schemas.microsoft.com/office/drawing/2014/main" id="{5D4F5C1E-1CA8-4D4B-9E70-B65E2E11E7E6}"/>
+                <a16:creationId xmlns:a16="http://schemas.microsoft.com/office/drawing/2014/main" id="{4F473174-18D3-4CAE-9DE9-0DD2F905AC03}"/>
               </a:ext>
             </a:extLst>
           </p:cNvPr>
@@ -6369,7 +6467,7 @@
                           <a:ea typeface="Arial"/>
                           <a:cs typeface="Arial"/>
                         </a:rPr>
-                        <a:t>Latest full suite</a:t>
+                        <a:t>Automated suites</a:t>
                       </a:r>
                     </a:p>
                   </a:txBody>
@@ -6393,7 +6491,7 @@
                           <a:ea typeface="Arial"/>
                           <a:cs typeface="Arial"/>
                         </a:rPr>
-                        <a:t>64 passed / 0 failed</a:t>
+                        <a:t>36 Flask + 64 regression tests passed</a:t>
                       </a:r>
                     </a:p>
                   </a:txBody>
@@ -6443,7 +6541,7 @@
                           <a:ea typeface="Arial"/>
                           <a:cs typeface="Arial"/>
                         </a:rPr>
-                        <a:t>Wallet mode / PostgreSQL / expected Sepolia vault</a:t>
+                        <a:t>Flask / PostgreSQL / expected Sepolia vault</a:t>
                       </a:r>
                     </a:p>
                   </a:txBody>
@@ -6611,7 +6709,7 @@
     </p:spTree>
     <p:extLst>
       <p:ext uri="{BB962C8B-B14F-4D97-AF65-F5344CB8AC3E}">
-        <p14:creationId xmlns:p14="http://schemas.microsoft.com/office/powerpoint/2010/main" val="2118534275"/>
+        <p14:creationId xmlns:p14="http://schemas.microsoft.com/office/powerpoint/2010/main" val="695340833"/>
       </p:ext>
     </p:extLst>
   </p:cSld>
@@ -6642,7 +6740,7 @@
           <p:cNvPr id="5" name="">
             <a:extLst xmlns:a="http://schemas.openxmlformats.org/drawingml/2006/main">
               <a:ext uri="{FF2B5EF4-FFF2-40B4-BE49-F238E27FC236}">
-                <a16:creationId xmlns:a16="http://schemas.microsoft.com/office/drawing/2014/main" id="{13AB003C-960C-416F-9EB4-3DD1E8B42CBB}"/>
+                <a16:creationId xmlns:a16="http://schemas.microsoft.com/office/drawing/2014/main" id="{1B719456-BD19-4EA3-89FC-0681F076F706}"/>
               </a:ext>
             </a:extLst>
           </p:cNvPr>
@@ -6680,6 +6778,7 @@
           </a:lstStyle>
           <a:p xmlns:a="http://schemas.openxmlformats.org/drawingml/2006/main">
             <a:pPr>
+              <a:buNone/>
               <a:defRPr sz="3150" b="1">
                 <a:solidFill>
                   <a:srgbClr val="173F50"/>
@@ -6708,7 +6807,7 @@
           <p:cNvPr id="2" name="">
             <a:extLst xmlns:a="http://schemas.openxmlformats.org/drawingml/2006/main">
               <a:ext uri="{FF2B5EF4-FFF2-40B4-BE49-F238E27FC236}">
-                <a16:creationId xmlns:a16="http://schemas.microsoft.com/office/drawing/2014/main" id="{AB747BF9-A620-4E7A-96CB-A6D9EEDF92C8}"/>
+                <a16:creationId xmlns:a16="http://schemas.microsoft.com/office/drawing/2014/main" id="{26FEF94F-4948-48E3-B57D-B3D6C109F074}"/>
               </a:ext>
             </a:extLst>
           </p:cNvPr>
@@ -6746,6 +6845,7 @@
           </a:lstStyle>
           <a:p xmlns:a="http://schemas.openxmlformats.org/drawingml/2006/main">
             <a:pPr>
+              <a:buNone/>
               <a:defRPr sz="1275" b="0">
                 <a:solidFill>
                   <a:srgbClr val="173F50"/>
@@ -6764,7 +6864,7 @@
                 <a:ea typeface="Arial"/>
                 <a:cs typeface="Arial"/>
               </a:rPr>
-              <a:t>AlphaVault  /  Du zhuotong  /  11 of 12</a:t>
+              <a:t>11 of 12</a:t>
             </a:r>
           </a:p>
         </p:txBody>
@@ -6774,7 +6874,7 @@
           <p:cNvPr id="3" name="">
             <a:extLst xmlns:a="http://schemas.openxmlformats.org/drawingml/2006/main">
               <a:ext uri="{FF2B5EF4-FFF2-40B4-BE49-F238E27FC236}">
-                <a16:creationId xmlns:a16="http://schemas.microsoft.com/office/drawing/2014/main" id="{1430A4ED-BD32-410C-B5A8-D843ACAE2A44}"/>
+                <a16:creationId xmlns:a16="http://schemas.microsoft.com/office/drawing/2014/main" id="{5EAFF6F4-E782-41B1-A259-C9A40957B359}"/>
               </a:ext>
             </a:extLst>
           </p:cNvPr>
@@ -7052,7 +7152,7 @@
           <p:cNvPr id="4" name="">
             <a:extLst xmlns:a="http://schemas.openxmlformats.org/drawingml/2006/main">
               <a:ext uri="{FF2B5EF4-FFF2-40B4-BE49-F238E27FC236}">
-                <a16:creationId xmlns:a16="http://schemas.microsoft.com/office/drawing/2014/main" id="{FAD78490-9152-4A4D-8A11-5E26A4AEB88D}"/>
+                <a16:creationId xmlns:a16="http://schemas.microsoft.com/office/drawing/2014/main" id="{9B5E686B-25A1-4339-B6EB-BBADD10BAD10}"/>
               </a:ext>
             </a:extLst>
           </p:cNvPr>
@@ -7090,6 +7190,7 @@
           </a:lstStyle>
           <a:p xmlns:a="http://schemas.openxmlformats.org/drawingml/2006/main">
             <a:pPr>
+              <a:buNone/>
               <a:defRPr sz="2100" b="0">
                 <a:solidFill>
                   <a:srgbClr val="173F50"/>
@@ -7116,7 +7217,7 @@
     </p:spTree>
     <p:extLst>
       <p:ext uri="{BB962C8B-B14F-4D97-AF65-F5344CB8AC3E}">
-        <p14:creationId xmlns:p14="http://schemas.microsoft.com/office/powerpoint/2010/main" val="2118817506"/>
+        <p14:creationId xmlns:p14="http://schemas.microsoft.com/office/powerpoint/2010/main" val="931790703"/>
       </p:ext>
     </p:extLst>
   </p:cSld>
@@ -7147,7 +7248,7 @@
           <p:cNvPr id="7" name="">
             <a:extLst xmlns:a="http://schemas.openxmlformats.org/drawingml/2006/main">
               <a:ext uri="{FF2B5EF4-FFF2-40B4-BE49-F238E27FC236}">
-                <a16:creationId xmlns:a16="http://schemas.microsoft.com/office/drawing/2014/main" id="{1FF62769-75A3-447B-BFA9-D97F5FB18D6E}"/>
+                <a16:creationId xmlns:a16="http://schemas.microsoft.com/office/drawing/2014/main" id="{27222899-5060-4CE3-8322-AA16D9B41B38}"/>
               </a:ext>
             </a:extLst>
           </p:cNvPr>
@@ -7185,6 +7286,7 @@
           </a:lstStyle>
           <a:p xmlns:a="http://schemas.openxmlformats.org/drawingml/2006/main">
             <a:pPr>
+              <a:buNone/>
               <a:defRPr sz="3150" b="1">
                 <a:solidFill>
                   <a:srgbClr val="173F50"/>
@@ -7213,7 +7315,7 @@
           <p:cNvPr id="2" name="">
             <a:extLst xmlns:a="http://schemas.openxmlformats.org/drawingml/2006/main">
               <a:ext uri="{FF2B5EF4-FFF2-40B4-BE49-F238E27FC236}">
-                <a16:creationId xmlns:a16="http://schemas.microsoft.com/office/drawing/2014/main" id="{159BF2E5-5C8C-484F-AFE7-E8BA3DABA9BA}"/>
+                <a16:creationId xmlns:a16="http://schemas.microsoft.com/office/drawing/2014/main" id="{B2202D99-C77C-40A9-8D49-FE912C2FDF38}"/>
               </a:ext>
             </a:extLst>
           </p:cNvPr>
@@ -7251,6 +7353,7 @@
           </a:lstStyle>
           <a:p xmlns:a="http://schemas.openxmlformats.org/drawingml/2006/main">
             <a:pPr>
+              <a:buNone/>
               <a:defRPr sz="1275" b="0">
                 <a:solidFill>
                   <a:srgbClr val="173F50"/>
@@ -7269,7 +7372,7 @@
                 <a:ea typeface="Arial"/>
                 <a:cs typeface="Arial"/>
               </a:rPr>
-              <a:t>AlphaVault  /  Du zhuotong  /  12 of 12</a:t>
+              <a:t>12 of 12</a:t>
             </a:r>
           </a:p>
         </p:txBody>
@@ -7279,7 +7382,7 @@
           <p:cNvPr id="3" name="">
             <a:extLst xmlns:a="http://schemas.openxmlformats.org/drawingml/2006/main">
               <a:ext uri="{FF2B5EF4-FFF2-40B4-BE49-F238E27FC236}">
-                <a16:creationId xmlns:a16="http://schemas.microsoft.com/office/drawing/2014/main" id="{6CFFBAA9-90EE-4393-9EFA-F446A6312245}"/>
+                <a16:creationId xmlns:a16="http://schemas.microsoft.com/office/drawing/2014/main" id="{E6A988CA-BF81-45C4-A0F4-914513217E5B}"/>
               </a:ext>
             </a:extLst>
           </p:cNvPr>
@@ -7317,6 +7420,7 @@
           </a:lstStyle>
           <a:p xmlns:a="http://schemas.openxmlformats.org/drawingml/2006/main">
             <a:pPr>
+              <a:buNone/>
               <a:defRPr sz="2400" b="1">
                 <a:solidFill>
                   <a:srgbClr val="173F50"/>
@@ -7345,7 +7449,7 @@
           <p:cNvPr id="4" name="">
             <a:extLst xmlns:a="http://schemas.openxmlformats.org/drawingml/2006/main">
               <a:ext uri="{FF2B5EF4-FFF2-40B4-BE49-F238E27FC236}">
-                <a16:creationId xmlns:a16="http://schemas.microsoft.com/office/drawing/2014/main" id="{929C84EE-E440-4BD3-AAC3-85270F61AA92}"/>
+                <a16:creationId xmlns:a16="http://schemas.microsoft.com/office/drawing/2014/main" id="{2AC7799D-F7DF-4E5E-AB0C-C1DF51F08048}"/>
               </a:ext>
             </a:extLst>
           </p:cNvPr>
@@ -7383,6 +7487,7 @@
           </a:lstStyle>
           <a:p xmlns:a="http://schemas.openxmlformats.org/drawingml/2006/main">
             <a:pPr>
+              <a:buNone/>
               <a:defRPr sz="2175" b="0">
                 <a:solidFill>
                   <a:srgbClr val="173F50"/>
@@ -7406,6 +7511,7 @@
           </a:p>
           <a:p xmlns:a="http://schemas.openxmlformats.org/drawingml/2006/main">
             <a:pPr>
+              <a:buNone/>
               <a:defRPr sz="2175" b="0">
                 <a:solidFill>
                   <a:srgbClr val="173F50"/>
@@ -7429,6 +7535,7 @@
           </a:p>
           <a:p xmlns:a="http://schemas.openxmlformats.org/drawingml/2006/main">
             <a:pPr>
+              <a:buNone/>
               <a:defRPr sz="2175" b="0">
                 <a:solidFill>
                   <a:srgbClr val="173F50"/>
@@ -7447,7 +7554,7 @@
                 <a:ea typeface="Arial"/>
                 <a:cs typeface="Arial"/>
               </a:rPr>
-              <a:t>Source, tests, deployment evidence and ten-minute video</a:t>
+              <a:t>Solidity, ABI, Flask, HTML/CSS/JS, tests and video</a:t>
             </a:r>
           </a:p>
         </p:txBody>
@@ -7457,7 +7564,7 @@
           <p:cNvPr id="5" name="">
             <a:extLst xmlns:a="http://schemas.openxmlformats.org/drawingml/2006/main">
               <a:ext uri="{FF2B5EF4-FFF2-40B4-BE49-F238E27FC236}">
-                <a16:creationId xmlns:a16="http://schemas.microsoft.com/office/drawing/2014/main" id="{86D3133E-D3AC-4B70-B35D-B8B2CBFFBEB2}"/>
+                <a16:creationId xmlns:a16="http://schemas.microsoft.com/office/drawing/2014/main" id="{29895771-2DE0-4503-A405-0F2F9C219112}"/>
               </a:ext>
             </a:extLst>
           </p:cNvPr>
@@ -7495,6 +7602,7 @@
           </a:lstStyle>
           <a:p xmlns:a="http://schemas.openxmlformats.org/drawingml/2006/main">
             <a:pPr>
+              <a:buNone/>
               <a:defRPr sz="2175" b="0">
                 <a:solidFill>
                   <a:srgbClr val="173F50"/>
@@ -7518,6 +7626,7 @@
           </a:p>
           <a:p xmlns:a="http://schemas.openxmlformats.org/drawingml/2006/main">
             <a:pPr>
+              <a:buNone/>
               <a:defRPr sz="2175" b="0">
                 <a:solidFill>
                   <a:srgbClr val="173F50"/>
@@ -7546,7 +7655,7 @@
           <p:cNvPr id="6" name="">
             <a:extLst xmlns:a="http://schemas.openxmlformats.org/drawingml/2006/main">
               <a:ext uri="{FF2B5EF4-FFF2-40B4-BE49-F238E27FC236}">
-                <a16:creationId xmlns:a16="http://schemas.microsoft.com/office/drawing/2014/main" id="{3306AEB2-1F10-4225-832B-69B0A8382F7A}"/>
+                <a16:creationId xmlns:a16="http://schemas.microsoft.com/office/drawing/2014/main" id="{55A630EF-6151-4442-B91D-D87A8F2E82C9}"/>
               </a:ext>
             </a:extLst>
           </p:cNvPr>
@@ -7584,6 +7693,7 @@
           </a:lstStyle>
           <a:p xmlns:a="http://schemas.openxmlformats.org/drawingml/2006/main">
             <a:pPr>
+              <a:buNone/>
               <a:defRPr sz="1800" b="0">
                 <a:solidFill>
                   <a:srgbClr val="173F50"/>
@@ -7610,7 +7720,7 @@
     </p:spTree>
     <p:extLst>
       <p:ext uri="{BB962C8B-B14F-4D97-AF65-F5344CB8AC3E}">
-        <p14:creationId xmlns:p14="http://schemas.microsoft.com/office/powerpoint/2010/main" val="2109374202"/>
+        <p14:creationId xmlns:p14="http://schemas.microsoft.com/office/powerpoint/2010/main" val="509706240"/>
       </p:ext>
     </p:extLst>
   </p:cSld>
@@ -7641,7 +7751,7 @@
           <p:cNvPr id="6" name="">
             <a:extLst xmlns:a="http://schemas.openxmlformats.org/drawingml/2006/main">
               <a:ext uri="{FF2B5EF4-FFF2-40B4-BE49-F238E27FC236}">
-                <a16:creationId xmlns:a16="http://schemas.microsoft.com/office/drawing/2014/main" id="{B607A217-EF57-4F81-A82E-0C7A8E40BB0F}"/>
+                <a16:creationId xmlns:a16="http://schemas.microsoft.com/office/drawing/2014/main" id="{57B40992-59B9-46D9-ADDF-9FC8F64F733A}"/>
               </a:ext>
             </a:extLst>
           </p:cNvPr>
@@ -7679,6 +7789,7 @@
           </a:lstStyle>
           <a:p xmlns:a="http://schemas.openxmlformats.org/drawingml/2006/main">
             <a:pPr>
+              <a:buNone/>
               <a:defRPr sz="3150" b="1">
                 <a:solidFill>
                   <a:srgbClr val="173F50"/>
@@ -7707,7 +7818,7 @@
           <p:cNvPr id="2" name="">
             <a:extLst xmlns:a="http://schemas.openxmlformats.org/drawingml/2006/main">
               <a:ext uri="{FF2B5EF4-FFF2-40B4-BE49-F238E27FC236}">
-                <a16:creationId xmlns:a16="http://schemas.microsoft.com/office/drawing/2014/main" id="{7A5B61CC-EC38-4969-BF3E-B9ED74DBD1D6}"/>
+                <a16:creationId xmlns:a16="http://schemas.microsoft.com/office/drawing/2014/main" id="{EA60B86A-EEFD-4EC0-8BB0-907C2F99BB5C}"/>
               </a:ext>
             </a:extLst>
           </p:cNvPr>
@@ -7745,6 +7856,7 @@
           </a:lstStyle>
           <a:p xmlns:a="http://schemas.openxmlformats.org/drawingml/2006/main">
             <a:pPr>
+              <a:buNone/>
               <a:defRPr sz="1275" b="0">
                 <a:solidFill>
                   <a:srgbClr val="173F50"/>
@@ -7763,7 +7875,7 @@
                 <a:ea typeface="Arial"/>
                 <a:cs typeface="Arial"/>
               </a:rPr>
-              <a:t>AlphaVault  /  Du zhuotong  /  2 of 12</a:t>
+              <a:t>2 of 12</a:t>
             </a:r>
           </a:p>
         </p:txBody>
@@ -7773,7 +7885,7 @@
           <p:cNvPr id="3" name="">
             <a:extLst xmlns:a="http://schemas.openxmlformats.org/drawingml/2006/main">
               <a:ext uri="{FF2B5EF4-FFF2-40B4-BE49-F238E27FC236}">
-                <a16:creationId xmlns:a16="http://schemas.microsoft.com/office/drawing/2014/main" id="{2D54F241-BB2A-4A12-BC9E-D58F480EFE9F}"/>
+                <a16:creationId xmlns:a16="http://schemas.microsoft.com/office/drawing/2014/main" id="{763D697C-59F4-4E3F-BF3C-27680B0F2882}"/>
               </a:ext>
             </a:extLst>
           </p:cNvPr>
@@ -7811,6 +7923,7 @@
           </a:lstStyle>
           <a:p xmlns:a="http://schemas.openxmlformats.org/drawingml/2006/main">
             <a:pPr>
+              <a:buNone/>
               <a:defRPr sz="2325" b="0">
                 <a:solidFill>
                   <a:srgbClr val="173F50"/>
@@ -7839,7 +7952,7 @@
           <p:cNvPr id="4" name="">
             <a:extLst xmlns:a="http://schemas.openxmlformats.org/drawingml/2006/main">
               <a:ext uri="{FF2B5EF4-FFF2-40B4-BE49-F238E27FC236}">
-                <a16:creationId xmlns:a16="http://schemas.microsoft.com/office/drawing/2014/main" id="{F89E3A2B-5D58-420D-8A44-9C81017C9354}"/>
+                <a16:creationId xmlns:a16="http://schemas.microsoft.com/office/drawing/2014/main" id="{3780FF50-52CB-4E5F-AF4B-6EDAA8A61C6C}"/>
               </a:ext>
             </a:extLst>
           </p:cNvPr>
@@ -8238,7 +8351,7 @@
           <p:cNvPr id="5" name="">
             <a:extLst xmlns:a="http://schemas.openxmlformats.org/drawingml/2006/main">
               <a:ext uri="{FF2B5EF4-FFF2-40B4-BE49-F238E27FC236}">
-                <a16:creationId xmlns:a16="http://schemas.microsoft.com/office/drawing/2014/main" id="{A61A8D73-7E10-4915-BF97-74623B960D6F}"/>
+                <a16:creationId xmlns:a16="http://schemas.microsoft.com/office/drawing/2014/main" id="{4A16E31D-A9EC-4D1A-BC72-C895C8C00F36}"/>
               </a:ext>
             </a:extLst>
           </p:cNvPr>
@@ -8276,6 +8389,7 @@
           </a:lstStyle>
           <a:p xmlns:a="http://schemas.openxmlformats.org/drawingml/2006/main">
             <a:pPr>
+              <a:buNone/>
               <a:defRPr sz="1875" b="0">
                 <a:solidFill>
                   <a:srgbClr val="173F50"/>
@@ -8302,7 +8416,7 @@
     </p:spTree>
     <p:extLst>
       <p:ext uri="{BB962C8B-B14F-4D97-AF65-F5344CB8AC3E}">
-        <p14:creationId xmlns:p14="http://schemas.microsoft.com/office/powerpoint/2010/main" val="2133195321"/>
+        <p14:creationId xmlns:p14="http://schemas.microsoft.com/office/powerpoint/2010/main" val="275932110"/>
       </p:ext>
     </p:extLst>
   </p:cSld>
@@ -8333,7 +8447,7 @@
           <p:cNvPr id="4" name="">
             <a:extLst xmlns:a="http://schemas.openxmlformats.org/drawingml/2006/main">
               <a:ext uri="{FF2B5EF4-FFF2-40B4-BE49-F238E27FC236}">
-                <a16:creationId xmlns:a16="http://schemas.microsoft.com/office/drawing/2014/main" id="{CA846238-02FA-44A9-934A-5CEA4833196F}"/>
+                <a16:creationId xmlns:a16="http://schemas.microsoft.com/office/drawing/2014/main" id="{B448848D-A159-410D-B1F9-75BB062CC9EB}"/>
               </a:ext>
             </a:extLst>
           </p:cNvPr>
@@ -8371,6 +8485,7 @@
           </a:lstStyle>
           <a:p xmlns:a="http://schemas.openxmlformats.org/drawingml/2006/main">
             <a:pPr>
+              <a:buNone/>
               <a:defRPr sz="3150" b="1">
                 <a:solidFill>
                   <a:srgbClr val="173F50"/>
@@ -8399,7 +8514,7 @@
           <p:cNvPr id="2" name="">
             <a:extLst xmlns:a="http://schemas.openxmlformats.org/drawingml/2006/main">
               <a:ext uri="{FF2B5EF4-FFF2-40B4-BE49-F238E27FC236}">
-                <a16:creationId xmlns:a16="http://schemas.microsoft.com/office/drawing/2014/main" id="{4E5966B3-44FF-44B9-B88E-F69424C1F0CA}"/>
+                <a16:creationId xmlns:a16="http://schemas.microsoft.com/office/drawing/2014/main" id="{3238731A-C398-4348-9384-19C55F60A4A5}"/>
               </a:ext>
             </a:extLst>
           </p:cNvPr>
@@ -8437,6 +8552,7 @@
           </a:lstStyle>
           <a:p xmlns:a="http://schemas.openxmlformats.org/drawingml/2006/main">
             <a:pPr>
+              <a:buNone/>
               <a:defRPr sz="1275" b="0">
                 <a:solidFill>
                   <a:srgbClr val="173F50"/>
@@ -8455,7 +8571,7 @@
                 <a:ea typeface="Arial"/>
                 <a:cs typeface="Arial"/>
               </a:rPr>
-              <a:t>AlphaVault  /  Du zhuotong  /  3 of 12</a:t>
+              <a:t>3 of 12</a:t>
             </a:r>
           </a:p>
         </p:txBody>
@@ -8465,7 +8581,7 @@
           <p:cNvPr id="3" name="">
             <a:extLst xmlns:a="http://schemas.openxmlformats.org/drawingml/2006/main">
               <a:ext uri="{FF2B5EF4-FFF2-40B4-BE49-F238E27FC236}">
-                <a16:creationId xmlns:a16="http://schemas.microsoft.com/office/drawing/2014/main" id="{A73CFBFC-89AC-4E02-B594-DF5721A17A02}"/>
+                <a16:creationId xmlns:a16="http://schemas.microsoft.com/office/drawing/2014/main" id="{1B581599-CFDB-4AA4-B320-13B3D28C06DE}"/>
               </a:ext>
             </a:extLst>
           </p:cNvPr>
@@ -8475,8 +8591,11 @@
           <p:nvPr/>
         </p:nvPicPr>
         <p:blipFill>
-          <a:blip xmlns:r="http://schemas.openxmlformats.org/officeDocument/2006/relationships" xmlns:a="http://schemas.openxmlformats.org/drawingml/2006/main" r:embed="Rf4be8d3056bb43c8"/>
-          <a:stretch xmlns:a="http://schemas.openxmlformats.org/drawingml/2006/main"/>
+          <a:blip xmlns:r="http://schemas.openxmlformats.org/officeDocument/2006/relationships" xmlns:a="http://schemas.openxmlformats.org/drawingml/2006/main" r:embed="R6fda511d996740ba"/>
+          <a:srcRect xmlns:a="http://schemas.openxmlformats.org/drawingml/2006/main" l="0" t="0" r="0" b="0"/>
+          <a:stretch xmlns:a="http://schemas.openxmlformats.org/drawingml/2006/main">
+            <a:fillRect l="0" t="0" r="0" b="0"/>
+          </a:stretch>
         </p:blipFill>
         <p:spPr>
           <a:xfrm xmlns:a="http://schemas.openxmlformats.org/drawingml/2006/main">
@@ -8491,7 +8610,7 @@
     </p:spTree>
     <p:extLst>
       <p:ext uri="{BB962C8B-B14F-4D97-AF65-F5344CB8AC3E}">
-        <p14:creationId xmlns:p14="http://schemas.microsoft.com/office/powerpoint/2010/main" val="1549362706"/>
+        <p14:creationId xmlns:p14="http://schemas.microsoft.com/office/powerpoint/2010/main" val="1437699212"/>
       </p:ext>
     </p:extLst>
   </p:cSld>
@@ -8522,7 +8641,7 @@
           <p:cNvPr id="4" name="">
             <a:extLst xmlns:a="http://schemas.openxmlformats.org/drawingml/2006/main">
               <a:ext uri="{FF2B5EF4-FFF2-40B4-BE49-F238E27FC236}">
-                <a16:creationId xmlns:a16="http://schemas.microsoft.com/office/drawing/2014/main" id="{695579E5-5F21-468D-8B11-010C6EE0222F}"/>
+                <a16:creationId xmlns:a16="http://schemas.microsoft.com/office/drawing/2014/main" id="{9CA53284-8CEE-4F06-8D47-E41BB5054802}"/>
               </a:ext>
             </a:extLst>
           </p:cNvPr>
@@ -8560,6 +8679,7 @@
           </a:lstStyle>
           <a:p xmlns:a="http://schemas.openxmlformats.org/drawingml/2006/main">
             <a:pPr>
+              <a:buNone/>
               <a:defRPr sz="3150" b="1">
                 <a:solidFill>
                   <a:srgbClr val="173F50"/>
@@ -8588,7 +8708,7 @@
           <p:cNvPr id="2" name="">
             <a:extLst xmlns:a="http://schemas.openxmlformats.org/drawingml/2006/main">
               <a:ext uri="{FF2B5EF4-FFF2-40B4-BE49-F238E27FC236}">
-                <a16:creationId xmlns:a16="http://schemas.microsoft.com/office/drawing/2014/main" id="{9DBD8525-DF91-4417-8D26-7DC150061606}"/>
+                <a16:creationId xmlns:a16="http://schemas.microsoft.com/office/drawing/2014/main" id="{77594C66-1116-4308-8D14-1A47AC41D4A3}"/>
               </a:ext>
             </a:extLst>
           </p:cNvPr>
@@ -8626,6 +8746,7 @@
           </a:lstStyle>
           <a:p xmlns:a="http://schemas.openxmlformats.org/drawingml/2006/main">
             <a:pPr>
+              <a:buNone/>
               <a:defRPr sz="1275" b="0">
                 <a:solidFill>
                   <a:srgbClr val="173F50"/>
@@ -8644,7 +8765,7 @@
                 <a:ea typeface="Arial"/>
                 <a:cs typeface="Arial"/>
               </a:rPr>
-              <a:t>AlphaVault  /  Du zhuotong  /  4 of 12</a:t>
+              <a:t>4 of 12</a:t>
             </a:r>
           </a:p>
         </p:txBody>
@@ -8654,7 +8775,7 @@
           <p:cNvPr id="3" name="">
             <a:extLst xmlns:a="http://schemas.openxmlformats.org/drawingml/2006/main">
               <a:ext uri="{FF2B5EF4-FFF2-40B4-BE49-F238E27FC236}">
-                <a16:creationId xmlns:a16="http://schemas.microsoft.com/office/drawing/2014/main" id="{596BB8E3-1E82-4D93-8DF8-EFC26ADD66B6}"/>
+                <a16:creationId xmlns:a16="http://schemas.microsoft.com/office/drawing/2014/main" id="{2B03C54E-E263-4C91-A9A6-A4A766598F1E}"/>
               </a:ext>
             </a:extLst>
           </p:cNvPr>
@@ -8664,7 +8785,7 @@
           <p:nvPr/>
         </p:nvPicPr>
         <p:blipFill>
-          <a:blip xmlns:r="http://schemas.openxmlformats.org/officeDocument/2006/relationships" xmlns:a="http://schemas.openxmlformats.org/drawingml/2006/main" r:embed="Rea0675274145406f"/>
+          <a:blip xmlns:r="http://schemas.openxmlformats.org/officeDocument/2006/relationships" xmlns:a="http://schemas.openxmlformats.org/drawingml/2006/main" r:embed="R770a21d2c3e84f53"/>
           <a:stretch xmlns:a="http://schemas.openxmlformats.org/drawingml/2006/main"/>
         </p:blipFill>
         <p:spPr>
@@ -8680,7 +8801,7 @@
     </p:spTree>
     <p:extLst>
       <p:ext uri="{BB962C8B-B14F-4D97-AF65-F5344CB8AC3E}">
-        <p14:creationId xmlns:p14="http://schemas.microsoft.com/office/powerpoint/2010/main" val="579562243"/>
+        <p14:creationId xmlns:p14="http://schemas.microsoft.com/office/powerpoint/2010/main" val="1389828653"/>
       </p:ext>
     </p:extLst>
   </p:cSld>
@@ -8711,7 +8832,7 @@
           <p:cNvPr id="4" name="">
             <a:extLst xmlns:a="http://schemas.openxmlformats.org/drawingml/2006/main">
               <a:ext uri="{FF2B5EF4-FFF2-40B4-BE49-F238E27FC236}">
-                <a16:creationId xmlns:a16="http://schemas.microsoft.com/office/drawing/2014/main" id="{FEC4B659-2D22-40FE-B7BD-976D1A2A4251}"/>
+                <a16:creationId xmlns:a16="http://schemas.microsoft.com/office/drawing/2014/main" id="{CF2E62E2-D243-4B0A-8526-E5F429C3EEE3}"/>
               </a:ext>
             </a:extLst>
           </p:cNvPr>
@@ -8749,6 +8870,7 @@
           </a:lstStyle>
           <a:p xmlns:a="http://schemas.openxmlformats.org/drawingml/2006/main">
             <a:pPr>
+              <a:buNone/>
               <a:defRPr sz="3150" b="1">
                 <a:solidFill>
                   <a:srgbClr val="173F50"/>
@@ -8777,7 +8899,7 @@
           <p:cNvPr id="2" name="">
             <a:extLst xmlns:a="http://schemas.openxmlformats.org/drawingml/2006/main">
               <a:ext uri="{FF2B5EF4-FFF2-40B4-BE49-F238E27FC236}">
-                <a16:creationId xmlns:a16="http://schemas.microsoft.com/office/drawing/2014/main" id="{1A65C9F7-5DE8-4093-A834-7B7C87267D42}"/>
+                <a16:creationId xmlns:a16="http://schemas.microsoft.com/office/drawing/2014/main" id="{9B447AEF-3376-4A28-9231-659BD660C512}"/>
               </a:ext>
             </a:extLst>
           </p:cNvPr>
@@ -8815,6 +8937,7 @@
           </a:lstStyle>
           <a:p xmlns:a="http://schemas.openxmlformats.org/drawingml/2006/main">
             <a:pPr>
+              <a:buNone/>
               <a:defRPr sz="1275" b="0">
                 <a:solidFill>
                   <a:srgbClr val="173F50"/>
@@ -8833,7 +8956,7 @@
                 <a:ea typeface="Arial"/>
                 <a:cs typeface="Arial"/>
               </a:rPr>
-              <a:t>AlphaVault  /  Du zhuotong  /  5 of 12</a:t>
+              <a:t>5 of 12</a:t>
             </a:r>
           </a:p>
         </p:txBody>
@@ -8843,7 +8966,7 @@
           <p:cNvPr id="3" name="">
             <a:extLst xmlns:a="http://schemas.openxmlformats.org/drawingml/2006/main">
               <a:ext uri="{FF2B5EF4-FFF2-40B4-BE49-F238E27FC236}">
-                <a16:creationId xmlns:a16="http://schemas.microsoft.com/office/drawing/2014/main" id="{F5E9F3D8-74F1-4908-9C19-8A5B50707EF2}"/>
+                <a16:creationId xmlns:a16="http://schemas.microsoft.com/office/drawing/2014/main" id="{59206142-BDDD-4965-8C02-F234B1E91F2E}"/>
               </a:ext>
             </a:extLst>
           </p:cNvPr>
@@ -8853,7 +8976,7 @@
           <p:nvPr/>
         </p:nvPicPr>
         <p:blipFill>
-          <a:blip xmlns:r="http://schemas.openxmlformats.org/officeDocument/2006/relationships" xmlns:a="http://schemas.openxmlformats.org/drawingml/2006/main" r:embed="Rb738d4e2f8314c9e"/>
+          <a:blip xmlns:r="http://schemas.openxmlformats.org/officeDocument/2006/relationships" xmlns:a="http://schemas.openxmlformats.org/drawingml/2006/main" r:embed="Rba2d4d09be64487c"/>
           <a:stretch xmlns:a="http://schemas.openxmlformats.org/drawingml/2006/main"/>
         </p:blipFill>
         <p:spPr>
@@ -8869,7 +8992,7 @@
     </p:spTree>
     <p:extLst>
       <p:ext uri="{BB962C8B-B14F-4D97-AF65-F5344CB8AC3E}">
-        <p14:creationId xmlns:p14="http://schemas.microsoft.com/office/powerpoint/2010/main" val="642832048"/>
+        <p14:creationId xmlns:p14="http://schemas.microsoft.com/office/powerpoint/2010/main" val="444935995"/>
       </p:ext>
     </p:extLst>
   </p:cSld>
@@ -8900,7 +9023,7 @@
           <p:cNvPr id="4" name="">
             <a:extLst xmlns:a="http://schemas.openxmlformats.org/drawingml/2006/main">
               <a:ext uri="{FF2B5EF4-FFF2-40B4-BE49-F238E27FC236}">
-                <a16:creationId xmlns:a16="http://schemas.microsoft.com/office/drawing/2014/main" id="{E448EAD9-201C-4C83-A00A-A464B53E6D67}"/>
+                <a16:creationId xmlns:a16="http://schemas.microsoft.com/office/drawing/2014/main" id="{792BA565-E76D-4463-AE57-CF32778850BC}"/>
               </a:ext>
             </a:extLst>
           </p:cNvPr>
@@ -8938,6 +9061,7 @@
           </a:lstStyle>
           <a:p xmlns:a="http://schemas.openxmlformats.org/drawingml/2006/main">
             <a:pPr>
+              <a:buNone/>
               <a:defRPr sz="3150" b="1">
                 <a:solidFill>
                   <a:srgbClr val="173F50"/>
@@ -8966,7 +9090,7 @@
           <p:cNvPr id="2" name="">
             <a:extLst xmlns:a="http://schemas.openxmlformats.org/drawingml/2006/main">
               <a:ext uri="{FF2B5EF4-FFF2-40B4-BE49-F238E27FC236}">
-                <a16:creationId xmlns:a16="http://schemas.microsoft.com/office/drawing/2014/main" id="{81357DD9-05F4-484D-9EEB-A931FE15B3BB}"/>
+                <a16:creationId xmlns:a16="http://schemas.microsoft.com/office/drawing/2014/main" id="{CC7E8D74-B3AE-4583-845B-65F56B0ECE37}"/>
               </a:ext>
             </a:extLst>
           </p:cNvPr>
@@ -9004,6 +9128,7 @@
           </a:lstStyle>
           <a:p xmlns:a="http://schemas.openxmlformats.org/drawingml/2006/main">
             <a:pPr>
+              <a:buNone/>
               <a:defRPr sz="1275" b="0">
                 <a:solidFill>
                   <a:srgbClr val="173F50"/>
@@ -9022,7 +9147,7 @@
                 <a:ea typeface="Arial"/>
                 <a:cs typeface="Arial"/>
               </a:rPr>
-              <a:t>AlphaVault  /  Du zhuotong  /  6 of 12</a:t>
+              <a:t>6 of 12</a:t>
             </a:r>
           </a:p>
         </p:txBody>
@@ -9032,7 +9157,7 @@
           <p:cNvPr id="3" name="">
             <a:extLst xmlns:a="http://schemas.openxmlformats.org/drawingml/2006/main">
               <a:ext uri="{FF2B5EF4-FFF2-40B4-BE49-F238E27FC236}">
-                <a16:creationId xmlns:a16="http://schemas.microsoft.com/office/drawing/2014/main" id="{4F0B614A-3811-4FEB-A2DA-AAB71FFE6515}"/>
+                <a16:creationId xmlns:a16="http://schemas.microsoft.com/office/drawing/2014/main" id="{3AD82179-5806-476D-B309-92375FB28D77}"/>
               </a:ext>
             </a:extLst>
           </p:cNvPr>
@@ -9042,7 +9167,7 @@
           <p:nvPr/>
         </p:nvPicPr>
         <p:blipFill>
-          <a:blip xmlns:r="http://schemas.openxmlformats.org/officeDocument/2006/relationships" xmlns:a="http://schemas.openxmlformats.org/drawingml/2006/main" r:embed="R5caaa120b1da4f32"/>
+          <a:blip xmlns:r="http://schemas.openxmlformats.org/officeDocument/2006/relationships" xmlns:a="http://schemas.openxmlformats.org/drawingml/2006/main" r:embed="R7b5d8ebb196b402a"/>
           <a:stretch xmlns:a="http://schemas.openxmlformats.org/drawingml/2006/main"/>
         </p:blipFill>
         <p:spPr>
@@ -9058,7 +9183,7 @@
     </p:spTree>
     <p:extLst>
       <p:ext uri="{BB962C8B-B14F-4D97-AF65-F5344CB8AC3E}">
-        <p14:creationId xmlns:p14="http://schemas.microsoft.com/office/powerpoint/2010/main" val="1902113514"/>
+        <p14:creationId xmlns:p14="http://schemas.microsoft.com/office/powerpoint/2010/main" val="1040127978"/>
       </p:ext>
     </p:extLst>
   </p:cSld>
@@ -9089,7 +9214,7 @@
           <p:cNvPr id="4" name="">
             <a:extLst xmlns:a="http://schemas.openxmlformats.org/drawingml/2006/main">
               <a:ext uri="{FF2B5EF4-FFF2-40B4-BE49-F238E27FC236}">
-                <a16:creationId xmlns:a16="http://schemas.microsoft.com/office/drawing/2014/main" id="{37390D7D-9B4F-4668-86E1-895F91C5B30F}"/>
+                <a16:creationId xmlns:a16="http://schemas.microsoft.com/office/drawing/2014/main" id="{4F7EFB8A-63FD-4245-953F-BD330DDCD254}"/>
               </a:ext>
             </a:extLst>
           </p:cNvPr>
@@ -9127,6 +9252,7 @@
           </a:lstStyle>
           <a:p xmlns:a="http://schemas.openxmlformats.org/drawingml/2006/main">
             <a:pPr>
+              <a:buNone/>
               <a:defRPr sz="3150" b="1">
                 <a:solidFill>
                   <a:srgbClr val="173F50"/>
@@ -9155,7 +9281,7 @@
           <p:cNvPr id="2" name="">
             <a:extLst xmlns:a="http://schemas.openxmlformats.org/drawingml/2006/main">
               <a:ext uri="{FF2B5EF4-FFF2-40B4-BE49-F238E27FC236}">
-                <a16:creationId xmlns:a16="http://schemas.microsoft.com/office/drawing/2014/main" id="{9E1215D9-D31C-4F2D-90A0-0CA45F887C49}"/>
+                <a16:creationId xmlns:a16="http://schemas.microsoft.com/office/drawing/2014/main" id="{5A6EB0F8-8840-4F46-93E5-2E2A75C6E7C2}"/>
               </a:ext>
             </a:extLst>
           </p:cNvPr>
@@ -9193,6 +9319,7 @@
           </a:lstStyle>
           <a:p xmlns:a="http://schemas.openxmlformats.org/drawingml/2006/main">
             <a:pPr>
+              <a:buNone/>
               <a:defRPr sz="1275" b="0">
                 <a:solidFill>
                   <a:srgbClr val="173F50"/>
@@ -9211,7 +9338,7 @@
                 <a:ea typeface="Arial"/>
                 <a:cs typeface="Arial"/>
               </a:rPr>
-              <a:t>AlphaVault  /  Du zhuotong  /  7 of 12</a:t>
+              <a:t>7 of 12</a:t>
             </a:r>
           </a:p>
         </p:txBody>
@@ -9221,7 +9348,7 @@
           <p:cNvPr id="3" name="">
             <a:extLst xmlns:a="http://schemas.openxmlformats.org/drawingml/2006/main">
               <a:ext uri="{FF2B5EF4-FFF2-40B4-BE49-F238E27FC236}">
-                <a16:creationId xmlns:a16="http://schemas.microsoft.com/office/drawing/2014/main" id="{00765441-7EFD-4E43-B128-572D0C83365C}"/>
+                <a16:creationId xmlns:a16="http://schemas.microsoft.com/office/drawing/2014/main" id="{966F6C19-DDF8-41EF-8FFB-D62C62FC660F}"/>
               </a:ext>
             </a:extLst>
           </p:cNvPr>
@@ -9231,7 +9358,7 @@
           <p:nvPr/>
         </p:nvPicPr>
         <p:blipFill>
-          <a:blip xmlns:r="http://schemas.openxmlformats.org/officeDocument/2006/relationships" xmlns:a="http://schemas.openxmlformats.org/drawingml/2006/main" r:embed="R175dfccffde949ec"/>
+          <a:blip xmlns:r="http://schemas.openxmlformats.org/officeDocument/2006/relationships" xmlns:a="http://schemas.openxmlformats.org/drawingml/2006/main" r:embed="R1f8b70effd3647a2"/>
           <a:stretch xmlns:a="http://schemas.openxmlformats.org/drawingml/2006/main"/>
         </p:blipFill>
         <p:spPr>
@@ -9247,7 +9374,7 @@
     </p:spTree>
     <p:extLst>
       <p:ext uri="{BB962C8B-B14F-4D97-AF65-F5344CB8AC3E}">
-        <p14:creationId xmlns:p14="http://schemas.microsoft.com/office/powerpoint/2010/main" val="1547733013"/>
+        <p14:creationId xmlns:p14="http://schemas.microsoft.com/office/powerpoint/2010/main" val="1096453579"/>
       </p:ext>
     </p:extLst>
   </p:cSld>
@@ -9278,7 +9405,7 @@
           <p:cNvPr id="5" name="">
             <a:extLst xmlns:a="http://schemas.openxmlformats.org/drawingml/2006/main">
               <a:ext uri="{FF2B5EF4-FFF2-40B4-BE49-F238E27FC236}">
-                <a16:creationId xmlns:a16="http://schemas.microsoft.com/office/drawing/2014/main" id="{1F7E19A0-3425-463E-99C7-DE2F49183143}"/>
+                <a16:creationId xmlns:a16="http://schemas.microsoft.com/office/drawing/2014/main" id="{7431D4DF-F8D4-474E-85F9-9531FA19608B}"/>
               </a:ext>
             </a:extLst>
           </p:cNvPr>
@@ -9316,6 +9443,7 @@
           </a:lstStyle>
           <a:p xmlns:a="http://schemas.openxmlformats.org/drawingml/2006/main">
             <a:pPr>
+              <a:buNone/>
               <a:defRPr sz="3150" b="1">
                 <a:solidFill>
                   <a:srgbClr val="173F50"/>
@@ -9344,7 +9472,7 @@
           <p:cNvPr id="2" name="">
             <a:extLst xmlns:a="http://schemas.openxmlformats.org/drawingml/2006/main">
               <a:ext uri="{FF2B5EF4-FFF2-40B4-BE49-F238E27FC236}">
-                <a16:creationId xmlns:a16="http://schemas.microsoft.com/office/drawing/2014/main" id="{8009FFAC-B425-46E0-826C-58119D28B62F}"/>
+                <a16:creationId xmlns:a16="http://schemas.microsoft.com/office/drawing/2014/main" id="{9BD14C7E-2090-4E00-9859-3BF29B4B0692}"/>
               </a:ext>
             </a:extLst>
           </p:cNvPr>
@@ -9382,6 +9510,7 @@
           </a:lstStyle>
           <a:p xmlns:a="http://schemas.openxmlformats.org/drawingml/2006/main">
             <a:pPr>
+              <a:buNone/>
               <a:defRPr sz="1275" b="0">
                 <a:solidFill>
                   <a:srgbClr val="173F50"/>
@@ -9400,7 +9529,7 @@
                 <a:ea typeface="Arial"/>
                 <a:cs typeface="Arial"/>
               </a:rPr>
-              <a:t>AlphaVault  /  Du zhuotong  /  8 of 12</a:t>
+              <a:t>8 of 12</a:t>
             </a:r>
           </a:p>
         </p:txBody>
@@ -9410,7 +9539,7 @@
           <p:cNvPr id="3" name="">
             <a:extLst xmlns:a="http://schemas.openxmlformats.org/drawingml/2006/main">
               <a:ext uri="{FF2B5EF4-FFF2-40B4-BE49-F238E27FC236}">
-                <a16:creationId xmlns:a16="http://schemas.microsoft.com/office/drawing/2014/main" id="{2D6EBD2D-350E-45BB-AA0E-96B3ABB9AC63}"/>
+                <a16:creationId xmlns:a16="http://schemas.microsoft.com/office/drawing/2014/main" id="{3B974791-778B-4DA1-967B-D864CE68605A}"/>
               </a:ext>
             </a:extLst>
           </p:cNvPr>
@@ -9688,7 +9817,7 @@
           <p:cNvPr id="4" name="">
             <a:extLst xmlns:a="http://schemas.openxmlformats.org/drawingml/2006/main">
               <a:ext uri="{FF2B5EF4-FFF2-40B4-BE49-F238E27FC236}">
-                <a16:creationId xmlns:a16="http://schemas.microsoft.com/office/drawing/2014/main" id="{BCF79EAE-F9C7-4E11-B368-447C99428F2E}"/>
+                <a16:creationId xmlns:a16="http://schemas.microsoft.com/office/drawing/2014/main" id="{FC739FA6-7F08-40DD-8D7D-5D1637A8FA33}"/>
               </a:ext>
             </a:extLst>
           </p:cNvPr>
@@ -9726,6 +9855,7 @@
           </a:lstStyle>
           <a:p xmlns:a="http://schemas.openxmlformats.org/drawingml/2006/main">
             <a:pPr>
+              <a:buNone/>
               <a:defRPr sz="2025" b="0">
                 <a:solidFill>
                   <a:srgbClr val="173F50"/>
@@ -9752,7 +9882,7 @@
     </p:spTree>
     <p:extLst>
       <p:ext uri="{BB962C8B-B14F-4D97-AF65-F5344CB8AC3E}">
-        <p14:creationId xmlns:p14="http://schemas.microsoft.com/office/powerpoint/2010/main" val="1303080640"/>
+        <p14:creationId xmlns:p14="http://schemas.microsoft.com/office/powerpoint/2010/main" val="511823044"/>
       </p:ext>
     </p:extLst>
   </p:cSld>
@@ -9783,7 +9913,7 @@
           <p:cNvPr id="8" name="">
             <a:extLst xmlns:a="http://schemas.openxmlformats.org/drawingml/2006/main">
               <a:ext uri="{FF2B5EF4-FFF2-40B4-BE49-F238E27FC236}">
-                <a16:creationId xmlns:a16="http://schemas.microsoft.com/office/drawing/2014/main" id="{0AB3978F-718F-48DE-9822-A7EFB59B882C}"/>
+                <a16:creationId xmlns:a16="http://schemas.microsoft.com/office/drawing/2014/main" id="{D4FCEB2E-177E-43C4-818A-2D4AD2FD4C5A}"/>
               </a:ext>
             </a:extLst>
           </p:cNvPr>
@@ -9821,6 +9951,7 @@
           </a:lstStyle>
           <a:p xmlns:a="http://schemas.openxmlformats.org/drawingml/2006/main">
             <a:pPr>
+              <a:buNone/>
               <a:defRPr sz="3150" b="1">
                 <a:solidFill>
                   <a:srgbClr val="173F50"/>
@@ -9849,7 +9980,7 @@
           <p:cNvPr id="2" name="">
             <a:extLst xmlns:a="http://schemas.openxmlformats.org/drawingml/2006/main">
               <a:ext uri="{FF2B5EF4-FFF2-40B4-BE49-F238E27FC236}">
-                <a16:creationId xmlns:a16="http://schemas.microsoft.com/office/drawing/2014/main" id="{D6A6915B-10B2-4F2F-B3EC-F342DB6F87F3}"/>
+                <a16:creationId xmlns:a16="http://schemas.microsoft.com/office/drawing/2014/main" id="{6E887DE1-D472-4744-AE5D-639A6FF130A8}"/>
               </a:ext>
             </a:extLst>
           </p:cNvPr>
@@ -9887,6 +10018,7 @@
           </a:lstStyle>
           <a:p xmlns:a="http://schemas.openxmlformats.org/drawingml/2006/main">
             <a:pPr>
+              <a:buNone/>
               <a:defRPr sz="1275" b="0">
                 <a:solidFill>
                   <a:srgbClr val="173F50"/>
@@ -9905,7 +10037,7 @@
                 <a:ea typeface="Arial"/>
                 <a:cs typeface="Arial"/>
               </a:rPr>
-              <a:t>AlphaVault  /  Du zhuotong  /  9 of 12</a:t>
+              <a:t>9 of 12</a:t>
             </a:r>
           </a:p>
         </p:txBody>
@@ -9915,7 +10047,7 @@
           <p:cNvPr id="3" name="Chart">
             <a:extLst xmlns:a="http://schemas.openxmlformats.org/drawingml/2006/main">
               <a:ext uri="{FF2B5EF4-FFF2-40B4-BE49-F238E27FC236}">
-                <a16:creationId xmlns:a16="http://schemas.microsoft.com/office/drawing/2014/main" id="{0E4F35ED-482B-438F-8643-98CE7E94DC7F}"/>
+                <a16:creationId xmlns:a16="http://schemas.microsoft.com/office/drawing/2014/main" id="{D4E8E970-921A-4F97-883C-3B2AB6BB81C4}"/>
               </a:ext>
             </a:extLst>
           </p:cNvPr>
@@ -9928,7 +10060,7 @@
         </p:xfrm>
         <a:graphic xmlns:a="http://schemas.openxmlformats.org/drawingml/2006/main">
           <a:graphicData uri="http://schemas.openxmlformats.org/drawingml/2006/chart">
-            <c:chart xmlns:r="http://schemas.openxmlformats.org/officeDocument/2006/relationships" xmlns:c="http://schemas.openxmlformats.org/drawingml/2006/chart" r:id="R6cc0ac5a66294808"/>
+            <c:chart xmlns:r="http://schemas.openxmlformats.org/officeDocument/2006/relationships" xmlns:c="http://schemas.openxmlformats.org/drawingml/2006/chart" r:id="R1e8ca2b5abcd4cf1"/>
           </a:graphicData>
         </a:graphic>
       </p:graphicFrame>
@@ -9937,7 +10069,7 @@
           <p:cNvPr id="4" name="">
             <a:extLst xmlns:a="http://schemas.openxmlformats.org/drawingml/2006/main">
               <a:ext uri="{FF2B5EF4-FFF2-40B4-BE49-F238E27FC236}">
-                <a16:creationId xmlns:a16="http://schemas.microsoft.com/office/drawing/2014/main" id="{CEEF3F1C-5DF8-4C5B-A4E3-7ABC16DE1129}"/>
+                <a16:creationId xmlns:a16="http://schemas.microsoft.com/office/drawing/2014/main" id="{98D300EB-77E3-4268-9D20-33227E4F8356}"/>
               </a:ext>
             </a:extLst>
           </p:cNvPr>
@@ -9975,6 +10107,7 @@
           </a:lstStyle>
           <a:p xmlns:a="http://schemas.openxmlformats.org/drawingml/2006/main">
             <a:pPr>
+              <a:buNone/>
               <a:defRPr sz="2100" b="1">
                 <a:solidFill>
                   <a:srgbClr val="173F50"/>
@@ -10003,7 +10136,7 @@
           <p:cNvPr id="5" name="">
             <a:extLst xmlns:a="http://schemas.openxmlformats.org/drawingml/2006/main">
               <a:ext uri="{FF2B5EF4-FFF2-40B4-BE49-F238E27FC236}">
-                <a16:creationId xmlns:a16="http://schemas.microsoft.com/office/drawing/2014/main" id="{2A48E8B5-D784-4523-8F0C-9EB3303C7782}"/>
+                <a16:creationId xmlns:a16="http://schemas.microsoft.com/office/drawing/2014/main" id="{CB1B8872-1A4C-4389-AFCD-6F937032F9B1}"/>
               </a:ext>
             </a:extLst>
           </p:cNvPr>
@@ -10041,6 +10174,7 @@
           </a:lstStyle>
           <a:p xmlns:a="http://schemas.openxmlformats.org/drawingml/2006/main">
             <a:pPr>
+              <a:buNone/>
               <a:defRPr sz="2025" b="0">
                 <a:solidFill>
                   <a:srgbClr val="173F50"/>
@@ -10064,6 +10198,7 @@
           </a:p>
           <a:p xmlns:a="http://schemas.openxmlformats.org/drawingml/2006/main">
             <a:pPr>
+              <a:buNone/>
               <a:defRPr sz="2025" b="0">
                 <a:solidFill>
                   <a:srgbClr val="173F50"/>
@@ -10087,6 +10222,7 @@
           </a:p>
           <a:p xmlns:a="http://schemas.openxmlformats.org/drawingml/2006/main">
             <a:pPr>
+              <a:buNone/>
               <a:defRPr sz="2025" b="0">
                 <a:solidFill>
                   <a:srgbClr val="173F50"/>
@@ -10115,7 +10251,7 @@
           <p:cNvPr id="6" name="">
             <a:extLst xmlns:a="http://schemas.openxmlformats.org/drawingml/2006/main">
               <a:ext uri="{FF2B5EF4-FFF2-40B4-BE49-F238E27FC236}">
-                <a16:creationId xmlns:a16="http://schemas.microsoft.com/office/drawing/2014/main" id="{8AC8DF61-AFF6-45E3-80EA-8E7D97B45855}"/>
+                <a16:creationId xmlns:a16="http://schemas.microsoft.com/office/drawing/2014/main" id="{83D43ECC-FC09-471A-AC8C-15DD64821542}"/>
               </a:ext>
             </a:extLst>
           </p:cNvPr>
@@ -10153,6 +10289,7 @@
           </a:lstStyle>
           <a:p xmlns:a="http://schemas.openxmlformats.org/drawingml/2006/main">
             <a:pPr>
+              <a:buNone/>
               <a:defRPr sz="1875" b="0">
                 <a:solidFill>
                   <a:srgbClr val="173F50"/>
@@ -10176,6 +10313,7 @@
           </a:p>
           <a:p xmlns:a="http://schemas.openxmlformats.org/drawingml/2006/main">
             <a:pPr>
+              <a:buNone/>
               <a:defRPr sz="1875" b="0">
                 <a:solidFill>
                   <a:srgbClr val="173F50"/>
@@ -10204,7 +10342,7 @@
           <p:cNvPr id="7" name="">
             <a:extLst xmlns:a="http://schemas.openxmlformats.org/drawingml/2006/main">
               <a:ext uri="{FF2B5EF4-FFF2-40B4-BE49-F238E27FC236}">
-                <a16:creationId xmlns:a16="http://schemas.microsoft.com/office/drawing/2014/main" id="{AA5A2DF1-B71D-479A-A07F-DB683B5D0E74}"/>
+                <a16:creationId xmlns:a16="http://schemas.microsoft.com/office/drawing/2014/main" id="{7EA1EB5A-9CE5-44EF-8E71-71DEC507CBFA}"/>
               </a:ext>
             </a:extLst>
           </p:cNvPr>
@@ -10242,6 +10380,7 @@
           </a:lstStyle>
           <a:p xmlns:a="http://schemas.openxmlformats.org/drawingml/2006/main">
             <a:pPr>
+              <a:buNone/>
               <a:defRPr sz="1875" b="0">
                 <a:solidFill>
                   <a:srgbClr val="173F50"/>
@@ -10268,7 +10407,7 @@
     </p:spTree>
     <p:extLst>
       <p:ext uri="{BB962C8B-B14F-4D97-AF65-F5344CB8AC3E}">
-        <p14:creationId xmlns:p14="http://schemas.microsoft.com/office/powerpoint/2010/main" val="1906100928"/>
+        <p14:creationId xmlns:p14="http://schemas.microsoft.com/office/powerpoint/2010/main" val="653509106"/>
       </p:ext>
     </p:extLst>
   </p:cSld>
@@ -10276,9 +10415,9 @@
 </file>
 
 <file path=ppt/theme/theme1.xml><?xml version="1.0" encoding="utf-8"?>
-<a:theme xmlns:a="http://schemas.openxmlformats.org/drawingml/2006/main" name="ChatGPT">
+<a:theme xmlns:a="http://schemas.openxmlformats.org/drawingml/2006/main" name="AlphaVault">
   <a:themeElements>
-    <a:clrScheme name="ChatGPT">
+    <a:clrScheme name="AlphaVault">
       <a:dk1>
         <a:srgbClr val="000000"/>
       </a:dk1>
@@ -10328,7 +10467,7 @@
         <a:cs typeface=""/>
       </a:minorFont>
     </a:fontScheme>
-    <a:fmtScheme name="ChatGPT">
+    <a:fmtScheme name="AlphaVault">
       <a:fillStyleLst>
         <a:solidFill>
           <a:schemeClr val="phClr"/>

</xml_diff>